<commit_message>
Updated the slides and the UI
</commit_message>
<xml_diff>
--- a/Imran_NoF_26.pptx
+++ b/Imran_NoF_26.pptx
@@ -5,7 +5,7 @@
     <p:sldMasterId id="2147483648" r:id="rId1"/>
   </p:sldMasterIdLst>
   <p:notesMasterIdLst>
-    <p:notesMasterId r:id="rId16"/>
+    <p:notesMasterId r:id="rId20"/>
   </p:notesMasterIdLst>
   <p:sldIdLst>
     <p:sldId id="514" r:id="rId2"/>
@@ -22,6 +22,10 @@
     <p:sldId id="555" r:id="rId13"/>
     <p:sldId id="556" r:id="rId14"/>
     <p:sldId id="543" r:id="rId15"/>
+    <p:sldId id="557" r:id="rId16"/>
+    <p:sldId id="558" r:id="rId17"/>
+    <p:sldId id="560" r:id="rId18"/>
+    <p:sldId id="561" r:id="rId19"/>
   </p:sldIdLst>
   <p:sldSz cx="12192000" cy="6858000"/>
   <p:notesSz cx="6858000" cy="9144000"/>
@@ -354,7 +358,7 @@
           <a:p>
             <a:fld id="{A85B8F7D-9DF9-4D5C-A5C0-CD9BE235298F}" type="datetimeFigureOut">
               <a:rPr lang="en-US" smtClean="0"/>
-              <a:t>9/4/2026</a:t>
+              <a:t>9/14/2026</a:t>
             </a:fld>
             <a:endParaRPr lang="en-US"/>
           </a:p>
@@ -1161,6 +1165,438 @@
 </p:notes>
 </file>
 
+<file path=ppt/notesSlides/notesSlide14.xml><?xml version="1.0" encoding="utf-8"?>
+<p:notes xmlns:a="http://schemas.openxmlformats.org/drawingml/2006/main" xmlns:r="http://schemas.openxmlformats.org/officeDocument/2006/relationships" xmlns:p="http://schemas.openxmlformats.org/presentationml/2006/main">
+  <p:cSld>
+    <p:spTree>
+      <p:nvGrpSpPr>
+        <p:cNvPr id="1" name="">
+          <a:extLst>
+            <a:ext uri="{FF2B5EF4-FFF2-40B4-BE49-F238E27FC236}">
+              <a16:creationId xmlns:a16="http://schemas.microsoft.com/office/drawing/2014/main" id="{D919A723-5008-8151-0CCB-18ACA6A615F7}"/>
+            </a:ext>
+          </a:extLst>
+        </p:cNvPr>
+        <p:cNvGrpSpPr/>
+        <p:nvPr/>
+      </p:nvGrpSpPr>
+      <p:grpSpPr>
+        <a:xfrm>
+          <a:off x="0" y="0"/>
+          <a:ext cx="0" cy="0"/>
+          <a:chOff x="0" y="0"/>
+          <a:chExt cx="0" cy="0"/>
+        </a:xfrm>
+      </p:grpSpPr>
+      <p:sp>
+        <p:nvSpPr>
+          <p:cNvPr id="2" name="Slide Image Placeholder 1">
+            <a:extLst>
+              <a:ext uri="{FF2B5EF4-FFF2-40B4-BE49-F238E27FC236}">
+                <a16:creationId xmlns:a16="http://schemas.microsoft.com/office/drawing/2014/main" id="{21C97FA2-2545-5B32-E5CB-59F5B8412C7C}"/>
+              </a:ext>
+            </a:extLst>
+          </p:cNvPr>
+          <p:cNvSpPr>
+            <a:spLocks noGrp="1" noRot="1" noChangeAspect="1"/>
+          </p:cNvSpPr>
+          <p:nvPr>
+            <p:ph type="sldImg"/>
+          </p:nvPr>
+        </p:nvSpPr>
+        <p:spPr/>
+      </p:sp>
+      <p:sp>
+        <p:nvSpPr>
+          <p:cNvPr id="3" name="Notes Placeholder 2">
+            <a:extLst>
+              <a:ext uri="{FF2B5EF4-FFF2-40B4-BE49-F238E27FC236}">
+                <a16:creationId xmlns:a16="http://schemas.microsoft.com/office/drawing/2014/main" id="{61DFEC12-593A-A1BA-0CF3-A148438DD8AD}"/>
+              </a:ext>
+            </a:extLst>
+          </p:cNvPr>
+          <p:cNvSpPr>
+            <a:spLocks noGrp="1"/>
+          </p:cNvSpPr>
+          <p:nvPr>
+            <p:ph type="body" idx="1"/>
+          </p:nvPr>
+        </p:nvSpPr>
+        <p:spPr/>
+        <p:txBody>
+          <a:bodyPr/>
+          <a:lstStyle/>
+          <a:p>
+            <a:endParaRPr lang="en-US"/>
+          </a:p>
+        </p:txBody>
+      </p:sp>
+      <p:sp>
+        <p:nvSpPr>
+          <p:cNvPr id="4" name="Slide Number Placeholder 3">
+            <a:extLst>
+              <a:ext uri="{FF2B5EF4-FFF2-40B4-BE49-F238E27FC236}">
+                <a16:creationId xmlns:a16="http://schemas.microsoft.com/office/drawing/2014/main" id="{F365D229-C6C9-AB37-479A-1779A9E897F3}"/>
+              </a:ext>
+            </a:extLst>
+          </p:cNvPr>
+          <p:cNvSpPr>
+            <a:spLocks noGrp="1"/>
+          </p:cNvSpPr>
+          <p:nvPr>
+            <p:ph type="sldNum" sz="quarter" idx="5"/>
+          </p:nvPr>
+        </p:nvSpPr>
+        <p:spPr/>
+        <p:txBody>
+          <a:bodyPr/>
+          <a:lstStyle/>
+          <a:p>
+            <a:fld id="{14DFF4C2-74DA-1D46-B541-49BD0013B7E1}" type="slidenum">
+              <a:rPr lang="en-DE" smtClean="0"/>
+              <a:t>15</a:t>
+            </a:fld>
+            <a:endParaRPr lang="en-DE"/>
+          </a:p>
+        </p:txBody>
+      </p:sp>
+    </p:spTree>
+    <p:extLst>
+      <p:ext uri="{BB962C8B-B14F-4D97-AF65-F5344CB8AC3E}">
+        <p14:creationId xmlns:p14="http://schemas.microsoft.com/office/powerpoint/2010/main" val="2049349185"/>
+      </p:ext>
+    </p:extLst>
+  </p:cSld>
+  <p:clrMapOvr>
+    <a:masterClrMapping/>
+  </p:clrMapOvr>
+</p:notes>
+</file>
+
+<file path=ppt/notesSlides/notesSlide15.xml><?xml version="1.0" encoding="utf-8"?>
+<p:notes xmlns:a="http://schemas.openxmlformats.org/drawingml/2006/main" xmlns:r="http://schemas.openxmlformats.org/officeDocument/2006/relationships" xmlns:p="http://schemas.openxmlformats.org/presentationml/2006/main">
+  <p:cSld>
+    <p:spTree>
+      <p:nvGrpSpPr>
+        <p:cNvPr id="1" name="">
+          <a:extLst>
+            <a:ext uri="{FF2B5EF4-FFF2-40B4-BE49-F238E27FC236}">
+              <a16:creationId xmlns:a16="http://schemas.microsoft.com/office/drawing/2014/main" id="{978A0C91-209A-A28D-403F-5C0334E3AE64}"/>
+            </a:ext>
+          </a:extLst>
+        </p:cNvPr>
+        <p:cNvGrpSpPr/>
+        <p:nvPr/>
+      </p:nvGrpSpPr>
+      <p:grpSpPr>
+        <a:xfrm>
+          <a:off x="0" y="0"/>
+          <a:ext cx="0" cy="0"/>
+          <a:chOff x="0" y="0"/>
+          <a:chExt cx="0" cy="0"/>
+        </a:xfrm>
+      </p:grpSpPr>
+      <p:sp>
+        <p:nvSpPr>
+          <p:cNvPr id="2" name="Slide Image Placeholder 1">
+            <a:extLst>
+              <a:ext uri="{FF2B5EF4-FFF2-40B4-BE49-F238E27FC236}">
+                <a16:creationId xmlns:a16="http://schemas.microsoft.com/office/drawing/2014/main" id="{B1433EB0-E0CC-BA09-A615-A896CB6490FC}"/>
+              </a:ext>
+            </a:extLst>
+          </p:cNvPr>
+          <p:cNvSpPr>
+            <a:spLocks noGrp="1" noRot="1" noChangeAspect="1"/>
+          </p:cNvSpPr>
+          <p:nvPr>
+            <p:ph type="sldImg"/>
+          </p:nvPr>
+        </p:nvSpPr>
+        <p:spPr/>
+      </p:sp>
+      <p:sp>
+        <p:nvSpPr>
+          <p:cNvPr id="3" name="Notes Placeholder 2">
+            <a:extLst>
+              <a:ext uri="{FF2B5EF4-FFF2-40B4-BE49-F238E27FC236}">
+                <a16:creationId xmlns:a16="http://schemas.microsoft.com/office/drawing/2014/main" id="{BD02A39D-79A5-04CA-A3A7-7643D7035D64}"/>
+              </a:ext>
+            </a:extLst>
+          </p:cNvPr>
+          <p:cNvSpPr>
+            <a:spLocks noGrp="1"/>
+          </p:cNvSpPr>
+          <p:nvPr>
+            <p:ph type="body" idx="1"/>
+          </p:nvPr>
+        </p:nvSpPr>
+        <p:spPr/>
+        <p:txBody>
+          <a:bodyPr/>
+          <a:lstStyle/>
+          <a:p>
+            <a:endParaRPr lang="en-US"/>
+          </a:p>
+        </p:txBody>
+      </p:sp>
+      <p:sp>
+        <p:nvSpPr>
+          <p:cNvPr id="4" name="Slide Number Placeholder 3">
+            <a:extLst>
+              <a:ext uri="{FF2B5EF4-FFF2-40B4-BE49-F238E27FC236}">
+                <a16:creationId xmlns:a16="http://schemas.microsoft.com/office/drawing/2014/main" id="{78B80394-0CDA-071E-9CE2-6C82D35845DD}"/>
+              </a:ext>
+            </a:extLst>
+          </p:cNvPr>
+          <p:cNvSpPr>
+            <a:spLocks noGrp="1"/>
+          </p:cNvSpPr>
+          <p:nvPr>
+            <p:ph type="sldNum" sz="quarter" idx="5"/>
+          </p:nvPr>
+        </p:nvSpPr>
+        <p:spPr/>
+        <p:txBody>
+          <a:bodyPr/>
+          <a:lstStyle/>
+          <a:p>
+            <a:fld id="{14DFF4C2-74DA-1D46-B541-49BD0013B7E1}" type="slidenum">
+              <a:rPr lang="en-DE" smtClean="0"/>
+              <a:t>16</a:t>
+            </a:fld>
+            <a:endParaRPr lang="en-DE"/>
+          </a:p>
+        </p:txBody>
+      </p:sp>
+    </p:spTree>
+    <p:extLst>
+      <p:ext uri="{BB962C8B-B14F-4D97-AF65-F5344CB8AC3E}">
+        <p14:creationId xmlns:p14="http://schemas.microsoft.com/office/powerpoint/2010/main" val="3016857559"/>
+      </p:ext>
+    </p:extLst>
+  </p:cSld>
+  <p:clrMapOvr>
+    <a:masterClrMapping/>
+  </p:clrMapOvr>
+</p:notes>
+</file>
+
+<file path=ppt/notesSlides/notesSlide16.xml><?xml version="1.0" encoding="utf-8"?>
+<p:notes xmlns:a="http://schemas.openxmlformats.org/drawingml/2006/main" xmlns:r="http://schemas.openxmlformats.org/officeDocument/2006/relationships" xmlns:p="http://schemas.openxmlformats.org/presentationml/2006/main">
+  <p:cSld>
+    <p:spTree>
+      <p:nvGrpSpPr>
+        <p:cNvPr id="1" name="">
+          <a:extLst>
+            <a:ext uri="{FF2B5EF4-FFF2-40B4-BE49-F238E27FC236}">
+              <a16:creationId xmlns:a16="http://schemas.microsoft.com/office/drawing/2014/main" id="{032FFEFC-7A42-E56F-F069-C948431F0683}"/>
+            </a:ext>
+          </a:extLst>
+        </p:cNvPr>
+        <p:cNvGrpSpPr/>
+        <p:nvPr/>
+      </p:nvGrpSpPr>
+      <p:grpSpPr>
+        <a:xfrm>
+          <a:off x="0" y="0"/>
+          <a:ext cx="0" cy="0"/>
+          <a:chOff x="0" y="0"/>
+          <a:chExt cx="0" cy="0"/>
+        </a:xfrm>
+      </p:grpSpPr>
+      <p:sp>
+        <p:nvSpPr>
+          <p:cNvPr id="2" name="Slide Image Placeholder 1">
+            <a:extLst>
+              <a:ext uri="{FF2B5EF4-FFF2-40B4-BE49-F238E27FC236}">
+                <a16:creationId xmlns:a16="http://schemas.microsoft.com/office/drawing/2014/main" id="{53FE44D6-3756-FB46-514E-A4E4496942AA}"/>
+              </a:ext>
+            </a:extLst>
+          </p:cNvPr>
+          <p:cNvSpPr>
+            <a:spLocks noGrp="1" noRot="1" noChangeAspect="1"/>
+          </p:cNvSpPr>
+          <p:nvPr>
+            <p:ph type="sldImg"/>
+          </p:nvPr>
+        </p:nvSpPr>
+        <p:spPr/>
+      </p:sp>
+      <p:sp>
+        <p:nvSpPr>
+          <p:cNvPr id="3" name="Notes Placeholder 2">
+            <a:extLst>
+              <a:ext uri="{FF2B5EF4-FFF2-40B4-BE49-F238E27FC236}">
+                <a16:creationId xmlns:a16="http://schemas.microsoft.com/office/drawing/2014/main" id="{6217C001-483A-329E-1760-AB5B703EE25A}"/>
+              </a:ext>
+            </a:extLst>
+          </p:cNvPr>
+          <p:cNvSpPr>
+            <a:spLocks noGrp="1"/>
+          </p:cNvSpPr>
+          <p:nvPr>
+            <p:ph type="body" idx="1"/>
+          </p:nvPr>
+        </p:nvSpPr>
+        <p:spPr/>
+        <p:txBody>
+          <a:bodyPr/>
+          <a:lstStyle/>
+          <a:p>
+            <a:endParaRPr lang="en-US"/>
+          </a:p>
+        </p:txBody>
+      </p:sp>
+      <p:sp>
+        <p:nvSpPr>
+          <p:cNvPr id="4" name="Slide Number Placeholder 3">
+            <a:extLst>
+              <a:ext uri="{FF2B5EF4-FFF2-40B4-BE49-F238E27FC236}">
+                <a16:creationId xmlns:a16="http://schemas.microsoft.com/office/drawing/2014/main" id="{E8614E09-B076-D4AD-AE39-F8F30EFF8B78}"/>
+              </a:ext>
+            </a:extLst>
+          </p:cNvPr>
+          <p:cNvSpPr>
+            <a:spLocks noGrp="1"/>
+          </p:cNvSpPr>
+          <p:nvPr>
+            <p:ph type="sldNum" sz="quarter" idx="5"/>
+          </p:nvPr>
+        </p:nvSpPr>
+        <p:spPr/>
+        <p:txBody>
+          <a:bodyPr/>
+          <a:lstStyle/>
+          <a:p>
+            <a:fld id="{14DFF4C2-74DA-1D46-B541-49BD0013B7E1}" type="slidenum">
+              <a:rPr lang="en-DE" smtClean="0"/>
+              <a:t>17</a:t>
+            </a:fld>
+            <a:endParaRPr lang="en-DE"/>
+          </a:p>
+        </p:txBody>
+      </p:sp>
+    </p:spTree>
+    <p:extLst>
+      <p:ext uri="{BB962C8B-B14F-4D97-AF65-F5344CB8AC3E}">
+        <p14:creationId xmlns:p14="http://schemas.microsoft.com/office/powerpoint/2010/main" val="2945984557"/>
+      </p:ext>
+    </p:extLst>
+  </p:cSld>
+  <p:clrMapOvr>
+    <a:masterClrMapping/>
+  </p:clrMapOvr>
+</p:notes>
+</file>
+
+<file path=ppt/notesSlides/notesSlide17.xml><?xml version="1.0" encoding="utf-8"?>
+<p:notes xmlns:a="http://schemas.openxmlformats.org/drawingml/2006/main" xmlns:r="http://schemas.openxmlformats.org/officeDocument/2006/relationships" xmlns:p="http://schemas.openxmlformats.org/presentationml/2006/main">
+  <p:cSld>
+    <p:spTree>
+      <p:nvGrpSpPr>
+        <p:cNvPr id="1" name="">
+          <a:extLst>
+            <a:ext uri="{FF2B5EF4-FFF2-40B4-BE49-F238E27FC236}">
+              <a16:creationId xmlns:a16="http://schemas.microsoft.com/office/drawing/2014/main" id="{506FEC5F-BFDB-6639-A982-0176C84071D6}"/>
+            </a:ext>
+          </a:extLst>
+        </p:cNvPr>
+        <p:cNvGrpSpPr/>
+        <p:nvPr/>
+      </p:nvGrpSpPr>
+      <p:grpSpPr>
+        <a:xfrm>
+          <a:off x="0" y="0"/>
+          <a:ext cx="0" cy="0"/>
+          <a:chOff x="0" y="0"/>
+          <a:chExt cx="0" cy="0"/>
+        </a:xfrm>
+      </p:grpSpPr>
+      <p:sp>
+        <p:nvSpPr>
+          <p:cNvPr id="2" name="Slide Image Placeholder 1">
+            <a:extLst>
+              <a:ext uri="{FF2B5EF4-FFF2-40B4-BE49-F238E27FC236}">
+                <a16:creationId xmlns:a16="http://schemas.microsoft.com/office/drawing/2014/main" id="{DD8D446C-FAED-8A91-8E29-C4F046C92285}"/>
+              </a:ext>
+            </a:extLst>
+          </p:cNvPr>
+          <p:cNvSpPr>
+            <a:spLocks noGrp="1" noRot="1" noChangeAspect="1"/>
+          </p:cNvSpPr>
+          <p:nvPr>
+            <p:ph type="sldImg"/>
+          </p:nvPr>
+        </p:nvSpPr>
+        <p:spPr/>
+      </p:sp>
+      <p:sp>
+        <p:nvSpPr>
+          <p:cNvPr id="3" name="Notes Placeholder 2">
+            <a:extLst>
+              <a:ext uri="{FF2B5EF4-FFF2-40B4-BE49-F238E27FC236}">
+                <a16:creationId xmlns:a16="http://schemas.microsoft.com/office/drawing/2014/main" id="{1CB49C38-7F43-215F-7346-4A775563D69B}"/>
+              </a:ext>
+            </a:extLst>
+          </p:cNvPr>
+          <p:cNvSpPr>
+            <a:spLocks noGrp="1"/>
+          </p:cNvSpPr>
+          <p:nvPr>
+            <p:ph type="body" idx="1"/>
+          </p:nvPr>
+        </p:nvSpPr>
+        <p:spPr/>
+        <p:txBody>
+          <a:bodyPr/>
+          <a:lstStyle/>
+          <a:p>
+            <a:endParaRPr lang="en-US"/>
+          </a:p>
+        </p:txBody>
+      </p:sp>
+      <p:sp>
+        <p:nvSpPr>
+          <p:cNvPr id="4" name="Slide Number Placeholder 3">
+            <a:extLst>
+              <a:ext uri="{FF2B5EF4-FFF2-40B4-BE49-F238E27FC236}">
+                <a16:creationId xmlns:a16="http://schemas.microsoft.com/office/drawing/2014/main" id="{83683CD9-6BF0-1576-EFAA-1804FDA7C508}"/>
+              </a:ext>
+            </a:extLst>
+          </p:cNvPr>
+          <p:cNvSpPr>
+            <a:spLocks noGrp="1"/>
+          </p:cNvSpPr>
+          <p:nvPr>
+            <p:ph type="sldNum" sz="quarter" idx="5"/>
+          </p:nvPr>
+        </p:nvSpPr>
+        <p:spPr/>
+        <p:txBody>
+          <a:bodyPr/>
+          <a:lstStyle/>
+          <a:p>
+            <a:fld id="{14DFF4C2-74DA-1D46-B541-49BD0013B7E1}" type="slidenum">
+              <a:rPr lang="en-DE" smtClean="0"/>
+              <a:t>18</a:t>
+            </a:fld>
+            <a:endParaRPr lang="en-DE"/>
+          </a:p>
+        </p:txBody>
+      </p:sp>
+    </p:spTree>
+    <p:extLst>
+      <p:ext uri="{BB962C8B-B14F-4D97-AF65-F5344CB8AC3E}">
+        <p14:creationId xmlns:p14="http://schemas.microsoft.com/office/powerpoint/2010/main" val="824163311"/>
+      </p:ext>
+    </p:extLst>
+  </p:cSld>
+  <p:clrMapOvr>
+    <a:masterClrMapping/>
+  </p:clrMapOvr>
+</p:notes>
+</file>
+
 <file path=ppt/notesSlides/notesSlide2.xml><?xml version="1.0" encoding="utf-8"?>
 <p:notes xmlns:a="http://schemas.openxmlformats.org/drawingml/2006/main" xmlns:r="http://schemas.openxmlformats.org/officeDocument/2006/relationships" xmlns:p="http://schemas.openxmlformats.org/presentationml/2006/main">
   <p:cSld>
@@ -2172,7 +2608,7 @@
           <a:p>
             <a:fld id="{6473CF59-A18C-4D57-9490-8821DC8785C9}" type="datetimeFigureOut">
               <a:rPr lang="en-US" smtClean="0"/>
-              <a:t>9/4/2026</a:t>
+              <a:t>9/14/2026</a:t>
             </a:fld>
             <a:endParaRPr lang="en-US"/>
           </a:p>
@@ -2370,7 +2806,7 @@
           <a:p>
             <a:fld id="{6473CF59-A18C-4D57-9490-8821DC8785C9}" type="datetimeFigureOut">
               <a:rPr lang="en-US" smtClean="0"/>
-              <a:t>9/4/2026</a:t>
+              <a:t>9/14/2026</a:t>
             </a:fld>
             <a:endParaRPr lang="en-US"/>
           </a:p>
@@ -2578,7 +3014,7 @@
           <a:p>
             <a:fld id="{6473CF59-A18C-4D57-9490-8821DC8785C9}" type="datetimeFigureOut">
               <a:rPr lang="en-US" smtClean="0"/>
-              <a:t>9/4/2026</a:t>
+              <a:t>9/14/2026</a:t>
             </a:fld>
             <a:endParaRPr lang="en-US"/>
           </a:p>
@@ -3600,7 +4036,7 @@
           <a:p>
             <a:fld id="{6473CF59-A18C-4D57-9490-8821DC8785C9}" type="datetimeFigureOut">
               <a:rPr lang="en-US" smtClean="0"/>
-              <a:t>9/4/2026</a:t>
+              <a:t>9/14/2026</a:t>
             </a:fld>
             <a:endParaRPr lang="en-US"/>
           </a:p>
@@ -3875,7 +4311,7 @@
           <a:p>
             <a:fld id="{6473CF59-A18C-4D57-9490-8821DC8785C9}" type="datetimeFigureOut">
               <a:rPr lang="en-US" smtClean="0"/>
-              <a:t>9/4/2026</a:t>
+              <a:t>9/14/2026</a:t>
             </a:fld>
             <a:endParaRPr lang="en-US"/>
           </a:p>
@@ -4140,7 +4576,7 @@
           <a:p>
             <a:fld id="{6473CF59-A18C-4D57-9490-8821DC8785C9}" type="datetimeFigureOut">
               <a:rPr lang="en-US" smtClean="0"/>
-              <a:t>9/4/2026</a:t>
+              <a:t>9/14/2026</a:t>
             </a:fld>
             <a:endParaRPr lang="en-US"/>
           </a:p>
@@ -4552,7 +4988,7 @@
           <a:p>
             <a:fld id="{6473CF59-A18C-4D57-9490-8821DC8785C9}" type="datetimeFigureOut">
               <a:rPr lang="en-US" smtClean="0"/>
-              <a:t>9/4/2026</a:t>
+              <a:t>9/14/2026</a:t>
             </a:fld>
             <a:endParaRPr lang="en-US"/>
           </a:p>
@@ -4693,7 +5129,7 @@
           <a:p>
             <a:fld id="{6473CF59-A18C-4D57-9490-8821DC8785C9}" type="datetimeFigureOut">
               <a:rPr lang="en-US" smtClean="0"/>
-              <a:t>9/4/2026</a:t>
+              <a:t>9/14/2026</a:t>
             </a:fld>
             <a:endParaRPr lang="en-US"/>
           </a:p>
@@ -4806,7 +5242,7 @@
           <a:p>
             <a:fld id="{6473CF59-A18C-4D57-9490-8821DC8785C9}" type="datetimeFigureOut">
               <a:rPr lang="en-US" smtClean="0"/>
-              <a:t>9/4/2026</a:t>
+              <a:t>9/14/2026</a:t>
             </a:fld>
             <a:endParaRPr lang="en-US"/>
           </a:p>
@@ -5117,7 +5553,7 @@
           <a:p>
             <a:fld id="{6473CF59-A18C-4D57-9490-8821DC8785C9}" type="datetimeFigureOut">
               <a:rPr lang="en-US" smtClean="0"/>
-              <a:t>9/4/2026</a:t>
+              <a:t>9/14/2026</a:t>
             </a:fld>
             <a:endParaRPr lang="en-US"/>
           </a:p>
@@ -5405,7 +5841,7 @@
           <a:p>
             <a:fld id="{6473CF59-A18C-4D57-9490-8821DC8785C9}" type="datetimeFigureOut">
               <a:rPr lang="en-US" smtClean="0"/>
-              <a:t>9/4/2026</a:t>
+              <a:t>9/14/2026</a:t>
             </a:fld>
             <a:endParaRPr lang="en-US"/>
           </a:p>
@@ -5646,7 +6082,7 @@
           <a:p>
             <a:fld id="{6473CF59-A18C-4D57-9490-8821DC8785C9}" type="datetimeFigureOut">
               <a:rPr lang="en-US" smtClean="0"/>
-              <a:t>9/4/2026</a:t>
+              <a:t>9/14/2026</a:t>
             </a:fld>
             <a:endParaRPr lang="en-US"/>
           </a:p>
@@ -8234,6 +8670,1198 @@
     <p:extLst>
       <p:ext uri="{BB962C8B-B14F-4D97-AF65-F5344CB8AC3E}">
         <p14:creationId xmlns:p14="http://schemas.microsoft.com/office/powerpoint/2010/main" val="2272969208"/>
+      </p:ext>
+    </p:extLst>
+  </p:cSld>
+  <p:clrMapOvr>
+    <a:masterClrMapping/>
+  </p:clrMapOvr>
+</p:sld>
+</file>
+
+<file path=ppt/slides/slide15.xml><?xml version="1.0" encoding="utf-8"?>
+<p:sld xmlns:a="http://schemas.openxmlformats.org/drawingml/2006/main" xmlns:r="http://schemas.openxmlformats.org/officeDocument/2006/relationships" xmlns:p="http://schemas.openxmlformats.org/presentationml/2006/main">
+  <p:cSld>
+    <p:spTree>
+      <p:nvGrpSpPr>
+        <p:cNvPr id="1" name="">
+          <a:extLst>
+            <a:ext uri="{FF2B5EF4-FFF2-40B4-BE49-F238E27FC236}">
+              <a16:creationId xmlns:a16="http://schemas.microsoft.com/office/drawing/2014/main" id="{9DF90A9C-2556-2A0D-DD20-7CFDA596CB64}"/>
+            </a:ext>
+          </a:extLst>
+        </p:cNvPr>
+        <p:cNvGrpSpPr/>
+        <p:nvPr/>
+      </p:nvGrpSpPr>
+      <p:grpSpPr>
+        <a:xfrm>
+          <a:off x="0" y="0"/>
+          <a:ext cx="0" cy="0"/>
+          <a:chOff x="0" y="0"/>
+          <a:chExt cx="0" cy="0"/>
+        </a:xfrm>
+      </p:grpSpPr>
+      <p:sp>
+        <p:nvSpPr>
+          <p:cNvPr id="2" name="Title 1">
+            <a:extLst>
+              <a:ext uri="{FF2B5EF4-FFF2-40B4-BE49-F238E27FC236}">
+                <a16:creationId xmlns:a16="http://schemas.microsoft.com/office/drawing/2014/main" id="{4FDAE62F-E29A-3D9D-44F4-222EC7D96A63}"/>
+              </a:ext>
+            </a:extLst>
+          </p:cNvPr>
+          <p:cNvSpPr>
+            <a:spLocks noGrp="1"/>
+          </p:cNvSpPr>
+          <p:nvPr>
+            <p:ph type="title"/>
+          </p:nvPr>
+        </p:nvSpPr>
+        <p:spPr>
+          <a:xfrm>
+            <a:off x="305555" y="0"/>
+            <a:ext cx="11885653" cy="838800"/>
+          </a:xfrm>
+        </p:spPr>
+        <p:txBody>
+          <a:bodyPr anchor="ctr">
+            <a:normAutofit/>
+          </a:bodyPr>
+          <a:lstStyle/>
+          <a:p>
+            <a:r>
+              <a:rPr lang="en-IN" dirty="0"/>
+              <a:t>Changelog 18</a:t>
+            </a:r>
+            <a:r>
+              <a:rPr lang="en-IN" baseline="30000" dirty="0"/>
+              <a:t>th</a:t>
+            </a:r>
+            <a:r>
+              <a:rPr lang="en-IN" dirty="0"/>
+              <a:t> September 2027</a:t>
+            </a:r>
+          </a:p>
+        </p:txBody>
+      </p:sp>
+      <p:sp>
+        <p:nvSpPr>
+          <p:cNvPr id="3" name="Content Placeholder 2">
+            <a:extLst>
+              <a:ext uri="{FF2B5EF4-FFF2-40B4-BE49-F238E27FC236}">
+                <a16:creationId xmlns:a16="http://schemas.microsoft.com/office/drawing/2014/main" id="{FF533231-C460-625D-3644-431F41443633}"/>
+              </a:ext>
+            </a:extLst>
+          </p:cNvPr>
+          <p:cNvSpPr>
+            <a:spLocks noGrp="1"/>
+          </p:cNvSpPr>
+          <p:nvPr>
+            <p:ph sz="quarter" idx="10"/>
+          </p:nvPr>
+        </p:nvSpPr>
+        <p:spPr>
+          <a:xfrm>
+            <a:off x="387580" y="752388"/>
+            <a:ext cx="11426771" cy="4813793"/>
+          </a:xfrm>
+        </p:spPr>
+        <p:txBody>
+          <a:bodyPr>
+            <a:normAutofit/>
+          </a:bodyPr>
+          <a:lstStyle/>
+          <a:p>
+            <a:pPr marL="457200" lvl="1" indent="0">
+              <a:buNone/>
+            </a:pPr>
+            <a:endParaRPr lang="en-US" sz="1100" dirty="0"/>
+          </a:p>
+          <a:p>
+            <a:pPr marL="800100" lvl="1" indent="-342900"/>
+            <a:endParaRPr lang="en-US" sz="1100" i="1" dirty="0"/>
+          </a:p>
+          <a:p>
+            <a:pPr>
+              <a:buFont typeface="Arial" panose="020B0604020202020204" pitchFamily="34" charset="0"/>
+              <a:buChar char="•"/>
+            </a:pPr>
+            <a:r>
+              <a:rPr lang="en-GB" sz="2400" b="1" dirty="0"/>
+              <a:t>Agentic Capabilities:</a:t>
+            </a:r>
+          </a:p>
+          <a:p>
+            <a:pPr>
+              <a:buFont typeface="Arial" panose="020B0604020202020204" pitchFamily="34" charset="0"/>
+              <a:buChar char="•"/>
+            </a:pPr>
+            <a:r>
+              <a:rPr lang="en-GB" sz="2400" b="1" dirty="0"/>
+              <a:t>Autonomous Tool Selection</a:t>
+            </a:r>
+          </a:p>
+          <a:p>
+            <a:pPr>
+              <a:buFont typeface="Arial" panose="020B0604020202020204" pitchFamily="34" charset="0"/>
+              <a:buChar char="•"/>
+            </a:pPr>
+            <a:r>
+              <a:rPr lang="en-GB" sz="2400" b="1" dirty="0"/>
+              <a:t>Context aware follow up reasoning</a:t>
+            </a:r>
+          </a:p>
+          <a:p>
+            <a:pPr>
+              <a:buFont typeface="Arial" panose="020B0604020202020204" pitchFamily="34" charset="0"/>
+              <a:buChar char="•"/>
+            </a:pPr>
+            <a:r>
+              <a:rPr lang="en-GB" sz="2400" b="1" dirty="0"/>
+              <a:t>Addition of tools as capabilities</a:t>
+            </a:r>
+          </a:p>
+          <a:p>
+            <a:pPr>
+              <a:buFont typeface="Arial" panose="020B0604020202020204" pitchFamily="34" charset="0"/>
+              <a:buChar char="•"/>
+            </a:pPr>
+            <a:r>
+              <a:rPr lang="en-GB" sz="2400" b="1" dirty="0"/>
+              <a:t>Multilingual support</a:t>
+            </a:r>
+          </a:p>
+          <a:p>
+            <a:pPr>
+              <a:buFont typeface="Arial" panose="020B0604020202020204" pitchFamily="34" charset="0"/>
+              <a:buChar char="•"/>
+            </a:pPr>
+            <a:endParaRPr lang="en-GB" sz="2000" dirty="0"/>
+          </a:p>
+          <a:p>
+            <a:pPr marL="457200" lvl="1" indent="0">
+              <a:buNone/>
+            </a:pPr>
+            <a:endParaRPr lang="en-GB" sz="2000" dirty="0"/>
+          </a:p>
+          <a:p>
+            <a:pPr>
+              <a:buFont typeface="Arial" panose="020B0604020202020204" pitchFamily="34" charset="0"/>
+              <a:buChar char="•"/>
+            </a:pPr>
+            <a:endParaRPr lang="en-US" sz="1100" i="1" dirty="0"/>
+          </a:p>
+          <a:p>
+            <a:endParaRPr lang="en-US" sz="1100" dirty="0"/>
+          </a:p>
+          <a:p>
+            <a:endParaRPr lang="en-US" sz="1100" dirty="0"/>
+          </a:p>
+          <a:p>
+            <a:endParaRPr lang="en-IN" sz="1100" dirty="0"/>
+          </a:p>
+        </p:txBody>
+      </p:sp>
+      <p:sp>
+        <p:nvSpPr>
+          <p:cNvPr id="7" name="TextBox 6">
+            <a:extLst>
+              <a:ext uri="{FF2B5EF4-FFF2-40B4-BE49-F238E27FC236}">
+                <a16:creationId xmlns:a16="http://schemas.microsoft.com/office/drawing/2014/main" id="{6F7A0F2C-729B-F061-C23E-33FA9CFC2380}"/>
+              </a:ext>
+            </a:extLst>
+          </p:cNvPr>
+          <p:cNvSpPr txBox="1"/>
+          <p:nvPr/>
+        </p:nvSpPr>
+        <p:spPr>
+          <a:xfrm>
+            <a:off x="8976320" y="2852936"/>
+            <a:ext cx="473206" cy="369332"/>
+          </a:xfrm>
+          <a:prstGeom prst="rect">
+            <a:avLst/>
+          </a:prstGeom>
+          <a:noFill/>
+        </p:spPr>
+        <p:txBody>
+          <a:bodyPr wrap="none" rtlCol="0">
+            <a:spAutoFit/>
+          </a:bodyPr>
+          <a:lstStyle/>
+          <a:p>
+            <a:pPr marL="285750" indent="-285750">
+              <a:buFont typeface="Wingdings" panose="05000000000000000000" pitchFamily="2" charset="2"/>
+              <a:buChar char="§"/>
+            </a:pPr>
+            <a:endParaRPr lang="en-US" err="1">
+              <a:solidFill>
+                <a:schemeClr val="accent2"/>
+              </a:solidFill>
+              <a:latin typeface="Montserrat" pitchFamily="2" charset="0"/>
+            </a:endParaRPr>
+          </a:p>
+        </p:txBody>
+      </p:sp>
+    </p:spTree>
+    <p:extLst>
+      <p:ext uri="{BB962C8B-B14F-4D97-AF65-F5344CB8AC3E}">
+        <p14:creationId xmlns:p14="http://schemas.microsoft.com/office/powerpoint/2010/main" val="2671849246"/>
+      </p:ext>
+    </p:extLst>
+  </p:cSld>
+  <p:clrMapOvr>
+    <a:masterClrMapping/>
+  </p:clrMapOvr>
+</p:sld>
+</file>
+
+<file path=ppt/slides/slide16.xml><?xml version="1.0" encoding="utf-8"?>
+<p:sld xmlns:a="http://schemas.openxmlformats.org/drawingml/2006/main" xmlns:r="http://schemas.openxmlformats.org/officeDocument/2006/relationships" xmlns:p="http://schemas.openxmlformats.org/presentationml/2006/main">
+  <p:cSld>
+    <p:spTree>
+      <p:nvGrpSpPr>
+        <p:cNvPr id="1" name="">
+          <a:extLst>
+            <a:ext uri="{FF2B5EF4-FFF2-40B4-BE49-F238E27FC236}">
+              <a16:creationId xmlns:a16="http://schemas.microsoft.com/office/drawing/2014/main" id="{A4BFD971-70AA-ED89-5D46-F6D2644CE003}"/>
+            </a:ext>
+          </a:extLst>
+        </p:cNvPr>
+        <p:cNvGrpSpPr/>
+        <p:nvPr/>
+      </p:nvGrpSpPr>
+      <p:grpSpPr>
+        <a:xfrm>
+          <a:off x="0" y="0"/>
+          <a:ext cx="0" cy="0"/>
+          <a:chOff x="0" y="0"/>
+          <a:chExt cx="0" cy="0"/>
+        </a:xfrm>
+      </p:grpSpPr>
+      <p:sp>
+        <p:nvSpPr>
+          <p:cNvPr id="2" name="Title 1">
+            <a:extLst>
+              <a:ext uri="{FF2B5EF4-FFF2-40B4-BE49-F238E27FC236}">
+                <a16:creationId xmlns:a16="http://schemas.microsoft.com/office/drawing/2014/main" id="{4F4F9BC8-A7B8-103F-27AA-F4D68A13422B}"/>
+              </a:ext>
+            </a:extLst>
+          </p:cNvPr>
+          <p:cNvSpPr>
+            <a:spLocks noGrp="1"/>
+          </p:cNvSpPr>
+          <p:nvPr>
+            <p:ph type="title"/>
+          </p:nvPr>
+        </p:nvSpPr>
+        <p:spPr>
+          <a:xfrm>
+            <a:off x="305555" y="0"/>
+            <a:ext cx="11885653" cy="838800"/>
+          </a:xfrm>
+        </p:spPr>
+        <p:txBody>
+          <a:bodyPr anchor="ctr">
+            <a:normAutofit/>
+          </a:bodyPr>
+          <a:lstStyle/>
+          <a:p>
+            <a:r>
+              <a:rPr lang="en-IN" dirty="0"/>
+              <a:t>tools</a:t>
+            </a:r>
+          </a:p>
+        </p:txBody>
+      </p:sp>
+      <p:sp>
+        <p:nvSpPr>
+          <p:cNvPr id="3" name="Content Placeholder 2">
+            <a:extLst>
+              <a:ext uri="{FF2B5EF4-FFF2-40B4-BE49-F238E27FC236}">
+                <a16:creationId xmlns:a16="http://schemas.microsoft.com/office/drawing/2014/main" id="{E4634376-E169-1D87-5192-47D65F79501A}"/>
+              </a:ext>
+            </a:extLst>
+          </p:cNvPr>
+          <p:cNvSpPr>
+            <a:spLocks noGrp="1"/>
+          </p:cNvSpPr>
+          <p:nvPr>
+            <p:ph sz="quarter" idx="10"/>
+          </p:nvPr>
+        </p:nvSpPr>
+        <p:spPr>
+          <a:xfrm>
+            <a:off x="387580" y="752388"/>
+            <a:ext cx="11426771" cy="4813793"/>
+          </a:xfrm>
+        </p:spPr>
+        <p:txBody>
+          <a:bodyPr>
+            <a:normAutofit/>
+          </a:bodyPr>
+          <a:lstStyle/>
+          <a:p>
+            <a:pPr marL="457200" lvl="1" indent="0">
+              <a:buNone/>
+            </a:pPr>
+            <a:endParaRPr lang="en-US" sz="1100" dirty="0"/>
+          </a:p>
+          <a:p>
+            <a:pPr marL="800100" lvl="1" indent="-342900"/>
+            <a:endParaRPr lang="en-US" sz="1100" i="1" dirty="0"/>
+          </a:p>
+          <a:p>
+            <a:pPr marL="342900" lvl="0" indent="-342900">
+              <a:buFont typeface="Arial" panose="020B0604020202020204" pitchFamily="34" charset="0"/>
+              <a:buChar char="•"/>
+            </a:pPr>
+            <a:r>
+              <a:rPr lang="en-US" sz="1400" b="1" dirty="0"/>
+              <a:t>Traffic Prediction</a:t>
+            </a:r>
+            <a:r>
+              <a:rPr lang="en-US" sz="1400" dirty="0"/>
+              <a:t> — </a:t>
+            </a:r>
+            <a:r>
+              <a:rPr lang="en-US" sz="1400" dirty="0" err="1">
+                <a:latin typeface="Courier New" panose="02070309020205020404" pitchFamily="49" charset="0"/>
+              </a:rPr>
+              <a:t>get_traffic_forecast</a:t>
+            </a:r>
+            <a:r>
+              <a:rPr lang="en-US" sz="1400" dirty="0"/>
+              <a:t> </a:t>
+            </a:r>
+          </a:p>
+          <a:p>
+            <a:pPr marL="342900" lvl="0" indent="-342900">
+              <a:buFont typeface="Arial" panose="020B0604020202020204" pitchFamily="34" charset="0"/>
+              <a:buChar char="•"/>
+            </a:pPr>
+            <a:r>
+              <a:rPr lang="en-US" sz="1400" b="1" dirty="0"/>
+              <a:t>SLA Risk/State Prediction</a:t>
+            </a:r>
+            <a:r>
+              <a:rPr lang="en-US" sz="1400" dirty="0"/>
+              <a:t> — </a:t>
+            </a:r>
+            <a:r>
+              <a:rPr lang="en-US" sz="1400" dirty="0" err="1">
+                <a:latin typeface="Courier New" panose="02070309020205020404" pitchFamily="49" charset="0"/>
+              </a:rPr>
+              <a:t>get_sla_prediction</a:t>
+            </a:r>
+            <a:r>
+              <a:rPr lang="en-US" sz="1400" dirty="0"/>
+              <a:t> </a:t>
+            </a:r>
+          </a:p>
+          <a:p>
+            <a:pPr marL="342900" lvl="0" indent="-342900">
+              <a:buFont typeface="Arial" panose="020B0604020202020204" pitchFamily="34" charset="0"/>
+              <a:buChar char="•"/>
+            </a:pPr>
+            <a:r>
+              <a:rPr lang="en-US" sz="1400" b="1" dirty="0"/>
+              <a:t>SLA Risk Explanation</a:t>
+            </a:r>
+            <a:r>
+              <a:rPr lang="en-US" sz="1400" dirty="0"/>
+              <a:t> — </a:t>
+            </a:r>
+            <a:r>
+              <a:rPr lang="en-US" sz="1400" dirty="0" err="1">
+                <a:latin typeface="Courier New" panose="02070309020205020404" pitchFamily="49" charset="0"/>
+              </a:rPr>
+              <a:t>explain_sla_risk</a:t>
+            </a:r>
+            <a:r>
+              <a:rPr lang="en-US" sz="1400" dirty="0"/>
+              <a:t> </a:t>
+            </a:r>
+          </a:p>
+          <a:p>
+            <a:pPr marL="342900" lvl="0" indent="-342900">
+              <a:buFont typeface="Arial" panose="020B0604020202020204" pitchFamily="34" charset="0"/>
+              <a:buChar char="•"/>
+            </a:pPr>
+            <a:r>
+              <a:rPr lang="en-US" sz="1400" b="1" dirty="0"/>
+              <a:t>Full Network State</a:t>
+            </a:r>
+            <a:r>
+              <a:rPr lang="en-US" sz="1400" dirty="0"/>
+              <a:t> — </a:t>
+            </a:r>
+            <a:r>
+              <a:rPr lang="en-US" sz="1400" dirty="0" err="1">
+                <a:latin typeface="Courier New" panose="02070309020205020404" pitchFamily="49" charset="0"/>
+              </a:rPr>
+              <a:t>get_network_state_at_time</a:t>
+            </a:r>
+            <a:r>
+              <a:rPr lang="en-US" sz="1400" dirty="0"/>
+              <a:t> </a:t>
+            </a:r>
+          </a:p>
+          <a:p>
+            <a:pPr marL="342900" lvl="0" indent="-342900">
+              <a:buFont typeface="Arial" panose="020B0604020202020204" pitchFamily="34" charset="0"/>
+              <a:buChar char="•"/>
+            </a:pPr>
+            <a:r>
+              <a:rPr lang="en-US" sz="1400" b="1" dirty="0"/>
+              <a:t>Policy Comparison &amp; Recommendation</a:t>
+            </a:r>
+            <a:r>
+              <a:rPr lang="en-US" sz="1400" dirty="0"/>
+              <a:t> — </a:t>
+            </a:r>
+            <a:r>
+              <a:rPr lang="en-US" sz="1400" dirty="0" err="1">
+                <a:latin typeface="Courier New" panose="02070309020205020404" pitchFamily="49" charset="0"/>
+              </a:rPr>
+              <a:t>compare_policies_at_time</a:t>
+            </a:r>
+            <a:r>
+              <a:rPr lang="en-US" sz="1400" dirty="0"/>
+              <a:t> </a:t>
+            </a:r>
+          </a:p>
+          <a:p>
+            <a:pPr marL="342900" lvl="0" indent="-342900">
+              <a:buFont typeface="Arial" panose="020B0604020202020204" pitchFamily="34" charset="0"/>
+              <a:buChar char="•"/>
+            </a:pPr>
+            <a:r>
+              <a:rPr lang="en-US" sz="1400" b="1" dirty="0"/>
+              <a:t>Policy Counterfactual Simulation</a:t>
+            </a:r>
+            <a:r>
+              <a:rPr lang="en-US" sz="1400" dirty="0"/>
+              <a:t> — </a:t>
+            </a:r>
+            <a:r>
+              <a:rPr lang="en-US" sz="1400" dirty="0" err="1">
+                <a:latin typeface="Courier New" panose="02070309020205020404" pitchFamily="49" charset="0"/>
+              </a:rPr>
+              <a:t>simulate_policy_at_time</a:t>
+            </a:r>
+            <a:r>
+              <a:rPr lang="en-US" sz="1400" dirty="0"/>
+              <a:t> </a:t>
+            </a:r>
+          </a:p>
+          <a:p>
+            <a:pPr marL="342900" lvl="0" indent="-342900">
+              <a:buFont typeface="Arial" panose="020B0604020202020204" pitchFamily="34" charset="0"/>
+              <a:buChar char="•"/>
+            </a:pPr>
+            <a:r>
+              <a:rPr lang="en-US" sz="1400" b="1" dirty="0"/>
+              <a:t>SC Constraint Analysis</a:t>
+            </a:r>
+            <a:r>
+              <a:rPr lang="en-US" sz="1400" dirty="0"/>
+              <a:t> — </a:t>
+            </a:r>
+            <a:r>
+              <a:rPr lang="en-US" sz="1400" dirty="0" err="1">
+                <a:latin typeface="Courier New" panose="02070309020205020404" pitchFamily="49" charset="0"/>
+              </a:rPr>
+              <a:t>analyze_constrained_allocation</a:t>
+            </a:r>
+            <a:r>
+              <a:rPr lang="en-US" sz="1400" dirty="0"/>
+              <a:t> </a:t>
+            </a:r>
+          </a:p>
+          <a:p>
+            <a:pPr marL="342900" lvl="0" indent="-342900">
+              <a:buFont typeface="Arial" panose="020B0604020202020204" pitchFamily="34" charset="0"/>
+              <a:buChar char="•"/>
+            </a:pPr>
+            <a:r>
+              <a:rPr lang="en-US" sz="1400" b="1" dirty="0"/>
+              <a:t>Temporal Network Comparison</a:t>
+            </a:r>
+            <a:r>
+              <a:rPr lang="en-US" sz="1400" dirty="0"/>
+              <a:t> — </a:t>
+            </a:r>
+            <a:r>
+              <a:rPr lang="en-US" sz="1400" dirty="0" err="1">
+                <a:latin typeface="Courier New" panose="02070309020205020404" pitchFamily="49" charset="0"/>
+              </a:rPr>
+              <a:t>compare_network_states</a:t>
+            </a:r>
+            <a:r>
+              <a:rPr lang="en-US" sz="1400" dirty="0"/>
+              <a:t> </a:t>
+            </a:r>
+          </a:p>
+          <a:p>
+            <a:pPr marL="342900" lvl="0" indent="-342900">
+              <a:buFont typeface="Arial" panose="020B0604020202020204" pitchFamily="34" charset="0"/>
+              <a:buChar char="•"/>
+            </a:pPr>
+            <a:r>
+              <a:rPr lang="en-US" sz="1400" b="1" dirty="0"/>
+              <a:t>Risk/Peak Interval Discovery</a:t>
+            </a:r>
+            <a:r>
+              <a:rPr lang="en-US" sz="1400" dirty="0"/>
+              <a:t> — </a:t>
+            </a:r>
+            <a:r>
+              <a:rPr lang="en-US" sz="1400" dirty="0" err="1">
+                <a:latin typeface="Courier New" panose="02070309020205020404" pitchFamily="49" charset="0"/>
+              </a:rPr>
+              <a:t>find_risk_intervals</a:t>
+            </a:r>
+            <a:r>
+              <a:rPr lang="en-US" sz="1400" dirty="0"/>
+              <a:t> </a:t>
+            </a:r>
+          </a:p>
+          <a:p>
+            <a:pPr marL="342900" lvl="0" indent="-342900">
+              <a:buFont typeface="Arial" panose="020B0604020202020204" pitchFamily="34" charset="0"/>
+              <a:buChar char="•"/>
+            </a:pPr>
+            <a:r>
+              <a:rPr lang="en-US" sz="1400" b="1" dirty="0"/>
+              <a:t>Time-Range Summary</a:t>
+            </a:r>
+            <a:r>
+              <a:rPr lang="en-US" sz="1400" dirty="0"/>
+              <a:t> — </a:t>
+            </a:r>
+            <a:r>
+              <a:rPr lang="en-US" sz="1400" dirty="0" err="1">
+                <a:latin typeface="Courier New" panose="02070309020205020404" pitchFamily="49" charset="0"/>
+              </a:rPr>
+              <a:t>summarize_time_range</a:t>
+            </a:r>
+            <a:r>
+              <a:rPr lang="en-US" sz="1400" dirty="0"/>
+              <a:t> </a:t>
+            </a:r>
+          </a:p>
+          <a:p>
+            <a:pPr marL="342900" lvl="0" indent="-342900">
+              <a:buFont typeface="Arial" panose="020B0604020202020204" pitchFamily="34" charset="0"/>
+              <a:buChar char="•"/>
+            </a:pPr>
+            <a:r>
+              <a:rPr lang="en-US" sz="1400" b="1" dirty="0"/>
+              <a:t>Context Clarification</a:t>
+            </a:r>
+            <a:r>
+              <a:rPr lang="en-US" sz="1400" dirty="0"/>
+              <a:t> — </a:t>
+            </a:r>
+            <a:r>
+              <a:rPr lang="en-US" sz="1400" dirty="0" err="1">
+                <a:latin typeface="Courier New" panose="02070309020205020404" pitchFamily="49" charset="0"/>
+              </a:rPr>
+              <a:t>request_clarification</a:t>
+            </a:r>
+            <a:r>
+              <a:rPr lang="en-US" sz="1400" dirty="0"/>
+              <a:t> </a:t>
+            </a:r>
+          </a:p>
+          <a:p>
+            <a:pPr marL="342900" lvl="0" indent="-342900">
+              <a:buFont typeface="Arial" panose="020B0604020202020204" pitchFamily="34" charset="0"/>
+              <a:buChar char="•"/>
+            </a:pPr>
+            <a:r>
+              <a:rPr lang="en-US" sz="1400" b="1" dirty="0"/>
+              <a:t>Physical-Layer Scope Guardrail</a:t>
+            </a:r>
+            <a:r>
+              <a:rPr lang="en-US" sz="1400" dirty="0"/>
+              <a:t> — </a:t>
+            </a:r>
+            <a:r>
+              <a:rPr lang="en-US" sz="1400" dirty="0" err="1">
+                <a:latin typeface="Courier New" panose="02070309020205020404" pitchFamily="49" charset="0"/>
+              </a:rPr>
+              <a:t>decline_physical_layer</a:t>
+            </a:r>
+            <a:r>
+              <a:rPr lang="en-US" sz="1400" dirty="0"/>
+              <a:t> </a:t>
+            </a:r>
+          </a:p>
+          <a:p>
+            <a:pPr marL="342900" lvl="0" indent="-342900">
+              <a:buFont typeface="Arial" panose="020B0604020202020204" pitchFamily="34" charset="0"/>
+              <a:buChar char="•"/>
+            </a:pPr>
+            <a:r>
+              <a:rPr lang="en-US" sz="1400" b="1" dirty="0"/>
+              <a:t>General Out-of-Scope Guardrail</a:t>
+            </a:r>
+            <a:r>
+              <a:rPr lang="en-US" sz="1400" dirty="0"/>
+              <a:t> — </a:t>
+            </a:r>
+            <a:r>
+              <a:rPr lang="en-US" sz="1400" dirty="0" err="1">
+                <a:latin typeface="Courier New" panose="02070309020205020404" pitchFamily="49" charset="0"/>
+              </a:rPr>
+              <a:t>decline_out_of_scope</a:t>
+            </a:r>
+            <a:endParaRPr lang="en-US" sz="1400" dirty="0"/>
+          </a:p>
+          <a:p>
+            <a:pPr>
+              <a:buFont typeface="Arial" panose="020B0604020202020204" pitchFamily="34" charset="0"/>
+              <a:buChar char="•"/>
+            </a:pPr>
+            <a:endParaRPr lang="en-GB" sz="2000" dirty="0"/>
+          </a:p>
+          <a:p>
+            <a:pPr marL="457200" lvl="1" indent="0">
+              <a:buNone/>
+            </a:pPr>
+            <a:endParaRPr lang="en-GB" sz="2000" dirty="0"/>
+          </a:p>
+          <a:p>
+            <a:pPr>
+              <a:buFont typeface="Arial" panose="020B0604020202020204" pitchFamily="34" charset="0"/>
+              <a:buChar char="•"/>
+            </a:pPr>
+            <a:endParaRPr lang="en-US" sz="1100" i="1" dirty="0"/>
+          </a:p>
+          <a:p>
+            <a:endParaRPr lang="en-US" sz="1100" dirty="0"/>
+          </a:p>
+          <a:p>
+            <a:endParaRPr lang="en-US" sz="1100" dirty="0"/>
+          </a:p>
+          <a:p>
+            <a:endParaRPr lang="en-IN" sz="1100" dirty="0"/>
+          </a:p>
+        </p:txBody>
+      </p:sp>
+      <p:sp>
+        <p:nvSpPr>
+          <p:cNvPr id="7" name="TextBox 6">
+            <a:extLst>
+              <a:ext uri="{FF2B5EF4-FFF2-40B4-BE49-F238E27FC236}">
+                <a16:creationId xmlns:a16="http://schemas.microsoft.com/office/drawing/2014/main" id="{2E1903B8-F308-A847-CE4D-EE18EC0ABD9A}"/>
+              </a:ext>
+            </a:extLst>
+          </p:cNvPr>
+          <p:cNvSpPr txBox="1"/>
+          <p:nvPr/>
+        </p:nvSpPr>
+        <p:spPr>
+          <a:xfrm>
+            <a:off x="8976320" y="2852936"/>
+            <a:ext cx="473206" cy="369332"/>
+          </a:xfrm>
+          <a:prstGeom prst="rect">
+            <a:avLst/>
+          </a:prstGeom>
+          <a:noFill/>
+        </p:spPr>
+        <p:txBody>
+          <a:bodyPr wrap="none" rtlCol="0">
+            <a:spAutoFit/>
+          </a:bodyPr>
+          <a:lstStyle/>
+          <a:p>
+            <a:pPr marL="285750" indent="-285750">
+              <a:buFont typeface="Wingdings" panose="05000000000000000000" pitchFamily="2" charset="2"/>
+              <a:buChar char="§"/>
+            </a:pPr>
+            <a:endParaRPr lang="en-US" err="1">
+              <a:solidFill>
+                <a:schemeClr val="accent2"/>
+              </a:solidFill>
+              <a:latin typeface="Montserrat" pitchFamily="2" charset="0"/>
+            </a:endParaRPr>
+          </a:p>
+        </p:txBody>
+      </p:sp>
+    </p:spTree>
+    <p:extLst>
+      <p:ext uri="{BB962C8B-B14F-4D97-AF65-F5344CB8AC3E}">
+        <p14:creationId xmlns:p14="http://schemas.microsoft.com/office/powerpoint/2010/main" val="2585927000"/>
+      </p:ext>
+    </p:extLst>
+  </p:cSld>
+  <p:clrMapOvr>
+    <a:masterClrMapping/>
+  </p:clrMapOvr>
+</p:sld>
+</file>
+
+<file path=ppt/slides/slide17.xml><?xml version="1.0" encoding="utf-8"?>
+<p:sld xmlns:a="http://schemas.openxmlformats.org/drawingml/2006/main" xmlns:r="http://schemas.openxmlformats.org/officeDocument/2006/relationships" xmlns:p="http://schemas.openxmlformats.org/presentationml/2006/main">
+  <p:cSld>
+    <p:spTree>
+      <p:nvGrpSpPr>
+        <p:cNvPr id="1" name="">
+          <a:extLst>
+            <a:ext uri="{FF2B5EF4-FFF2-40B4-BE49-F238E27FC236}">
+              <a16:creationId xmlns:a16="http://schemas.microsoft.com/office/drawing/2014/main" id="{8FC667A8-DCA2-02C1-2D0C-C730BAAEAC05}"/>
+            </a:ext>
+          </a:extLst>
+        </p:cNvPr>
+        <p:cNvGrpSpPr/>
+        <p:nvPr/>
+      </p:nvGrpSpPr>
+      <p:grpSpPr>
+        <a:xfrm>
+          <a:off x="0" y="0"/>
+          <a:ext cx="0" cy="0"/>
+          <a:chOff x="0" y="0"/>
+          <a:chExt cx="0" cy="0"/>
+        </a:xfrm>
+      </p:grpSpPr>
+      <p:sp>
+        <p:nvSpPr>
+          <p:cNvPr id="2" name="Title 1">
+            <a:extLst>
+              <a:ext uri="{FF2B5EF4-FFF2-40B4-BE49-F238E27FC236}">
+                <a16:creationId xmlns:a16="http://schemas.microsoft.com/office/drawing/2014/main" id="{8C7D69CC-E432-96D1-EB47-862199E23B17}"/>
+              </a:ext>
+            </a:extLst>
+          </p:cNvPr>
+          <p:cNvSpPr>
+            <a:spLocks noGrp="1"/>
+          </p:cNvSpPr>
+          <p:nvPr>
+            <p:ph type="title"/>
+          </p:nvPr>
+        </p:nvSpPr>
+        <p:spPr>
+          <a:xfrm>
+            <a:off x="305555" y="0"/>
+            <a:ext cx="11885653" cy="838800"/>
+          </a:xfrm>
+        </p:spPr>
+        <p:txBody>
+          <a:bodyPr anchor="ctr">
+            <a:normAutofit/>
+          </a:bodyPr>
+          <a:lstStyle/>
+          <a:p>
+            <a:r>
+              <a:rPr lang="en-IN" dirty="0"/>
+              <a:t>Evaluation steps</a:t>
+            </a:r>
+          </a:p>
+        </p:txBody>
+      </p:sp>
+      <mc:AlternateContent xmlns:mc="http://schemas.openxmlformats.org/markup-compatibility/2006">
+        <mc:Choice xmlns:a14="http://schemas.microsoft.com/office/drawing/2010/main" Requires="a14">
+          <p:sp>
+            <p:nvSpPr>
+              <p:cNvPr id="3" name="Content Placeholder 2">
+                <a:extLst>
+                  <a:ext uri="{FF2B5EF4-FFF2-40B4-BE49-F238E27FC236}">
+                    <a16:creationId xmlns:a16="http://schemas.microsoft.com/office/drawing/2014/main" id="{E1CEBB5E-ECF0-7FF5-347B-2E75797E5B25}"/>
+                  </a:ext>
+                </a:extLst>
+              </p:cNvPr>
+              <p:cNvSpPr>
+                <a:spLocks noGrp="1"/>
+              </p:cNvSpPr>
+              <p:nvPr>
+                <p:ph sz="quarter" idx="10"/>
+              </p:nvPr>
+            </p:nvSpPr>
+            <p:spPr>
+              <a:xfrm>
+                <a:off x="172788" y="556007"/>
+                <a:ext cx="11426771" cy="5924573"/>
+              </a:xfrm>
+            </p:spPr>
+            <p:txBody>
+              <a:bodyPr>
+                <a:normAutofit/>
+              </a:bodyPr>
+              <a:lstStyle/>
+              <a:p>
+                <a:pPr marL="457200" lvl="1" indent="0">
+                  <a:buNone/>
+                </a:pPr>
+                <a:endParaRPr lang="en-US" sz="1100" dirty="0"/>
+              </a:p>
+              <a:p>
+                <a:pPr marL="800100" lvl="1" indent="-342900"/>
+                <a:endParaRPr lang="en-US" sz="1100" i="1" dirty="0"/>
+              </a:p>
+              <a:p>
+                <a:pPr>
+                  <a:buNone/>
+                </a:pPr>
+                <a14:m>
+                  <m:oMathPara xmlns:m="http://schemas.openxmlformats.org/officeDocument/2006/math">
+                    <m:oMath>
+                      <m:r>
+                        <m:rPr>
+                          <m:nor/>
+                        </m:rPr>
+                        <a:rPr lang="en-US" sz="1400" b="0" i="0"/>
+                        <m:t>Tool Accuracy</m:t>
+                      </m:r>
+                      <m:r>
+                        <a:rPr lang="en-US" sz="1400" b="0" i="0">
+                          <a:latin typeface="Cambria Math" panose="02040503050406030204" pitchFamily="18" charset="0"/>
+                        </a:rPr>
+                        <m:t>=</m:t>
+                      </m:r>
+                      <m:f>
+                        <m:fPr>
+                          <m:ctrlPr>
+                            <a:rPr lang="en-US" sz="1400" b="0" i="0">
+                              <a:latin typeface="Cambria Math" panose="02040503050406030204" pitchFamily="18" charset="0"/>
+                            </a:rPr>
+                          </m:ctrlPr>
+                        </m:fPr>
+                        <m:num>
+                          <m:r>
+                            <m:rPr>
+                              <m:nor/>
+                            </m:rPr>
+                            <a:rPr lang="en-US" sz="1400" b="0" i="0">
+                              <a:latin typeface="Cambria Math" panose="02040503050406030204" pitchFamily="18" charset="0"/>
+                            </a:rPr>
+                            <m:t>Correct tool selections</m:t>
+                          </m:r>
+                        </m:num>
+                        <m:den>
+                          <m:r>
+                            <m:rPr>
+                              <m:nor/>
+                            </m:rPr>
+                            <a:rPr lang="en-US" sz="1400" b="0" i="0">
+                              <a:latin typeface="Cambria Math" panose="02040503050406030204" pitchFamily="18" charset="0"/>
+                            </a:rPr>
+                            <m:t>Total queries</m:t>
+                          </m:r>
+                        </m:den>
+                      </m:f>
+                      <m:r>
+                        <a:rPr lang="en-US" sz="1400" b="0" i="0">
+                          <a:latin typeface="Cambria Math" panose="02040503050406030204" pitchFamily="18" charset="0"/>
+                        </a:rPr>
+                        <m:t>×100</m:t>
+                      </m:r>
+                    </m:oMath>
+                  </m:oMathPara>
+                </a14:m>
+                <a:endParaRPr lang="en-US" sz="1400" b="0" dirty="0"/>
+              </a:p>
+              <a:p>
+                <a:pPr>
+                  <a:buNone/>
+                </a:pPr>
+                <a:r>
+                  <a:rPr lang="en-US" sz="1400" dirty="0"/>
+                  <a:t>Argument Accuracy=Total queries/Queries with correct extracted arguments​×100</a:t>
+                </a:r>
+              </a:p>
+              <a:p>
+                <a:pPr>
+                  <a:buNone/>
+                </a:pPr>
+                <a:endParaRPr lang="en-US" sz="1400" dirty="0"/>
+              </a:p>
+              <a:p>
+                <a:pPr>
+                  <a:buNone/>
+                </a:pPr>
+                <a:r>
+                  <a:rPr lang="en-US" sz="2000" dirty="0"/>
+                  <a:t>	   Hallucination Rate=Total queries / Queries with unsupported LLM claims​ × 100</a:t>
+                </a:r>
+              </a:p>
+              <a:p>
+                <a:pPr marL="457200" lvl="1" indent="0">
+                  <a:buNone/>
+                </a:pPr>
+                <a:endParaRPr lang="en-GB" sz="2000" dirty="0"/>
+              </a:p>
+              <a:p>
+                <a:pPr marL="457200" lvl="1" indent="0">
+                  <a:buNone/>
+                </a:pPr>
+                <a:r>
+                  <a:rPr lang="en-US" sz="2000" dirty="0"/>
+                  <a:t>Combined Average Accuracy = (Tool Accuracy + Argument Accuracy) / 2 = (74 + 56) / 2 = 65%	</a:t>
+                </a:r>
+                <a:endParaRPr lang="en-US" sz="1100" i="1" dirty="0"/>
+              </a:p>
+              <a:p>
+                <a:endParaRPr lang="en-US" sz="1100" dirty="0"/>
+              </a:p>
+              <a:p>
+                <a:endParaRPr lang="en-US" sz="1100" dirty="0"/>
+              </a:p>
+              <a:p>
+                <a:endParaRPr lang="en-IN" sz="1100" dirty="0"/>
+              </a:p>
+            </p:txBody>
+          </p:sp>
+        </mc:Choice>
+        <mc:Fallback>
+          <p:sp>
+            <p:nvSpPr>
+              <p:cNvPr id="3" name="Content Placeholder 2">
+                <a:extLst>
+                  <a:ext uri="{FF2B5EF4-FFF2-40B4-BE49-F238E27FC236}">
+                    <a16:creationId xmlns:a16="http://schemas.microsoft.com/office/drawing/2014/main" id="{E1CEBB5E-ECF0-7FF5-347B-2E75797E5B25}"/>
+                  </a:ext>
+                </a:extLst>
+              </p:cNvPr>
+              <p:cNvSpPr>
+                <a:spLocks noGrp="1" noRot="1" noChangeAspect="1" noMove="1" noResize="1" noEditPoints="1" noAdjustHandles="1" noChangeArrowheads="1" noChangeShapeType="1" noTextEdit="1"/>
+              </p:cNvSpPr>
+              <p:nvPr>
+                <p:ph sz="quarter" idx="10"/>
+              </p:nvPr>
+            </p:nvSpPr>
+            <p:spPr>
+              <a:xfrm>
+                <a:off x="172788" y="556007"/>
+                <a:ext cx="11426771" cy="5924573"/>
+              </a:xfrm>
+              <a:blipFill>
+                <a:blip r:embed="rId3"/>
+                <a:stretch>
+                  <a:fillRect l="-160" r="-427"/>
+                </a:stretch>
+              </a:blipFill>
+            </p:spPr>
+            <p:txBody>
+              <a:bodyPr/>
+              <a:lstStyle/>
+              <a:p>
+                <a:r>
+                  <a:rPr lang="en-US">
+                    <a:noFill/>
+                  </a:rPr>
+                  <a:t> </a:t>
+                </a:r>
+              </a:p>
+            </p:txBody>
+          </p:sp>
+        </mc:Fallback>
+      </mc:AlternateContent>
+    </p:spTree>
+    <p:extLst>
+      <p:ext uri="{BB962C8B-B14F-4D97-AF65-F5344CB8AC3E}">
+        <p14:creationId xmlns:p14="http://schemas.microsoft.com/office/powerpoint/2010/main" val="593684527"/>
+      </p:ext>
+    </p:extLst>
+  </p:cSld>
+  <p:clrMapOvr>
+    <a:masterClrMapping/>
+  </p:clrMapOvr>
+</p:sld>
+</file>
+
+<file path=ppt/slides/slide18.xml><?xml version="1.0" encoding="utf-8"?>
+<p:sld xmlns:a="http://schemas.openxmlformats.org/drawingml/2006/main" xmlns:r="http://schemas.openxmlformats.org/officeDocument/2006/relationships" xmlns:p="http://schemas.openxmlformats.org/presentationml/2006/main">
+  <p:cSld>
+    <p:spTree>
+      <p:nvGrpSpPr>
+        <p:cNvPr id="1" name="">
+          <a:extLst>
+            <a:ext uri="{FF2B5EF4-FFF2-40B4-BE49-F238E27FC236}">
+              <a16:creationId xmlns:a16="http://schemas.microsoft.com/office/drawing/2014/main" id="{B900C2F6-9F79-33A7-76FC-2774DB35FB56}"/>
+            </a:ext>
+          </a:extLst>
+        </p:cNvPr>
+        <p:cNvGrpSpPr/>
+        <p:nvPr/>
+      </p:nvGrpSpPr>
+      <p:grpSpPr>
+        <a:xfrm>
+          <a:off x="0" y="0"/>
+          <a:ext cx="0" cy="0"/>
+          <a:chOff x="0" y="0"/>
+          <a:chExt cx="0" cy="0"/>
+        </a:xfrm>
+      </p:grpSpPr>
+      <p:sp>
+        <p:nvSpPr>
+          <p:cNvPr id="2" name="Title 1">
+            <a:extLst>
+              <a:ext uri="{FF2B5EF4-FFF2-40B4-BE49-F238E27FC236}">
+                <a16:creationId xmlns:a16="http://schemas.microsoft.com/office/drawing/2014/main" id="{5BB8F4F5-9009-FCC1-1542-85E4687F341F}"/>
+              </a:ext>
+            </a:extLst>
+          </p:cNvPr>
+          <p:cNvSpPr>
+            <a:spLocks noGrp="1"/>
+          </p:cNvSpPr>
+          <p:nvPr>
+            <p:ph type="title"/>
+          </p:nvPr>
+        </p:nvSpPr>
+        <p:spPr>
+          <a:xfrm>
+            <a:off x="305555" y="0"/>
+            <a:ext cx="11885653" cy="838800"/>
+          </a:xfrm>
+        </p:spPr>
+        <p:txBody>
+          <a:bodyPr anchor="ctr">
+            <a:normAutofit/>
+          </a:bodyPr>
+          <a:lstStyle/>
+          <a:p>
+            <a:r>
+              <a:rPr lang="en-IN" dirty="0"/>
+              <a:t>Todays demo</a:t>
+            </a:r>
+          </a:p>
+        </p:txBody>
+      </p:sp>
+      <p:sp>
+        <p:nvSpPr>
+          <p:cNvPr id="3" name="Content Placeholder 2">
+            <a:extLst>
+              <a:ext uri="{FF2B5EF4-FFF2-40B4-BE49-F238E27FC236}">
+                <a16:creationId xmlns:a16="http://schemas.microsoft.com/office/drawing/2014/main" id="{F2285AB5-7FE8-25C8-B84E-698086E31CC4}"/>
+              </a:ext>
+            </a:extLst>
+          </p:cNvPr>
+          <p:cNvSpPr>
+            <a:spLocks noGrp="1"/>
+          </p:cNvSpPr>
+          <p:nvPr>
+            <p:ph sz="quarter" idx="10"/>
+          </p:nvPr>
+        </p:nvSpPr>
+        <p:spPr>
+          <a:xfrm>
+            <a:off x="172788" y="556007"/>
+            <a:ext cx="11426771" cy="5924573"/>
+          </a:xfrm>
+        </p:spPr>
+        <p:txBody>
+          <a:bodyPr>
+            <a:normAutofit fontScale="92500" lnSpcReduction="10000"/>
+          </a:bodyPr>
+          <a:lstStyle/>
+          <a:p>
+            <a:pPr marL="457200" lvl="1" indent="0">
+              <a:buNone/>
+            </a:pPr>
+            <a:endParaRPr lang="en-US" sz="1100" dirty="0"/>
+          </a:p>
+          <a:p>
+            <a:pPr marL="800100" lvl="1" indent="-342900"/>
+            <a:endParaRPr lang="en-US" sz="1100" i="1" dirty="0"/>
+          </a:p>
+          <a:p>
+            <a:r>
+              <a:rPr lang="en-US" sz="2000" dirty="0"/>
+              <a:t>1. What traffic do you expect at 21:15?</a:t>
+            </a:r>
+          </a:p>
+          <a:p>
+            <a:endParaRPr lang="en-US" sz="2000" dirty="0"/>
+          </a:p>
+          <a:p>
+            <a:r>
+              <a:rPr lang="en-US" sz="2000" dirty="0"/>
+              <a:t>2. What is the predicted SLA state at 21:15?</a:t>
+            </a:r>
+          </a:p>
+          <a:p>
+            <a:endParaRPr lang="en-US" sz="2000" dirty="0"/>
+          </a:p>
+          <a:p>
+            <a:r>
+              <a:rPr lang="en-US" sz="2000" dirty="0"/>
+              <a:t>3. Show me the complete network state at 16:20.</a:t>
+            </a:r>
+          </a:p>
+          <a:p>
+            <a:endParaRPr lang="en-US" sz="2000" dirty="0"/>
+          </a:p>
+          <a:p>
+            <a:r>
+              <a:rPr lang="en-US" sz="2000" dirty="0"/>
+              <a:t>4. Keep PON on 2 subcarriers at 21:15 and allocate the remaining two.</a:t>
+            </a:r>
+          </a:p>
+          <a:p>
+            <a:endParaRPr lang="en-US" sz="2000" dirty="0"/>
+          </a:p>
+          <a:p>
+            <a:r>
+              <a:rPr lang="en-US" sz="2000" dirty="0"/>
+              <a:t>5. Reserve 1 subcarrier for PON at 21:15 and allocate the remaining three.</a:t>
+            </a:r>
+          </a:p>
+          <a:p>
+            <a:endParaRPr lang="en-US" sz="2000" dirty="0"/>
+          </a:p>
+          <a:p>
+            <a:r>
+              <a:rPr lang="en-US" sz="2000" dirty="0"/>
+              <a:t>6. And one hour later?</a:t>
+            </a:r>
+          </a:p>
+          <a:p>
+            <a:endParaRPr lang="en-US" sz="2000" dirty="0"/>
+          </a:p>
+          <a:p>
+            <a:r>
+              <a:rPr lang="en-US" sz="2000" dirty="0"/>
+              <a:t>   System → Which time should I use as the reference?</a:t>
+            </a:r>
+          </a:p>
+          <a:p>
+            <a:endParaRPr lang="en-US" sz="2000" dirty="0"/>
+          </a:p>
+          <a:p>
+            <a:r>
+              <a:rPr lang="en-US" sz="2000" dirty="0"/>
+              <a:t>7. </a:t>
+            </a:r>
+            <a:r>
+              <a:rPr lang="en-US" sz="2000"/>
+              <a:t>10:00%</a:t>
+            </a:r>
+            <a:r>
+              <a:rPr lang="en-US" sz="2000" dirty="0"/>
+              <a:t>	</a:t>
+            </a:r>
+            <a:endParaRPr lang="en-US" sz="1100" i="1" dirty="0"/>
+          </a:p>
+          <a:p>
+            <a:endParaRPr lang="en-US" sz="1100" dirty="0"/>
+          </a:p>
+          <a:p>
+            <a:endParaRPr lang="en-US" sz="1100" dirty="0"/>
+          </a:p>
+          <a:p>
+            <a:endParaRPr lang="en-IN" sz="1100" dirty="0"/>
+          </a:p>
+        </p:txBody>
+      </p:sp>
+    </p:spTree>
+    <p:extLst>
+      <p:ext uri="{BB962C8B-B14F-4D97-AF65-F5344CB8AC3E}">
+        <p14:creationId xmlns:p14="http://schemas.microsoft.com/office/powerpoint/2010/main" val="315198265"/>
       </p:ext>
     </p:extLst>
   </p:cSld>

</xml_diff>

<commit_message>
Freeze v3 router and current demo backend
</commit_message>
<xml_diff>
--- a/Imran_NoF_26.pptx
+++ b/Imran_NoF_26.pptx
@@ -5,7 +5,7 @@
     <p:sldMasterId id="2147483648" r:id="rId1"/>
   </p:sldMasterIdLst>
   <p:notesMasterIdLst>
-    <p:notesMasterId r:id="rId20"/>
+    <p:notesMasterId r:id="rId27"/>
   </p:notesMasterIdLst>
   <p:sldIdLst>
     <p:sldId id="514" r:id="rId2"/>
@@ -23,9 +23,16 @@
     <p:sldId id="556" r:id="rId14"/>
     <p:sldId id="543" r:id="rId15"/>
     <p:sldId id="557" r:id="rId16"/>
-    <p:sldId id="558" r:id="rId17"/>
-    <p:sldId id="560" r:id="rId18"/>
-    <p:sldId id="561" r:id="rId19"/>
+    <p:sldId id="563" r:id="rId17"/>
+    <p:sldId id="562" r:id="rId18"/>
+    <p:sldId id="558" r:id="rId19"/>
+    <p:sldId id="560" r:id="rId20"/>
+    <p:sldId id="561" r:id="rId21"/>
+    <p:sldId id="564" r:id="rId22"/>
+    <p:sldId id="565" r:id="rId23"/>
+    <p:sldId id="566" r:id="rId24"/>
+    <p:sldId id="567" r:id="rId25"/>
+    <p:sldId id="568" r:id="rId26"/>
   </p:sldIdLst>
   <p:sldSz cx="12192000" cy="6858000"/>
   <p:notesSz cx="6858000" cy="9144000"/>
@@ -358,7 +365,7 @@
           <a:p>
             <a:fld id="{A85B8F7D-9DF9-4D5C-A5C0-CD9BE235298F}" type="datetimeFigureOut">
               <a:rPr lang="en-US" smtClean="0"/>
-              <a:t>9/14/2026</a:t>
+              <a:t>9/15/2026</a:t>
             </a:fld>
             <a:endParaRPr lang="en-US"/>
           </a:p>
@@ -1281,6 +1288,222 @@
         <p:cNvPr id="1" name="">
           <a:extLst>
             <a:ext uri="{FF2B5EF4-FFF2-40B4-BE49-F238E27FC236}">
+              <a16:creationId xmlns:a16="http://schemas.microsoft.com/office/drawing/2014/main" id="{092EB607-9107-A725-E6EB-3E8F6CFD57E5}"/>
+            </a:ext>
+          </a:extLst>
+        </p:cNvPr>
+        <p:cNvGrpSpPr/>
+        <p:nvPr/>
+      </p:nvGrpSpPr>
+      <p:grpSpPr>
+        <a:xfrm>
+          <a:off x="0" y="0"/>
+          <a:ext cx="0" cy="0"/>
+          <a:chOff x="0" y="0"/>
+          <a:chExt cx="0" cy="0"/>
+        </a:xfrm>
+      </p:grpSpPr>
+      <p:sp>
+        <p:nvSpPr>
+          <p:cNvPr id="2" name="Slide Image Placeholder 1">
+            <a:extLst>
+              <a:ext uri="{FF2B5EF4-FFF2-40B4-BE49-F238E27FC236}">
+                <a16:creationId xmlns:a16="http://schemas.microsoft.com/office/drawing/2014/main" id="{74079909-BB41-D309-0D11-E9688504E5B3}"/>
+              </a:ext>
+            </a:extLst>
+          </p:cNvPr>
+          <p:cNvSpPr>
+            <a:spLocks noGrp="1" noRot="1" noChangeAspect="1"/>
+          </p:cNvSpPr>
+          <p:nvPr>
+            <p:ph type="sldImg"/>
+          </p:nvPr>
+        </p:nvSpPr>
+        <p:spPr/>
+      </p:sp>
+      <p:sp>
+        <p:nvSpPr>
+          <p:cNvPr id="3" name="Notes Placeholder 2">
+            <a:extLst>
+              <a:ext uri="{FF2B5EF4-FFF2-40B4-BE49-F238E27FC236}">
+                <a16:creationId xmlns:a16="http://schemas.microsoft.com/office/drawing/2014/main" id="{963149F9-5683-E8DF-4574-6AB9DFB0FC7A}"/>
+              </a:ext>
+            </a:extLst>
+          </p:cNvPr>
+          <p:cNvSpPr>
+            <a:spLocks noGrp="1"/>
+          </p:cNvSpPr>
+          <p:nvPr>
+            <p:ph type="body" idx="1"/>
+          </p:nvPr>
+        </p:nvSpPr>
+        <p:spPr/>
+        <p:txBody>
+          <a:bodyPr/>
+          <a:lstStyle/>
+          <a:p>
+            <a:endParaRPr lang="en-US"/>
+          </a:p>
+        </p:txBody>
+      </p:sp>
+      <p:sp>
+        <p:nvSpPr>
+          <p:cNvPr id="4" name="Slide Number Placeholder 3">
+            <a:extLst>
+              <a:ext uri="{FF2B5EF4-FFF2-40B4-BE49-F238E27FC236}">
+                <a16:creationId xmlns:a16="http://schemas.microsoft.com/office/drawing/2014/main" id="{54F717F0-2648-14F9-B4B1-0AB8CB16AE68}"/>
+              </a:ext>
+            </a:extLst>
+          </p:cNvPr>
+          <p:cNvSpPr>
+            <a:spLocks noGrp="1"/>
+          </p:cNvSpPr>
+          <p:nvPr>
+            <p:ph type="sldNum" sz="quarter" idx="5"/>
+          </p:nvPr>
+        </p:nvSpPr>
+        <p:spPr/>
+        <p:txBody>
+          <a:bodyPr/>
+          <a:lstStyle/>
+          <a:p>
+            <a:fld id="{14DFF4C2-74DA-1D46-B541-49BD0013B7E1}" type="slidenum">
+              <a:rPr lang="en-DE" smtClean="0"/>
+              <a:t>16</a:t>
+            </a:fld>
+            <a:endParaRPr lang="en-DE"/>
+          </a:p>
+        </p:txBody>
+      </p:sp>
+    </p:spTree>
+    <p:extLst>
+      <p:ext uri="{BB962C8B-B14F-4D97-AF65-F5344CB8AC3E}">
+        <p14:creationId xmlns:p14="http://schemas.microsoft.com/office/powerpoint/2010/main" val="3865714206"/>
+      </p:ext>
+    </p:extLst>
+  </p:cSld>
+  <p:clrMapOvr>
+    <a:masterClrMapping/>
+  </p:clrMapOvr>
+</p:notes>
+</file>
+
+<file path=ppt/notesSlides/notesSlide16.xml><?xml version="1.0" encoding="utf-8"?>
+<p:notes xmlns:a="http://schemas.openxmlformats.org/drawingml/2006/main" xmlns:r="http://schemas.openxmlformats.org/officeDocument/2006/relationships" xmlns:p="http://schemas.openxmlformats.org/presentationml/2006/main">
+  <p:cSld>
+    <p:spTree>
+      <p:nvGrpSpPr>
+        <p:cNvPr id="1" name="">
+          <a:extLst>
+            <a:ext uri="{FF2B5EF4-FFF2-40B4-BE49-F238E27FC236}">
+              <a16:creationId xmlns:a16="http://schemas.microsoft.com/office/drawing/2014/main" id="{D442ABE2-5B98-3775-FB7F-EFAEDC1EBB2A}"/>
+            </a:ext>
+          </a:extLst>
+        </p:cNvPr>
+        <p:cNvGrpSpPr/>
+        <p:nvPr/>
+      </p:nvGrpSpPr>
+      <p:grpSpPr>
+        <a:xfrm>
+          <a:off x="0" y="0"/>
+          <a:ext cx="0" cy="0"/>
+          <a:chOff x="0" y="0"/>
+          <a:chExt cx="0" cy="0"/>
+        </a:xfrm>
+      </p:grpSpPr>
+      <p:sp>
+        <p:nvSpPr>
+          <p:cNvPr id="2" name="Slide Image Placeholder 1">
+            <a:extLst>
+              <a:ext uri="{FF2B5EF4-FFF2-40B4-BE49-F238E27FC236}">
+                <a16:creationId xmlns:a16="http://schemas.microsoft.com/office/drawing/2014/main" id="{B50D52C0-0C7B-5F10-D53B-20355F2E80C1}"/>
+              </a:ext>
+            </a:extLst>
+          </p:cNvPr>
+          <p:cNvSpPr>
+            <a:spLocks noGrp="1" noRot="1" noChangeAspect="1"/>
+          </p:cNvSpPr>
+          <p:nvPr>
+            <p:ph type="sldImg"/>
+          </p:nvPr>
+        </p:nvSpPr>
+        <p:spPr/>
+      </p:sp>
+      <p:sp>
+        <p:nvSpPr>
+          <p:cNvPr id="3" name="Notes Placeholder 2">
+            <a:extLst>
+              <a:ext uri="{FF2B5EF4-FFF2-40B4-BE49-F238E27FC236}">
+                <a16:creationId xmlns:a16="http://schemas.microsoft.com/office/drawing/2014/main" id="{E969A23A-614E-C815-C571-2D66A4B3B554}"/>
+              </a:ext>
+            </a:extLst>
+          </p:cNvPr>
+          <p:cNvSpPr>
+            <a:spLocks noGrp="1"/>
+          </p:cNvSpPr>
+          <p:nvPr>
+            <p:ph type="body" idx="1"/>
+          </p:nvPr>
+        </p:nvSpPr>
+        <p:spPr/>
+        <p:txBody>
+          <a:bodyPr/>
+          <a:lstStyle/>
+          <a:p>
+            <a:endParaRPr lang="en-US"/>
+          </a:p>
+        </p:txBody>
+      </p:sp>
+      <p:sp>
+        <p:nvSpPr>
+          <p:cNvPr id="4" name="Slide Number Placeholder 3">
+            <a:extLst>
+              <a:ext uri="{FF2B5EF4-FFF2-40B4-BE49-F238E27FC236}">
+                <a16:creationId xmlns:a16="http://schemas.microsoft.com/office/drawing/2014/main" id="{6D643267-81F2-C2E2-70EF-71DF274C73A5}"/>
+              </a:ext>
+            </a:extLst>
+          </p:cNvPr>
+          <p:cNvSpPr>
+            <a:spLocks noGrp="1"/>
+          </p:cNvSpPr>
+          <p:nvPr>
+            <p:ph type="sldNum" sz="quarter" idx="5"/>
+          </p:nvPr>
+        </p:nvSpPr>
+        <p:spPr/>
+        <p:txBody>
+          <a:bodyPr/>
+          <a:lstStyle/>
+          <a:p>
+            <a:fld id="{14DFF4C2-74DA-1D46-B541-49BD0013B7E1}" type="slidenum">
+              <a:rPr lang="en-DE" smtClean="0"/>
+              <a:t>17</a:t>
+            </a:fld>
+            <a:endParaRPr lang="en-DE"/>
+          </a:p>
+        </p:txBody>
+      </p:sp>
+    </p:spTree>
+    <p:extLst>
+      <p:ext uri="{BB962C8B-B14F-4D97-AF65-F5344CB8AC3E}">
+        <p14:creationId xmlns:p14="http://schemas.microsoft.com/office/powerpoint/2010/main" val="3495292350"/>
+      </p:ext>
+    </p:extLst>
+  </p:cSld>
+  <p:clrMapOvr>
+    <a:masterClrMapping/>
+  </p:clrMapOvr>
+</p:notes>
+</file>
+
+<file path=ppt/notesSlides/notesSlide17.xml><?xml version="1.0" encoding="utf-8"?>
+<p:notes xmlns:a="http://schemas.openxmlformats.org/drawingml/2006/main" xmlns:r="http://schemas.openxmlformats.org/officeDocument/2006/relationships" xmlns:p="http://schemas.openxmlformats.org/presentationml/2006/main">
+  <p:cSld>
+    <p:spTree>
+      <p:nvGrpSpPr>
+        <p:cNvPr id="1" name="">
+          <a:extLst>
+            <a:ext uri="{FF2B5EF4-FFF2-40B4-BE49-F238E27FC236}">
               <a16:creationId xmlns:a16="http://schemas.microsoft.com/office/drawing/2014/main" id="{978A0C91-209A-A28D-403F-5C0334E3AE64}"/>
             </a:ext>
           </a:extLst>
@@ -1362,7 +1585,7 @@
           <a:p>
             <a:fld id="{14DFF4C2-74DA-1D46-B541-49BD0013B7E1}" type="slidenum">
               <a:rPr lang="en-DE" smtClean="0"/>
-              <a:t>16</a:t>
+              <a:t>18</a:t>
             </a:fld>
             <a:endParaRPr lang="en-DE"/>
           </a:p>
@@ -1381,7 +1604,7 @@
 </p:notes>
 </file>
 
-<file path=ppt/notesSlides/notesSlide16.xml><?xml version="1.0" encoding="utf-8"?>
+<file path=ppt/notesSlides/notesSlide18.xml><?xml version="1.0" encoding="utf-8"?>
 <p:notes xmlns:a="http://schemas.openxmlformats.org/drawingml/2006/main" xmlns:r="http://schemas.openxmlformats.org/officeDocument/2006/relationships" xmlns:p="http://schemas.openxmlformats.org/presentationml/2006/main">
   <p:cSld>
     <p:spTree>
@@ -1470,7 +1693,7 @@
           <a:p>
             <a:fld id="{14DFF4C2-74DA-1D46-B541-49BD0013B7E1}" type="slidenum">
               <a:rPr lang="en-DE" smtClean="0"/>
-              <a:t>17</a:t>
+              <a:t>19</a:t>
             </a:fld>
             <a:endParaRPr lang="en-DE"/>
           </a:p>
@@ -1489,7 +1712,7 @@
 </p:notes>
 </file>
 
-<file path=ppt/notesSlides/notesSlide17.xml><?xml version="1.0" encoding="utf-8"?>
+<file path=ppt/notesSlides/notesSlide19.xml><?xml version="1.0" encoding="utf-8"?>
 <p:notes xmlns:a="http://schemas.openxmlformats.org/drawingml/2006/main" xmlns:r="http://schemas.openxmlformats.org/officeDocument/2006/relationships" xmlns:p="http://schemas.openxmlformats.org/presentationml/2006/main">
   <p:cSld>
     <p:spTree>
@@ -1578,7 +1801,7 @@
           <a:p>
             <a:fld id="{14DFF4C2-74DA-1D46-B541-49BD0013B7E1}" type="slidenum">
               <a:rPr lang="en-DE" smtClean="0"/>
-              <a:t>18</a:t>
+              <a:t>20</a:t>
             </a:fld>
             <a:endParaRPr lang="en-DE"/>
           </a:p>
@@ -1696,6 +1919,546 @@
     <p:extLst>
       <p:ext uri="{BB962C8B-B14F-4D97-AF65-F5344CB8AC3E}">
         <p14:creationId xmlns:p14="http://schemas.microsoft.com/office/powerpoint/2010/main" val="1208360239"/>
+      </p:ext>
+    </p:extLst>
+  </p:cSld>
+  <p:clrMapOvr>
+    <a:masterClrMapping/>
+  </p:clrMapOvr>
+</p:notes>
+</file>
+
+<file path=ppt/notesSlides/notesSlide20.xml><?xml version="1.0" encoding="utf-8"?>
+<p:notes xmlns:a="http://schemas.openxmlformats.org/drawingml/2006/main" xmlns:r="http://schemas.openxmlformats.org/officeDocument/2006/relationships" xmlns:p="http://schemas.openxmlformats.org/presentationml/2006/main">
+  <p:cSld>
+    <p:spTree>
+      <p:nvGrpSpPr>
+        <p:cNvPr id="1" name="">
+          <a:extLst>
+            <a:ext uri="{FF2B5EF4-FFF2-40B4-BE49-F238E27FC236}">
+              <a16:creationId xmlns:a16="http://schemas.microsoft.com/office/drawing/2014/main" id="{A1488FE8-9096-3F9D-0AD8-D738AF06D9D8}"/>
+            </a:ext>
+          </a:extLst>
+        </p:cNvPr>
+        <p:cNvGrpSpPr/>
+        <p:nvPr/>
+      </p:nvGrpSpPr>
+      <p:grpSpPr>
+        <a:xfrm>
+          <a:off x="0" y="0"/>
+          <a:ext cx="0" cy="0"/>
+          <a:chOff x="0" y="0"/>
+          <a:chExt cx="0" cy="0"/>
+        </a:xfrm>
+      </p:grpSpPr>
+      <p:sp>
+        <p:nvSpPr>
+          <p:cNvPr id="2" name="Slide Image Placeholder 1">
+            <a:extLst>
+              <a:ext uri="{FF2B5EF4-FFF2-40B4-BE49-F238E27FC236}">
+                <a16:creationId xmlns:a16="http://schemas.microsoft.com/office/drawing/2014/main" id="{F4770454-ED59-2E9F-8B10-85C92C53B3E8}"/>
+              </a:ext>
+            </a:extLst>
+          </p:cNvPr>
+          <p:cNvSpPr>
+            <a:spLocks noGrp="1" noRot="1" noChangeAspect="1"/>
+          </p:cNvSpPr>
+          <p:nvPr>
+            <p:ph type="sldImg"/>
+          </p:nvPr>
+        </p:nvSpPr>
+        <p:spPr/>
+      </p:sp>
+      <p:sp>
+        <p:nvSpPr>
+          <p:cNvPr id="3" name="Notes Placeholder 2">
+            <a:extLst>
+              <a:ext uri="{FF2B5EF4-FFF2-40B4-BE49-F238E27FC236}">
+                <a16:creationId xmlns:a16="http://schemas.microsoft.com/office/drawing/2014/main" id="{02701745-9926-4BE3-3718-04406A103AB6}"/>
+              </a:ext>
+            </a:extLst>
+          </p:cNvPr>
+          <p:cNvSpPr>
+            <a:spLocks noGrp="1"/>
+          </p:cNvSpPr>
+          <p:nvPr>
+            <p:ph type="body" idx="1"/>
+          </p:nvPr>
+        </p:nvSpPr>
+        <p:spPr/>
+        <p:txBody>
+          <a:bodyPr/>
+          <a:lstStyle/>
+          <a:p>
+            <a:endParaRPr lang="en-US"/>
+          </a:p>
+        </p:txBody>
+      </p:sp>
+      <p:sp>
+        <p:nvSpPr>
+          <p:cNvPr id="4" name="Slide Number Placeholder 3">
+            <a:extLst>
+              <a:ext uri="{FF2B5EF4-FFF2-40B4-BE49-F238E27FC236}">
+                <a16:creationId xmlns:a16="http://schemas.microsoft.com/office/drawing/2014/main" id="{660726FF-1DF4-4CB8-4FE4-47C34025E872}"/>
+              </a:ext>
+            </a:extLst>
+          </p:cNvPr>
+          <p:cNvSpPr>
+            <a:spLocks noGrp="1"/>
+          </p:cNvSpPr>
+          <p:nvPr>
+            <p:ph type="sldNum" sz="quarter" idx="5"/>
+          </p:nvPr>
+        </p:nvSpPr>
+        <p:spPr/>
+        <p:txBody>
+          <a:bodyPr/>
+          <a:lstStyle/>
+          <a:p>
+            <a:fld id="{14DFF4C2-74DA-1D46-B541-49BD0013B7E1}" type="slidenum">
+              <a:rPr lang="en-DE" smtClean="0"/>
+              <a:t>21</a:t>
+            </a:fld>
+            <a:endParaRPr lang="en-DE"/>
+          </a:p>
+        </p:txBody>
+      </p:sp>
+    </p:spTree>
+    <p:extLst>
+      <p:ext uri="{BB962C8B-B14F-4D97-AF65-F5344CB8AC3E}">
+        <p14:creationId xmlns:p14="http://schemas.microsoft.com/office/powerpoint/2010/main" val="2748348097"/>
+      </p:ext>
+    </p:extLst>
+  </p:cSld>
+  <p:clrMapOvr>
+    <a:masterClrMapping/>
+  </p:clrMapOvr>
+</p:notes>
+</file>
+
+<file path=ppt/notesSlides/notesSlide21.xml><?xml version="1.0" encoding="utf-8"?>
+<p:notes xmlns:a="http://schemas.openxmlformats.org/drawingml/2006/main" xmlns:r="http://schemas.openxmlformats.org/officeDocument/2006/relationships" xmlns:p="http://schemas.openxmlformats.org/presentationml/2006/main">
+  <p:cSld>
+    <p:spTree>
+      <p:nvGrpSpPr>
+        <p:cNvPr id="1" name="">
+          <a:extLst>
+            <a:ext uri="{FF2B5EF4-FFF2-40B4-BE49-F238E27FC236}">
+              <a16:creationId xmlns:a16="http://schemas.microsoft.com/office/drawing/2014/main" id="{D35DB483-F0DD-CAAD-1AE9-2E99563B6F61}"/>
+            </a:ext>
+          </a:extLst>
+        </p:cNvPr>
+        <p:cNvGrpSpPr/>
+        <p:nvPr/>
+      </p:nvGrpSpPr>
+      <p:grpSpPr>
+        <a:xfrm>
+          <a:off x="0" y="0"/>
+          <a:ext cx="0" cy="0"/>
+          <a:chOff x="0" y="0"/>
+          <a:chExt cx="0" cy="0"/>
+        </a:xfrm>
+      </p:grpSpPr>
+      <p:sp>
+        <p:nvSpPr>
+          <p:cNvPr id="2" name="Slide Image Placeholder 1">
+            <a:extLst>
+              <a:ext uri="{FF2B5EF4-FFF2-40B4-BE49-F238E27FC236}">
+                <a16:creationId xmlns:a16="http://schemas.microsoft.com/office/drawing/2014/main" id="{5B7392D1-6828-B8FF-15A7-A9FF9A6809D9}"/>
+              </a:ext>
+            </a:extLst>
+          </p:cNvPr>
+          <p:cNvSpPr>
+            <a:spLocks noGrp="1" noRot="1" noChangeAspect="1"/>
+          </p:cNvSpPr>
+          <p:nvPr>
+            <p:ph type="sldImg"/>
+          </p:nvPr>
+        </p:nvSpPr>
+        <p:spPr/>
+      </p:sp>
+      <p:sp>
+        <p:nvSpPr>
+          <p:cNvPr id="3" name="Notes Placeholder 2">
+            <a:extLst>
+              <a:ext uri="{FF2B5EF4-FFF2-40B4-BE49-F238E27FC236}">
+                <a16:creationId xmlns:a16="http://schemas.microsoft.com/office/drawing/2014/main" id="{17591823-798B-92BD-02E3-3FD06E8F7A19}"/>
+              </a:ext>
+            </a:extLst>
+          </p:cNvPr>
+          <p:cNvSpPr>
+            <a:spLocks noGrp="1"/>
+          </p:cNvSpPr>
+          <p:nvPr>
+            <p:ph type="body" idx="1"/>
+          </p:nvPr>
+        </p:nvSpPr>
+        <p:spPr/>
+        <p:txBody>
+          <a:bodyPr/>
+          <a:lstStyle/>
+          <a:p>
+            <a:endParaRPr lang="en-US"/>
+          </a:p>
+        </p:txBody>
+      </p:sp>
+      <p:sp>
+        <p:nvSpPr>
+          <p:cNvPr id="4" name="Slide Number Placeholder 3">
+            <a:extLst>
+              <a:ext uri="{FF2B5EF4-FFF2-40B4-BE49-F238E27FC236}">
+                <a16:creationId xmlns:a16="http://schemas.microsoft.com/office/drawing/2014/main" id="{33E130D7-6E61-A9E2-51F0-0FC48A55A7FC}"/>
+              </a:ext>
+            </a:extLst>
+          </p:cNvPr>
+          <p:cNvSpPr>
+            <a:spLocks noGrp="1"/>
+          </p:cNvSpPr>
+          <p:nvPr>
+            <p:ph type="sldNum" sz="quarter" idx="5"/>
+          </p:nvPr>
+        </p:nvSpPr>
+        <p:spPr/>
+        <p:txBody>
+          <a:bodyPr/>
+          <a:lstStyle/>
+          <a:p>
+            <a:fld id="{14DFF4C2-74DA-1D46-B541-49BD0013B7E1}" type="slidenum">
+              <a:rPr lang="en-DE" smtClean="0"/>
+              <a:t>22</a:t>
+            </a:fld>
+            <a:endParaRPr lang="en-DE"/>
+          </a:p>
+        </p:txBody>
+      </p:sp>
+    </p:spTree>
+    <p:extLst>
+      <p:ext uri="{BB962C8B-B14F-4D97-AF65-F5344CB8AC3E}">
+        <p14:creationId xmlns:p14="http://schemas.microsoft.com/office/powerpoint/2010/main" val="1481125936"/>
+      </p:ext>
+    </p:extLst>
+  </p:cSld>
+  <p:clrMapOvr>
+    <a:masterClrMapping/>
+  </p:clrMapOvr>
+</p:notes>
+</file>
+
+<file path=ppt/notesSlides/notesSlide22.xml><?xml version="1.0" encoding="utf-8"?>
+<p:notes xmlns:a="http://schemas.openxmlformats.org/drawingml/2006/main" xmlns:r="http://schemas.openxmlformats.org/officeDocument/2006/relationships" xmlns:p="http://schemas.openxmlformats.org/presentationml/2006/main">
+  <p:cSld>
+    <p:spTree>
+      <p:nvGrpSpPr>
+        <p:cNvPr id="1" name="">
+          <a:extLst>
+            <a:ext uri="{FF2B5EF4-FFF2-40B4-BE49-F238E27FC236}">
+              <a16:creationId xmlns:a16="http://schemas.microsoft.com/office/drawing/2014/main" id="{36997820-0E60-5FC7-C1D3-A47CD9B2FAF5}"/>
+            </a:ext>
+          </a:extLst>
+        </p:cNvPr>
+        <p:cNvGrpSpPr/>
+        <p:nvPr/>
+      </p:nvGrpSpPr>
+      <p:grpSpPr>
+        <a:xfrm>
+          <a:off x="0" y="0"/>
+          <a:ext cx="0" cy="0"/>
+          <a:chOff x="0" y="0"/>
+          <a:chExt cx="0" cy="0"/>
+        </a:xfrm>
+      </p:grpSpPr>
+      <p:sp>
+        <p:nvSpPr>
+          <p:cNvPr id="2" name="Slide Image Placeholder 1">
+            <a:extLst>
+              <a:ext uri="{FF2B5EF4-FFF2-40B4-BE49-F238E27FC236}">
+                <a16:creationId xmlns:a16="http://schemas.microsoft.com/office/drawing/2014/main" id="{5D054A38-54FD-ADC5-0A5B-FE96D496E353}"/>
+              </a:ext>
+            </a:extLst>
+          </p:cNvPr>
+          <p:cNvSpPr>
+            <a:spLocks noGrp="1" noRot="1" noChangeAspect="1"/>
+          </p:cNvSpPr>
+          <p:nvPr>
+            <p:ph type="sldImg"/>
+          </p:nvPr>
+        </p:nvSpPr>
+        <p:spPr/>
+      </p:sp>
+      <p:sp>
+        <p:nvSpPr>
+          <p:cNvPr id="3" name="Notes Placeholder 2">
+            <a:extLst>
+              <a:ext uri="{FF2B5EF4-FFF2-40B4-BE49-F238E27FC236}">
+                <a16:creationId xmlns:a16="http://schemas.microsoft.com/office/drawing/2014/main" id="{7B8988FE-4A3C-A09C-772D-A76145B3FC44}"/>
+              </a:ext>
+            </a:extLst>
+          </p:cNvPr>
+          <p:cNvSpPr>
+            <a:spLocks noGrp="1"/>
+          </p:cNvSpPr>
+          <p:nvPr>
+            <p:ph type="body" idx="1"/>
+          </p:nvPr>
+        </p:nvSpPr>
+        <p:spPr/>
+        <p:txBody>
+          <a:bodyPr/>
+          <a:lstStyle/>
+          <a:p>
+            <a:endParaRPr lang="en-US"/>
+          </a:p>
+        </p:txBody>
+      </p:sp>
+      <p:sp>
+        <p:nvSpPr>
+          <p:cNvPr id="4" name="Slide Number Placeholder 3">
+            <a:extLst>
+              <a:ext uri="{FF2B5EF4-FFF2-40B4-BE49-F238E27FC236}">
+                <a16:creationId xmlns:a16="http://schemas.microsoft.com/office/drawing/2014/main" id="{9C2192A5-301A-4EE7-408E-62FED5211589}"/>
+              </a:ext>
+            </a:extLst>
+          </p:cNvPr>
+          <p:cNvSpPr>
+            <a:spLocks noGrp="1"/>
+          </p:cNvSpPr>
+          <p:nvPr>
+            <p:ph type="sldNum" sz="quarter" idx="5"/>
+          </p:nvPr>
+        </p:nvSpPr>
+        <p:spPr/>
+        <p:txBody>
+          <a:bodyPr/>
+          <a:lstStyle/>
+          <a:p>
+            <a:fld id="{14DFF4C2-74DA-1D46-B541-49BD0013B7E1}" type="slidenum">
+              <a:rPr lang="en-DE" smtClean="0"/>
+              <a:t>23</a:t>
+            </a:fld>
+            <a:endParaRPr lang="en-DE"/>
+          </a:p>
+        </p:txBody>
+      </p:sp>
+    </p:spTree>
+    <p:extLst>
+      <p:ext uri="{BB962C8B-B14F-4D97-AF65-F5344CB8AC3E}">
+        <p14:creationId xmlns:p14="http://schemas.microsoft.com/office/powerpoint/2010/main" val="1131764490"/>
+      </p:ext>
+    </p:extLst>
+  </p:cSld>
+  <p:clrMapOvr>
+    <a:masterClrMapping/>
+  </p:clrMapOvr>
+</p:notes>
+</file>
+
+<file path=ppt/notesSlides/notesSlide23.xml><?xml version="1.0" encoding="utf-8"?>
+<p:notes xmlns:a="http://schemas.openxmlformats.org/drawingml/2006/main" xmlns:r="http://schemas.openxmlformats.org/officeDocument/2006/relationships" xmlns:p="http://schemas.openxmlformats.org/presentationml/2006/main">
+  <p:cSld>
+    <p:spTree>
+      <p:nvGrpSpPr>
+        <p:cNvPr id="1" name="">
+          <a:extLst>
+            <a:ext uri="{FF2B5EF4-FFF2-40B4-BE49-F238E27FC236}">
+              <a16:creationId xmlns:a16="http://schemas.microsoft.com/office/drawing/2014/main" id="{DE2F4772-1095-EB7D-1B60-C1B55B525B53}"/>
+            </a:ext>
+          </a:extLst>
+        </p:cNvPr>
+        <p:cNvGrpSpPr/>
+        <p:nvPr/>
+      </p:nvGrpSpPr>
+      <p:grpSpPr>
+        <a:xfrm>
+          <a:off x="0" y="0"/>
+          <a:ext cx="0" cy="0"/>
+          <a:chOff x="0" y="0"/>
+          <a:chExt cx="0" cy="0"/>
+        </a:xfrm>
+      </p:grpSpPr>
+      <p:sp>
+        <p:nvSpPr>
+          <p:cNvPr id="2" name="Slide Image Placeholder 1">
+            <a:extLst>
+              <a:ext uri="{FF2B5EF4-FFF2-40B4-BE49-F238E27FC236}">
+                <a16:creationId xmlns:a16="http://schemas.microsoft.com/office/drawing/2014/main" id="{1280DC35-9B36-B3BA-DBEC-77CC28308E44}"/>
+              </a:ext>
+            </a:extLst>
+          </p:cNvPr>
+          <p:cNvSpPr>
+            <a:spLocks noGrp="1" noRot="1" noChangeAspect="1"/>
+          </p:cNvSpPr>
+          <p:nvPr>
+            <p:ph type="sldImg"/>
+          </p:nvPr>
+        </p:nvSpPr>
+        <p:spPr/>
+      </p:sp>
+      <p:sp>
+        <p:nvSpPr>
+          <p:cNvPr id="3" name="Notes Placeholder 2">
+            <a:extLst>
+              <a:ext uri="{FF2B5EF4-FFF2-40B4-BE49-F238E27FC236}">
+                <a16:creationId xmlns:a16="http://schemas.microsoft.com/office/drawing/2014/main" id="{FDBF8A17-C8A4-E1D3-FE22-EDBBA79E9E51}"/>
+              </a:ext>
+            </a:extLst>
+          </p:cNvPr>
+          <p:cNvSpPr>
+            <a:spLocks noGrp="1"/>
+          </p:cNvSpPr>
+          <p:nvPr>
+            <p:ph type="body" idx="1"/>
+          </p:nvPr>
+        </p:nvSpPr>
+        <p:spPr/>
+        <p:txBody>
+          <a:bodyPr/>
+          <a:lstStyle/>
+          <a:p>
+            <a:endParaRPr lang="en-US"/>
+          </a:p>
+        </p:txBody>
+      </p:sp>
+      <p:sp>
+        <p:nvSpPr>
+          <p:cNvPr id="4" name="Slide Number Placeholder 3">
+            <a:extLst>
+              <a:ext uri="{FF2B5EF4-FFF2-40B4-BE49-F238E27FC236}">
+                <a16:creationId xmlns:a16="http://schemas.microsoft.com/office/drawing/2014/main" id="{18055A52-AE36-EA78-828C-15E9087998E3}"/>
+              </a:ext>
+            </a:extLst>
+          </p:cNvPr>
+          <p:cNvSpPr>
+            <a:spLocks noGrp="1"/>
+          </p:cNvSpPr>
+          <p:nvPr>
+            <p:ph type="sldNum" sz="quarter" idx="5"/>
+          </p:nvPr>
+        </p:nvSpPr>
+        <p:spPr/>
+        <p:txBody>
+          <a:bodyPr/>
+          <a:lstStyle/>
+          <a:p>
+            <a:fld id="{14DFF4C2-74DA-1D46-B541-49BD0013B7E1}" type="slidenum">
+              <a:rPr lang="en-DE" smtClean="0"/>
+              <a:t>24</a:t>
+            </a:fld>
+            <a:endParaRPr lang="en-DE"/>
+          </a:p>
+        </p:txBody>
+      </p:sp>
+    </p:spTree>
+    <p:extLst>
+      <p:ext uri="{BB962C8B-B14F-4D97-AF65-F5344CB8AC3E}">
+        <p14:creationId xmlns:p14="http://schemas.microsoft.com/office/powerpoint/2010/main" val="2377946407"/>
+      </p:ext>
+    </p:extLst>
+  </p:cSld>
+  <p:clrMapOvr>
+    <a:masterClrMapping/>
+  </p:clrMapOvr>
+</p:notes>
+</file>
+
+<file path=ppt/notesSlides/notesSlide24.xml><?xml version="1.0" encoding="utf-8"?>
+<p:notes xmlns:a="http://schemas.openxmlformats.org/drawingml/2006/main" xmlns:r="http://schemas.openxmlformats.org/officeDocument/2006/relationships" xmlns:p="http://schemas.openxmlformats.org/presentationml/2006/main">
+  <p:cSld>
+    <p:spTree>
+      <p:nvGrpSpPr>
+        <p:cNvPr id="1" name="">
+          <a:extLst>
+            <a:ext uri="{FF2B5EF4-FFF2-40B4-BE49-F238E27FC236}">
+              <a16:creationId xmlns:a16="http://schemas.microsoft.com/office/drawing/2014/main" id="{25D21303-75DB-1CB6-191E-8F5851FAF3D2}"/>
+            </a:ext>
+          </a:extLst>
+        </p:cNvPr>
+        <p:cNvGrpSpPr/>
+        <p:nvPr/>
+      </p:nvGrpSpPr>
+      <p:grpSpPr>
+        <a:xfrm>
+          <a:off x="0" y="0"/>
+          <a:ext cx="0" cy="0"/>
+          <a:chOff x="0" y="0"/>
+          <a:chExt cx="0" cy="0"/>
+        </a:xfrm>
+      </p:grpSpPr>
+      <p:sp>
+        <p:nvSpPr>
+          <p:cNvPr id="2" name="Slide Image Placeholder 1">
+            <a:extLst>
+              <a:ext uri="{FF2B5EF4-FFF2-40B4-BE49-F238E27FC236}">
+                <a16:creationId xmlns:a16="http://schemas.microsoft.com/office/drawing/2014/main" id="{600F60FC-C7F0-3C27-A7F3-49E11FFCD478}"/>
+              </a:ext>
+            </a:extLst>
+          </p:cNvPr>
+          <p:cNvSpPr>
+            <a:spLocks noGrp="1" noRot="1" noChangeAspect="1"/>
+          </p:cNvSpPr>
+          <p:nvPr>
+            <p:ph type="sldImg"/>
+          </p:nvPr>
+        </p:nvSpPr>
+        <p:spPr/>
+      </p:sp>
+      <p:sp>
+        <p:nvSpPr>
+          <p:cNvPr id="3" name="Notes Placeholder 2">
+            <a:extLst>
+              <a:ext uri="{FF2B5EF4-FFF2-40B4-BE49-F238E27FC236}">
+                <a16:creationId xmlns:a16="http://schemas.microsoft.com/office/drawing/2014/main" id="{2F412707-4C7C-6645-940A-6D693CFF4485}"/>
+              </a:ext>
+            </a:extLst>
+          </p:cNvPr>
+          <p:cNvSpPr>
+            <a:spLocks noGrp="1"/>
+          </p:cNvSpPr>
+          <p:nvPr>
+            <p:ph type="body" idx="1"/>
+          </p:nvPr>
+        </p:nvSpPr>
+        <p:spPr/>
+        <p:txBody>
+          <a:bodyPr/>
+          <a:lstStyle/>
+          <a:p>
+            <a:endParaRPr lang="en-US"/>
+          </a:p>
+        </p:txBody>
+      </p:sp>
+      <p:sp>
+        <p:nvSpPr>
+          <p:cNvPr id="4" name="Slide Number Placeholder 3">
+            <a:extLst>
+              <a:ext uri="{FF2B5EF4-FFF2-40B4-BE49-F238E27FC236}">
+                <a16:creationId xmlns:a16="http://schemas.microsoft.com/office/drawing/2014/main" id="{7D225197-1619-13C2-127F-7B367D434F45}"/>
+              </a:ext>
+            </a:extLst>
+          </p:cNvPr>
+          <p:cNvSpPr>
+            <a:spLocks noGrp="1"/>
+          </p:cNvSpPr>
+          <p:nvPr>
+            <p:ph type="sldNum" sz="quarter" idx="5"/>
+          </p:nvPr>
+        </p:nvSpPr>
+        <p:spPr/>
+        <p:txBody>
+          <a:bodyPr/>
+          <a:lstStyle/>
+          <a:p>
+            <a:fld id="{14DFF4C2-74DA-1D46-B541-49BD0013B7E1}" type="slidenum">
+              <a:rPr lang="en-DE" smtClean="0"/>
+              <a:t>25</a:t>
+            </a:fld>
+            <a:endParaRPr lang="en-DE"/>
+          </a:p>
+        </p:txBody>
+      </p:sp>
+    </p:spTree>
+    <p:extLst>
+      <p:ext uri="{BB962C8B-B14F-4D97-AF65-F5344CB8AC3E}">
+        <p14:creationId xmlns:p14="http://schemas.microsoft.com/office/powerpoint/2010/main" val="1901104202"/>
       </p:ext>
     </p:extLst>
   </p:cSld>
@@ -2608,7 +3371,7 @@
           <a:p>
             <a:fld id="{6473CF59-A18C-4D57-9490-8821DC8785C9}" type="datetimeFigureOut">
               <a:rPr lang="en-US" smtClean="0"/>
-              <a:t>9/14/2026</a:t>
+              <a:t>9/15/2026</a:t>
             </a:fld>
             <a:endParaRPr lang="en-US"/>
           </a:p>
@@ -2806,7 +3569,7 @@
           <a:p>
             <a:fld id="{6473CF59-A18C-4D57-9490-8821DC8785C9}" type="datetimeFigureOut">
               <a:rPr lang="en-US" smtClean="0"/>
-              <a:t>9/14/2026</a:t>
+              <a:t>9/15/2026</a:t>
             </a:fld>
             <a:endParaRPr lang="en-US"/>
           </a:p>
@@ -3014,7 +3777,7 @@
           <a:p>
             <a:fld id="{6473CF59-A18C-4D57-9490-8821DC8785C9}" type="datetimeFigureOut">
               <a:rPr lang="en-US" smtClean="0"/>
-              <a:t>9/14/2026</a:t>
+              <a:t>9/15/2026</a:t>
             </a:fld>
             <a:endParaRPr lang="en-US"/>
           </a:p>
@@ -4036,7 +4799,7 @@
           <a:p>
             <a:fld id="{6473CF59-A18C-4D57-9490-8821DC8785C9}" type="datetimeFigureOut">
               <a:rPr lang="en-US" smtClean="0"/>
-              <a:t>9/14/2026</a:t>
+              <a:t>9/15/2026</a:t>
             </a:fld>
             <a:endParaRPr lang="en-US"/>
           </a:p>
@@ -4311,7 +5074,7 @@
           <a:p>
             <a:fld id="{6473CF59-A18C-4D57-9490-8821DC8785C9}" type="datetimeFigureOut">
               <a:rPr lang="en-US" smtClean="0"/>
-              <a:t>9/14/2026</a:t>
+              <a:t>9/15/2026</a:t>
             </a:fld>
             <a:endParaRPr lang="en-US"/>
           </a:p>
@@ -4576,7 +5339,7 @@
           <a:p>
             <a:fld id="{6473CF59-A18C-4D57-9490-8821DC8785C9}" type="datetimeFigureOut">
               <a:rPr lang="en-US" smtClean="0"/>
-              <a:t>9/14/2026</a:t>
+              <a:t>9/15/2026</a:t>
             </a:fld>
             <a:endParaRPr lang="en-US"/>
           </a:p>
@@ -4988,7 +5751,7 @@
           <a:p>
             <a:fld id="{6473CF59-A18C-4D57-9490-8821DC8785C9}" type="datetimeFigureOut">
               <a:rPr lang="en-US" smtClean="0"/>
-              <a:t>9/14/2026</a:t>
+              <a:t>9/15/2026</a:t>
             </a:fld>
             <a:endParaRPr lang="en-US"/>
           </a:p>
@@ -5129,7 +5892,7 @@
           <a:p>
             <a:fld id="{6473CF59-A18C-4D57-9490-8821DC8785C9}" type="datetimeFigureOut">
               <a:rPr lang="en-US" smtClean="0"/>
-              <a:t>9/14/2026</a:t>
+              <a:t>9/15/2026</a:t>
             </a:fld>
             <a:endParaRPr lang="en-US"/>
           </a:p>
@@ -5242,7 +6005,7 @@
           <a:p>
             <a:fld id="{6473CF59-A18C-4D57-9490-8821DC8785C9}" type="datetimeFigureOut">
               <a:rPr lang="en-US" smtClean="0"/>
-              <a:t>9/14/2026</a:t>
+              <a:t>9/15/2026</a:t>
             </a:fld>
             <a:endParaRPr lang="en-US"/>
           </a:p>
@@ -5553,7 +6316,7 @@
           <a:p>
             <a:fld id="{6473CF59-A18C-4D57-9490-8821DC8785C9}" type="datetimeFigureOut">
               <a:rPr lang="en-US" smtClean="0"/>
-              <a:t>9/14/2026</a:t>
+              <a:t>9/15/2026</a:t>
             </a:fld>
             <a:endParaRPr lang="en-US"/>
           </a:p>
@@ -5841,7 +6604,7 @@
           <a:p>
             <a:fld id="{6473CF59-A18C-4D57-9490-8821DC8785C9}" type="datetimeFigureOut">
               <a:rPr lang="en-US" smtClean="0"/>
-              <a:t>9/14/2026</a:t>
+              <a:t>9/15/2026</a:t>
             </a:fld>
             <a:endParaRPr lang="en-US"/>
           </a:p>
@@ -6082,7 +6845,7 @@
           <a:p>
             <a:fld id="{6473CF59-A18C-4D57-9490-8821DC8785C9}" type="datetimeFigureOut">
               <a:rPr lang="en-US" smtClean="0"/>
-              <a:t>9/14/2026</a:t>
+              <a:t>9/15/2026</a:t>
             </a:fld>
             <a:endParaRPr lang="en-US"/>
           </a:p>
@@ -8740,7 +9503,7 @@
             </a:r>
             <a:r>
               <a:rPr lang="en-IN" dirty="0"/>
-              <a:t> September 2027</a:t>
+              <a:t> September 2026</a:t>
             </a:r>
           </a:p>
         </p:txBody>
@@ -8769,7 +9532,7 @@
         </p:spPr>
         <p:txBody>
           <a:bodyPr>
-            <a:normAutofit/>
+            <a:normAutofit fontScale="92500" lnSpcReduction="10000"/>
           </a:bodyPr>
           <a:lstStyle/>
           <a:p>
@@ -8789,7 +9552,7 @@
             </a:pPr>
             <a:r>
               <a:rPr lang="en-GB" sz="2400" b="1" dirty="0"/>
-              <a:t>Agentic Capabilities:</a:t>
+              <a:t>Autonomous Tool Selection</a:t>
             </a:r>
           </a:p>
           <a:p>
@@ -8799,7 +9562,7 @@
             </a:pPr>
             <a:r>
               <a:rPr lang="en-GB" sz="2400" b="1" dirty="0"/>
-              <a:t>Autonomous Tool Selection</a:t>
+              <a:t>Context aware follow up reasoning</a:t>
             </a:r>
           </a:p>
           <a:p>
@@ -8809,7 +9572,7 @@
             </a:pPr>
             <a:r>
               <a:rPr lang="en-GB" sz="2400" b="1" dirty="0"/>
-              <a:t>Context aware follow up reasoning</a:t>
+              <a:t>Test in 50 curated queries</a:t>
             </a:r>
           </a:p>
           <a:p>
@@ -8819,7 +9582,7 @@
             </a:pPr>
             <a:r>
               <a:rPr lang="en-GB" sz="2400" b="1" dirty="0"/>
-              <a:t>Addition of tools as capabilities</a:t>
+              <a:t>Enhanced prompting/instruction tuning</a:t>
             </a:r>
           </a:p>
           <a:p>
@@ -8827,16 +9590,54 @@
               <a:buFont typeface="Arial" panose="020B0604020202020204" pitchFamily="34" charset="0"/>
               <a:buChar char="•"/>
             </a:pPr>
-            <a:r>
-              <a:rPr lang="en-GB" sz="2400" b="1" dirty="0"/>
-              <a:t>Multilingual support</a:t>
-            </a:r>
-          </a:p>
-          <a:p>
-            <a:pPr>
-              <a:buFont typeface="Arial" panose="020B0604020202020204" pitchFamily="34" charset="0"/>
-              <a:buChar char="•"/>
-            </a:pPr>
+            <a:endParaRPr lang="en-GB" sz="2400" b="1" dirty="0"/>
+          </a:p>
+          <a:p>
+            <a:pPr marL="0" indent="0"/>
+            <a:r>
+              <a:rPr lang="en-US" sz="2000" b="1" dirty="0"/>
+              <a:t>Policy-aware mathematical execution (PSC): </a:t>
+            </a:r>
+            <a:r>
+              <a:rPr lang="en-US" sz="2000" dirty="0"/>
+              <a:t>PCA, MBA, and SAA policies they are executed through deterministic Python policy logic and feed to the Mistral Agent</a:t>
+            </a:r>
+          </a:p>
+          <a:p>
+            <a:pPr marL="0" indent="0"/>
+            <a:r>
+              <a:rPr lang="en-US" sz="2000" b="1" dirty="0"/>
+              <a:t>What-if policy simulation: </a:t>
+            </a:r>
+            <a:r>
+              <a:rPr lang="en-US" sz="2000" dirty="0"/>
+              <a:t>operators can ask counterfactual questions such as changing SC constraints or replaying a policy at a timestamp. </a:t>
+            </a:r>
+          </a:p>
+          <a:p>
+            <a:pPr marL="0" indent="0"/>
+            <a:r>
+              <a:rPr lang="en-US" sz="2000" b="1" dirty="0"/>
+              <a:t>Constraint-aware allocation analysis: </a:t>
+            </a:r>
+            <a:r>
+              <a:rPr lang="en-US" sz="2000" dirty="0"/>
+              <a:t>the system can evaluate hard operator constraints, e.g. reserving SCs for PON/RAN, and recompute feasible allocations. </a:t>
+            </a:r>
+          </a:p>
+          <a:p>
+            <a:pPr marL="0" indent="0"/>
+            <a:r>
+              <a:rPr lang="en-US" sz="2000" b="1" dirty="0"/>
+              <a:t>LLM + deterministic split: </a:t>
+            </a:r>
+            <a:r>
+              <a:rPr lang="en-US" sz="2000" dirty="0"/>
+              <a:t>Mistral decides the intent/tool, while Python performs the traffic, SLA, policy, blocking, and reconfiguration calculations.</a:t>
+            </a:r>
+          </a:p>
+          <a:p>
+            <a:pPr marL="0" indent="0"/>
             <a:endParaRPr lang="en-GB" sz="2000" dirty="0"/>
           </a:p>
           <a:p>
@@ -8918,6 +9719,487 @@
 </file>
 
 <file path=ppt/slides/slide16.xml><?xml version="1.0" encoding="utf-8"?>
+<p:sld xmlns:a="http://schemas.openxmlformats.org/drawingml/2006/main" xmlns:r="http://schemas.openxmlformats.org/officeDocument/2006/relationships" xmlns:p="http://schemas.openxmlformats.org/presentationml/2006/main">
+  <p:cSld>
+    <p:spTree>
+      <p:nvGrpSpPr>
+        <p:cNvPr id="1" name="">
+          <a:extLst>
+            <a:ext uri="{FF2B5EF4-FFF2-40B4-BE49-F238E27FC236}">
+              <a16:creationId xmlns:a16="http://schemas.microsoft.com/office/drawing/2014/main" id="{157E0F60-7DB2-A524-3130-F0CB58CF6687}"/>
+            </a:ext>
+          </a:extLst>
+        </p:cNvPr>
+        <p:cNvGrpSpPr/>
+        <p:nvPr/>
+      </p:nvGrpSpPr>
+      <p:grpSpPr>
+        <a:xfrm>
+          <a:off x="0" y="0"/>
+          <a:ext cx="0" cy="0"/>
+          <a:chOff x="0" y="0"/>
+          <a:chExt cx="0" cy="0"/>
+        </a:xfrm>
+      </p:grpSpPr>
+      <p:sp>
+        <p:nvSpPr>
+          <p:cNvPr id="2" name="Title 1">
+            <a:extLst>
+              <a:ext uri="{FF2B5EF4-FFF2-40B4-BE49-F238E27FC236}">
+                <a16:creationId xmlns:a16="http://schemas.microsoft.com/office/drawing/2014/main" id="{DB9E9A5A-D0B1-E37E-B502-9D3508E80D4C}"/>
+              </a:ext>
+            </a:extLst>
+          </p:cNvPr>
+          <p:cNvSpPr>
+            <a:spLocks noGrp="1"/>
+          </p:cNvSpPr>
+          <p:nvPr>
+            <p:ph type="title"/>
+          </p:nvPr>
+        </p:nvSpPr>
+        <p:spPr>
+          <a:xfrm>
+            <a:off x="305555" y="0"/>
+            <a:ext cx="11885653" cy="838800"/>
+          </a:xfrm>
+        </p:spPr>
+        <p:txBody>
+          <a:bodyPr anchor="ctr">
+            <a:normAutofit/>
+          </a:bodyPr>
+          <a:lstStyle/>
+          <a:p>
+            <a:r>
+              <a:rPr lang="en-IN" dirty="0"/>
+              <a:t>architecture</a:t>
+            </a:r>
+          </a:p>
+        </p:txBody>
+      </p:sp>
+      <p:sp>
+        <p:nvSpPr>
+          <p:cNvPr id="3" name="Content Placeholder 2">
+            <a:extLst>
+              <a:ext uri="{FF2B5EF4-FFF2-40B4-BE49-F238E27FC236}">
+                <a16:creationId xmlns:a16="http://schemas.microsoft.com/office/drawing/2014/main" id="{F9581DDF-97C1-2CFB-FF1A-79C5E9EC6DC8}"/>
+              </a:ext>
+            </a:extLst>
+          </p:cNvPr>
+          <p:cNvSpPr>
+            <a:spLocks noGrp="1"/>
+          </p:cNvSpPr>
+          <p:nvPr>
+            <p:ph sz="quarter" idx="10"/>
+          </p:nvPr>
+        </p:nvSpPr>
+        <p:spPr>
+          <a:xfrm>
+            <a:off x="387580" y="752388"/>
+            <a:ext cx="11426771" cy="4813793"/>
+          </a:xfrm>
+        </p:spPr>
+        <p:txBody>
+          <a:bodyPr>
+            <a:normAutofit/>
+          </a:bodyPr>
+          <a:lstStyle/>
+          <a:p>
+            <a:pPr marL="457200" lvl="1" indent="0">
+              <a:buNone/>
+            </a:pPr>
+            <a:endParaRPr lang="en-US" sz="1100" dirty="0"/>
+          </a:p>
+          <a:p>
+            <a:pPr marL="800100" lvl="1" indent="-342900"/>
+            <a:endParaRPr lang="en-US" sz="1100" i="1" dirty="0"/>
+          </a:p>
+          <a:p>
+            <a:pPr marL="0" indent="0"/>
+            <a:endParaRPr lang="en-GB" sz="2000" dirty="0"/>
+          </a:p>
+          <a:p>
+            <a:pPr marL="457200" lvl="1" indent="0">
+              <a:buNone/>
+            </a:pPr>
+            <a:endParaRPr lang="en-GB" sz="2000" dirty="0"/>
+          </a:p>
+          <a:p>
+            <a:pPr>
+              <a:buFont typeface="Arial" panose="020B0604020202020204" pitchFamily="34" charset="0"/>
+              <a:buChar char="•"/>
+            </a:pPr>
+            <a:endParaRPr lang="en-US" sz="1100" i="1" dirty="0"/>
+          </a:p>
+          <a:p>
+            <a:endParaRPr lang="en-US" sz="1100" dirty="0"/>
+          </a:p>
+          <a:p>
+            <a:endParaRPr lang="en-US" sz="1100" dirty="0"/>
+          </a:p>
+          <a:p>
+            <a:endParaRPr lang="en-IN" sz="1100" dirty="0"/>
+          </a:p>
+        </p:txBody>
+      </p:sp>
+      <p:sp>
+        <p:nvSpPr>
+          <p:cNvPr id="7" name="TextBox 6">
+            <a:extLst>
+              <a:ext uri="{FF2B5EF4-FFF2-40B4-BE49-F238E27FC236}">
+                <a16:creationId xmlns:a16="http://schemas.microsoft.com/office/drawing/2014/main" id="{2943239E-FF82-60DC-344B-03F9449E45E4}"/>
+              </a:ext>
+            </a:extLst>
+          </p:cNvPr>
+          <p:cNvSpPr txBox="1"/>
+          <p:nvPr/>
+        </p:nvSpPr>
+        <p:spPr>
+          <a:xfrm>
+            <a:off x="8976320" y="2852936"/>
+            <a:ext cx="473206" cy="369332"/>
+          </a:xfrm>
+          <a:prstGeom prst="rect">
+            <a:avLst/>
+          </a:prstGeom>
+          <a:noFill/>
+        </p:spPr>
+        <p:txBody>
+          <a:bodyPr wrap="none" rtlCol="0">
+            <a:spAutoFit/>
+          </a:bodyPr>
+          <a:lstStyle/>
+          <a:p>
+            <a:pPr marL="285750" indent="-285750">
+              <a:buFont typeface="Wingdings" panose="05000000000000000000" pitchFamily="2" charset="2"/>
+              <a:buChar char="§"/>
+            </a:pPr>
+            <a:endParaRPr lang="en-US" err="1">
+              <a:solidFill>
+                <a:schemeClr val="accent2"/>
+              </a:solidFill>
+              <a:latin typeface="Montserrat" pitchFamily="2" charset="0"/>
+            </a:endParaRPr>
+          </a:p>
+        </p:txBody>
+      </p:sp>
+      <p:pic>
+        <p:nvPicPr>
+          <p:cNvPr id="23" name="Picture 22">
+            <a:extLst>
+              <a:ext uri="{FF2B5EF4-FFF2-40B4-BE49-F238E27FC236}">
+                <a16:creationId xmlns:a16="http://schemas.microsoft.com/office/drawing/2014/main" id="{B2A47DAF-B41E-CE4C-8B5C-E10467F6637E}"/>
+              </a:ext>
+            </a:extLst>
+          </p:cNvPr>
+          <p:cNvPicPr>
+            <a:picLocks noChangeAspect="1"/>
+          </p:cNvPicPr>
+          <p:nvPr/>
+        </p:nvPicPr>
+        <p:blipFill>
+          <a:blip r:embed="rId3"/>
+          <a:srcRect t="9601" b="6437"/>
+          <a:stretch>
+            <a:fillRect/>
+          </a:stretch>
+        </p:blipFill>
+        <p:spPr>
+          <a:xfrm>
+            <a:off x="98596" y="752389"/>
+            <a:ext cx="11885653" cy="5758140"/>
+          </a:xfrm>
+          <a:prstGeom prst="rect">
+            <a:avLst/>
+          </a:prstGeom>
+        </p:spPr>
+      </p:pic>
+    </p:spTree>
+    <p:extLst>
+      <p:ext uri="{BB962C8B-B14F-4D97-AF65-F5344CB8AC3E}">
+        <p14:creationId xmlns:p14="http://schemas.microsoft.com/office/powerpoint/2010/main" val="1670250028"/>
+      </p:ext>
+    </p:extLst>
+  </p:cSld>
+  <p:clrMapOvr>
+    <a:masterClrMapping/>
+  </p:clrMapOvr>
+</p:sld>
+</file>
+
+<file path=ppt/slides/slide17.xml><?xml version="1.0" encoding="utf-8"?>
+<p:sld xmlns:a="http://schemas.openxmlformats.org/drawingml/2006/main" xmlns:r="http://schemas.openxmlformats.org/officeDocument/2006/relationships" xmlns:p="http://schemas.openxmlformats.org/presentationml/2006/main">
+  <p:cSld>
+    <p:spTree>
+      <p:nvGrpSpPr>
+        <p:cNvPr id="1" name="">
+          <a:extLst>
+            <a:ext uri="{FF2B5EF4-FFF2-40B4-BE49-F238E27FC236}">
+              <a16:creationId xmlns:a16="http://schemas.microsoft.com/office/drawing/2014/main" id="{AFB98CCF-DDA2-DE97-04EE-052C781E9D60}"/>
+            </a:ext>
+          </a:extLst>
+        </p:cNvPr>
+        <p:cNvGrpSpPr/>
+        <p:nvPr/>
+      </p:nvGrpSpPr>
+      <p:grpSpPr>
+        <a:xfrm>
+          <a:off x="0" y="0"/>
+          <a:ext cx="0" cy="0"/>
+          <a:chOff x="0" y="0"/>
+          <a:chExt cx="0" cy="0"/>
+        </a:xfrm>
+      </p:grpSpPr>
+      <p:sp>
+        <p:nvSpPr>
+          <p:cNvPr id="2" name="Title 1">
+            <a:extLst>
+              <a:ext uri="{FF2B5EF4-FFF2-40B4-BE49-F238E27FC236}">
+                <a16:creationId xmlns:a16="http://schemas.microsoft.com/office/drawing/2014/main" id="{FB25FCD0-FE04-F011-6E89-5CAFB47742D5}"/>
+              </a:ext>
+            </a:extLst>
+          </p:cNvPr>
+          <p:cNvSpPr>
+            <a:spLocks noGrp="1"/>
+          </p:cNvSpPr>
+          <p:nvPr>
+            <p:ph type="title"/>
+          </p:nvPr>
+        </p:nvSpPr>
+        <p:spPr>
+          <a:xfrm>
+            <a:off x="305555" y="0"/>
+            <a:ext cx="11885653" cy="838800"/>
+          </a:xfrm>
+        </p:spPr>
+        <p:txBody>
+          <a:bodyPr anchor="ctr">
+            <a:normAutofit/>
+          </a:bodyPr>
+          <a:lstStyle/>
+          <a:p>
+            <a:r>
+              <a:rPr lang="en-IN" dirty="0"/>
+              <a:t>Explanation of risk scores</a:t>
+            </a:r>
+          </a:p>
+        </p:txBody>
+      </p:sp>
+      <p:sp>
+        <p:nvSpPr>
+          <p:cNvPr id="3" name="Content Placeholder 2">
+            <a:extLst>
+              <a:ext uri="{FF2B5EF4-FFF2-40B4-BE49-F238E27FC236}">
+                <a16:creationId xmlns:a16="http://schemas.microsoft.com/office/drawing/2014/main" id="{3664BD83-139B-1A52-A32F-5493E2838677}"/>
+              </a:ext>
+            </a:extLst>
+          </p:cNvPr>
+          <p:cNvSpPr>
+            <a:spLocks noGrp="1"/>
+          </p:cNvSpPr>
+          <p:nvPr>
+            <p:ph sz="quarter" idx="10"/>
+          </p:nvPr>
+        </p:nvSpPr>
+        <p:spPr>
+          <a:xfrm>
+            <a:off x="387580" y="752388"/>
+            <a:ext cx="11426771" cy="4813793"/>
+          </a:xfrm>
+        </p:spPr>
+        <p:txBody>
+          <a:bodyPr>
+            <a:normAutofit/>
+          </a:bodyPr>
+          <a:lstStyle/>
+          <a:p>
+            <a:pPr marL="457200" lvl="1" indent="0">
+              <a:buNone/>
+            </a:pPr>
+            <a:endParaRPr lang="en-US" sz="1100" dirty="0"/>
+          </a:p>
+          <a:p>
+            <a:pPr marL="0" indent="0"/>
+            <a:endParaRPr lang="en-GB" sz="2000" dirty="0"/>
+          </a:p>
+          <a:p>
+            <a:pPr marL="457200" lvl="1" indent="0">
+              <a:buNone/>
+            </a:pPr>
+            <a:r>
+              <a:rPr lang="en-GB" sz="2000" dirty="0"/>
+              <a:t>Risk(t)=P(</a:t>
+            </a:r>
+            <a:r>
+              <a:rPr lang="en-GB" sz="2000" dirty="0" err="1"/>
+              <a:t>SLAstate</a:t>
+            </a:r>
+            <a:r>
+              <a:rPr lang="en-GB" sz="2000" dirty="0"/>
+              <a:t>​=</a:t>
+            </a:r>
+            <a:r>
+              <a:rPr lang="en-GB" sz="2000" dirty="0" err="1"/>
+              <a:t>Failure-prone∣Xt</a:t>
+            </a:r>
+            <a:r>
+              <a:rPr lang="en-GB" sz="2000" dirty="0"/>
+              <a:t>​) </a:t>
+            </a:r>
+          </a:p>
+          <a:p>
+            <a:pPr marL="457200" lvl="1" indent="0">
+              <a:buNone/>
+            </a:pPr>
+            <a:r>
+              <a:rPr lang="en-GB" sz="2000" dirty="0"/>
+              <a:t>Where:</a:t>
+            </a:r>
+          </a:p>
+          <a:p>
+            <a:pPr marL="457200" lvl="1" indent="0">
+              <a:buNone/>
+            </a:pPr>
+            <a:r>
+              <a:rPr lang="en-GB" sz="2000" dirty="0"/>
+              <a:t>𝑋_𝑡={𝑡ⓜ,𝑟ⓜ,𝑎ⓜ,𝑓ⓜ,𝑓𝑖𝑐_𝑡 " " 𝑝𝑜𝑙𝑖𝑐𝑦" " 𝑠𝑡𝑎𝑡𝑒_𝑡 " " 𝑎𝑙𝑙𝑜𝑐𝑎𝑡𝑖𝑜𝑛" " 𝑓𝑒𝑎𝑡𝑢𝑟𝑒𝑠_𝑡 " " 𝑏𝑙𝑜𝑐𝑘𝑖𝑛𝑔_𝑡 " " 𝑟𝑒𝑐𝑜𝑛𝑓𝑖𝑔𝑢𝑟𝑎𝑡𝑖𝑜𝑛_𝑡 }</a:t>
+            </a:r>
+          </a:p>
+          <a:p>
+            <a:pPr marL="457200" lvl="1" indent="0">
+              <a:buNone/>
+            </a:pPr>
+            <a:r>
+              <a:rPr lang="en-GB" sz="2000" dirty="0"/>
+              <a:t>Hence:</a:t>
+            </a:r>
+          </a:p>
+          <a:p>
+            <a:pPr marL="457200" lvl="1" indent="0">
+              <a:buNone/>
+            </a:pPr>
+            <a:r>
+              <a:rPr lang="en-GB" sz="2000" b="1" dirty="0"/>
+              <a:t>Input: </a:t>
+            </a:r>
+            <a:r>
+              <a:rPr lang="en-GB" sz="2000" dirty="0"/>
+              <a:t>predicted traffic + network/policy features at timestamp 𝑡</a:t>
+            </a:r>
+          </a:p>
+          <a:p>
+            <a:pPr marL="457200" lvl="1" indent="0">
+              <a:buNone/>
+            </a:pPr>
+            <a:r>
+              <a:rPr lang="en-GB" sz="2000" b="1" dirty="0"/>
+              <a:t>Model output: </a:t>
+            </a:r>
+            <a:r>
+              <a:rPr lang="en-GB" sz="2000" dirty="0"/>
+              <a:t>Failure-prone probability/risk score </a:t>
+            </a:r>
+          </a:p>
+          <a:p>
+            <a:pPr marL="457200" lvl="1" indent="0">
+              <a:buNone/>
+            </a:pPr>
+            <a:r>
+              <a:rPr lang="en-GB" sz="2000" dirty="0"/>
+              <a:t>Displayed result: SLA state + risk percentage </a:t>
+            </a:r>
+          </a:p>
+          <a:p>
+            <a:pPr marL="457200" lvl="1" indent="0">
+              <a:buNone/>
+            </a:pPr>
+            <a:r>
+              <a:rPr lang="en-GB" sz="2000" b="1" dirty="0"/>
+              <a:t>Example: </a:t>
+            </a:r>
+            <a:r>
+              <a:rPr lang="en-GB" sz="2000" dirty="0"/>
+              <a:t>at 21:15, SLA state = Normal, Failure-prone risk = 12%</a:t>
+            </a:r>
+          </a:p>
+          <a:p>
+            <a:pPr marL="457200" lvl="1" indent="0">
+              <a:buNone/>
+            </a:pPr>
+            <a:endParaRPr lang="en-GB" sz="2000" dirty="0"/>
+          </a:p>
+          <a:p>
+            <a:pPr>
+              <a:buFont typeface="Arial" panose="020B0604020202020204" pitchFamily="34" charset="0"/>
+              <a:buChar char="•"/>
+            </a:pPr>
+            <a:endParaRPr lang="en-US" sz="1100" i="1" dirty="0"/>
+          </a:p>
+          <a:p>
+            <a:endParaRPr lang="en-US" sz="1100" dirty="0"/>
+          </a:p>
+          <a:p>
+            <a:endParaRPr lang="en-US" sz="1100" dirty="0"/>
+          </a:p>
+          <a:p>
+            <a:endParaRPr lang="en-IN" sz="1100" dirty="0"/>
+          </a:p>
+        </p:txBody>
+      </p:sp>
+      <p:sp>
+        <p:nvSpPr>
+          <p:cNvPr id="7" name="TextBox 6">
+            <a:extLst>
+              <a:ext uri="{FF2B5EF4-FFF2-40B4-BE49-F238E27FC236}">
+                <a16:creationId xmlns:a16="http://schemas.microsoft.com/office/drawing/2014/main" id="{45FD624B-9BF4-BCAB-CA9B-2F35126C628C}"/>
+              </a:ext>
+            </a:extLst>
+          </p:cNvPr>
+          <p:cNvSpPr txBox="1"/>
+          <p:nvPr/>
+        </p:nvSpPr>
+        <p:spPr>
+          <a:xfrm>
+            <a:off x="8976320" y="2852936"/>
+            <a:ext cx="473206" cy="369332"/>
+          </a:xfrm>
+          <a:prstGeom prst="rect">
+            <a:avLst/>
+          </a:prstGeom>
+          <a:noFill/>
+        </p:spPr>
+        <p:txBody>
+          <a:bodyPr wrap="none" rtlCol="0">
+            <a:spAutoFit/>
+          </a:bodyPr>
+          <a:lstStyle/>
+          <a:p>
+            <a:pPr marL="285750" indent="-285750">
+              <a:buFont typeface="Wingdings" panose="05000000000000000000" pitchFamily="2" charset="2"/>
+              <a:buChar char="§"/>
+            </a:pPr>
+            <a:endParaRPr lang="en-US" err="1">
+              <a:solidFill>
+                <a:schemeClr val="accent2"/>
+              </a:solidFill>
+              <a:latin typeface="Montserrat" pitchFamily="2" charset="0"/>
+            </a:endParaRPr>
+          </a:p>
+        </p:txBody>
+      </p:sp>
+    </p:spTree>
+    <p:extLst>
+      <p:ext uri="{BB962C8B-B14F-4D97-AF65-F5344CB8AC3E}">
+        <p14:creationId xmlns:p14="http://schemas.microsoft.com/office/powerpoint/2010/main" val="605112156"/>
+      </p:ext>
+    </p:extLst>
+  </p:cSld>
+  <p:clrMapOvr>
+    <a:masterClrMapping/>
+  </p:clrMapOvr>
+</p:sld>
+</file>
+
+<file path=ppt/slides/slide18.xml><?xml version="1.0" encoding="utf-8"?>
 <p:sld xmlns:a="http://schemas.openxmlformats.org/drawingml/2006/main" xmlns:r="http://schemas.openxmlformats.org/officeDocument/2006/relationships" xmlns:p="http://schemas.openxmlformats.org/presentationml/2006/main">
   <p:cSld>
     <p:spTree>
@@ -9406,7 +10688,7 @@
 </p:sld>
 </file>
 
-<file path=ppt/slides/slide17.xml><?xml version="1.0" encoding="utf-8"?>
+<file path=ppt/slides/slide19.xml><?xml version="1.0" encoding="utf-8"?>
 <p:sld xmlns:a="http://schemas.openxmlformats.org/drawingml/2006/main" xmlns:r="http://schemas.openxmlformats.org/officeDocument/2006/relationships" xmlns:p="http://schemas.openxmlformats.org/presentationml/2006/main">
   <p:cSld>
     <p:spTree>
@@ -9464,8 +10746,8 @@
           </a:p>
         </p:txBody>
       </p:sp>
-      <mc:AlternateContent xmlns:mc="http://schemas.openxmlformats.org/markup-compatibility/2006">
-        <mc:Choice xmlns:a14="http://schemas.microsoft.com/office/drawing/2010/main" Requires="a14">
+      <mc:AlternateContent xmlns:mc="http://schemas.openxmlformats.org/markup-compatibility/2006" xmlns:a14="http://schemas.microsoft.com/office/drawing/2010/main">
+        <mc:Choice Requires="a14">
           <p:sp>
             <p:nvSpPr>
               <p:cNvPr id="3" name="Content Placeholder 2">
@@ -9514,11 +10796,11 @@
                         <m:rPr>
                           <m:nor/>
                         </m:rPr>
-                        <a:rPr lang="en-US" sz="1400" b="0" i="0"/>
+                        <a:rPr lang="en-US" sz="1800" b="0" i="0"/>
                         <m:t>Tool Accuracy</m:t>
                       </m:r>
                       <m:r>
-                        <a:rPr lang="en-US" sz="1400" b="0" i="0">
+                        <a:rPr lang="en-US" sz="1800" b="0" i="0">
                           <a:latin typeface="Cambria Math" panose="02040503050406030204" pitchFamily="18" charset="0"/>
                         </a:rPr>
                         <m:t>=</m:t>
@@ -9526,7 +10808,7 @@
                       <m:f>
                         <m:fPr>
                           <m:ctrlPr>
-                            <a:rPr lang="en-US" sz="1400" b="0" i="0">
+                            <a:rPr lang="en-US" sz="1800" b="0" i="0">
                               <a:latin typeface="Cambria Math" panose="02040503050406030204" pitchFamily="18" charset="0"/>
                             </a:rPr>
                           </m:ctrlPr>
@@ -9536,7 +10818,7 @@
                             <m:rPr>
                               <m:nor/>
                             </m:rPr>
-                            <a:rPr lang="en-US" sz="1400" b="0" i="0">
+                            <a:rPr lang="en-US" sz="1800" b="0" i="0">
                               <a:latin typeface="Cambria Math" panose="02040503050406030204" pitchFamily="18" charset="0"/>
                             </a:rPr>
                             <m:t>Correct tool selections</m:t>
@@ -9547,7 +10829,7 @@
                             <m:rPr>
                               <m:nor/>
                             </m:rPr>
-                            <a:rPr lang="en-US" sz="1400" b="0" i="0">
+                            <a:rPr lang="en-US" sz="1800" b="0" i="0">
                               <a:latin typeface="Cambria Math" panose="02040503050406030204" pitchFamily="18" charset="0"/>
                             </a:rPr>
                             <m:t>Total queries</m:t>
@@ -9555,7 +10837,7 @@
                         </m:den>
                       </m:f>
                       <m:r>
-                        <a:rPr lang="en-US" sz="1400" b="0" i="0">
+                        <a:rPr lang="en-US" sz="1800" b="0" i="0">
                           <a:latin typeface="Cambria Math" panose="02040503050406030204" pitchFamily="18" charset="0"/>
                         </a:rPr>
                         <m:t>×100</m:t>
@@ -9563,47 +10845,56 @@
                     </m:oMath>
                   </m:oMathPara>
                 </a14:m>
-                <a:endParaRPr lang="en-US" sz="1400" b="0" dirty="0"/>
+                <a:endParaRPr lang="en-US" sz="1800" b="0" dirty="0"/>
               </a:p>
               <a:p>
                 <a:pPr>
                   <a:buNone/>
                 </a:pPr>
                 <a:r>
-                  <a:rPr lang="en-US" sz="1400" dirty="0"/>
-                  <a:t>Argument Accuracy=Total queries/Queries with correct extracted arguments​×100</a:t>
+                  <a:rPr lang="en-US" sz="1800" dirty="0"/>
+                  <a:t>Argument Accuracy=Total queries / Queries with correct extracted arguments ​× 100</a:t>
                 </a:r>
               </a:p>
               <a:p>
                 <a:pPr>
                   <a:buNone/>
                 </a:pPr>
-                <a:endParaRPr lang="en-US" sz="1400" dirty="0"/>
+                <a:endParaRPr lang="en-US" sz="1800" dirty="0"/>
               </a:p>
               <a:p>
                 <a:pPr>
                   <a:buNone/>
                 </a:pPr>
                 <a:r>
-                  <a:rPr lang="en-US" sz="2000" dirty="0"/>
-                  <a:t>	   Hallucination Rate=Total queries / Queries with unsupported LLM claims​ × 100</a:t>
+                  <a:rPr lang="en-US" dirty="0"/>
+                  <a:t>	   Hallucination Rate = Queries with unsupported LLM claims / 	total queries​ × 100</a:t>
+                </a:r>
+              </a:p>
+              <a:p>
+                <a:pPr>
+                  <a:buNone/>
+                </a:pPr>
+                <a:r>
+                  <a:rPr lang="en-US" dirty="0"/>
+                  <a:t>		6 / 50 x 100 = 12%</a:t>
                 </a:r>
               </a:p>
               <a:p>
                 <a:pPr marL="457200" lvl="1" indent="0">
                   <a:buNone/>
                 </a:pPr>
-                <a:endParaRPr lang="en-GB" sz="2000" dirty="0"/>
+                <a:endParaRPr lang="en-GB" sz="2800" dirty="0"/>
               </a:p>
               <a:p>
                 <a:pPr marL="457200" lvl="1" indent="0">
                   <a:buNone/>
                 </a:pPr>
                 <a:r>
-                  <a:rPr lang="en-US" sz="2000" dirty="0"/>
+                  <a:rPr lang="en-US" sz="2800" dirty="0"/>
                   <a:t>Combined Average Accuracy = (Tool Accuracy + Argument Accuracy) / 2 = (74 + 56) / 2 = 65%	</a:t>
                 </a:r>
-                <a:endParaRPr lang="en-US" sz="1100" i="1" dirty="0"/>
+                <a:endParaRPr lang="en-US" sz="1400" i="1" dirty="0"/>
               </a:p>
               <a:p>
                 <a:endParaRPr lang="en-US" sz="1100" dirty="0"/>
@@ -9617,7 +10908,7 @@
             </p:txBody>
           </p:sp>
         </mc:Choice>
-        <mc:Fallback>
+        <mc:Fallback xmlns="">
           <p:sp>
             <p:nvSpPr>
               <p:cNvPr id="3" name="Content Placeholder 2">
@@ -9642,7 +10933,7 @@
               <a:blipFill>
                 <a:blip r:embed="rId3"/>
                 <a:stretch>
-                  <a:fillRect l="-160" r="-427"/>
+                  <a:fillRect l="-427"/>
                 </a:stretch>
               </a:blipFill>
             </p:spPr>
@@ -9665,203 +10956,6 @@
     <p:extLst>
       <p:ext uri="{BB962C8B-B14F-4D97-AF65-F5344CB8AC3E}">
         <p14:creationId xmlns:p14="http://schemas.microsoft.com/office/powerpoint/2010/main" val="593684527"/>
-      </p:ext>
-    </p:extLst>
-  </p:cSld>
-  <p:clrMapOvr>
-    <a:masterClrMapping/>
-  </p:clrMapOvr>
-</p:sld>
-</file>
-
-<file path=ppt/slides/slide18.xml><?xml version="1.0" encoding="utf-8"?>
-<p:sld xmlns:a="http://schemas.openxmlformats.org/drawingml/2006/main" xmlns:r="http://schemas.openxmlformats.org/officeDocument/2006/relationships" xmlns:p="http://schemas.openxmlformats.org/presentationml/2006/main">
-  <p:cSld>
-    <p:spTree>
-      <p:nvGrpSpPr>
-        <p:cNvPr id="1" name="">
-          <a:extLst>
-            <a:ext uri="{FF2B5EF4-FFF2-40B4-BE49-F238E27FC236}">
-              <a16:creationId xmlns:a16="http://schemas.microsoft.com/office/drawing/2014/main" id="{B900C2F6-9F79-33A7-76FC-2774DB35FB56}"/>
-            </a:ext>
-          </a:extLst>
-        </p:cNvPr>
-        <p:cNvGrpSpPr/>
-        <p:nvPr/>
-      </p:nvGrpSpPr>
-      <p:grpSpPr>
-        <a:xfrm>
-          <a:off x="0" y="0"/>
-          <a:ext cx="0" cy="0"/>
-          <a:chOff x="0" y="0"/>
-          <a:chExt cx="0" cy="0"/>
-        </a:xfrm>
-      </p:grpSpPr>
-      <p:sp>
-        <p:nvSpPr>
-          <p:cNvPr id="2" name="Title 1">
-            <a:extLst>
-              <a:ext uri="{FF2B5EF4-FFF2-40B4-BE49-F238E27FC236}">
-                <a16:creationId xmlns:a16="http://schemas.microsoft.com/office/drawing/2014/main" id="{5BB8F4F5-9009-FCC1-1542-85E4687F341F}"/>
-              </a:ext>
-            </a:extLst>
-          </p:cNvPr>
-          <p:cNvSpPr>
-            <a:spLocks noGrp="1"/>
-          </p:cNvSpPr>
-          <p:nvPr>
-            <p:ph type="title"/>
-          </p:nvPr>
-        </p:nvSpPr>
-        <p:spPr>
-          <a:xfrm>
-            <a:off x="305555" y="0"/>
-            <a:ext cx="11885653" cy="838800"/>
-          </a:xfrm>
-        </p:spPr>
-        <p:txBody>
-          <a:bodyPr anchor="ctr">
-            <a:normAutofit/>
-          </a:bodyPr>
-          <a:lstStyle/>
-          <a:p>
-            <a:r>
-              <a:rPr lang="en-IN" dirty="0"/>
-              <a:t>Todays demo</a:t>
-            </a:r>
-          </a:p>
-        </p:txBody>
-      </p:sp>
-      <p:sp>
-        <p:nvSpPr>
-          <p:cNvPr id="3" name="Content Placeholder 2">
-            <a:extLst>
-              <a:ext uri="{FF2B5EF4-FFF2-40B4-BE49-F238E27FC236}">
-                <a16:creationId xmlns:a16="http://schemas.microsoft.com/office/drawing/2014/main" id="{F2285AB5-7FE8-25C8-B84E-698086E31CC4}"/>
-              </a:ext>
-            </a:extLst>
-          </p:cNvPr>
-          <p:cNvSpPr>
-            <a:spLocks noGrp="1"/>
-          </p:cNvSpPr>
-          <p:nvPr>
-            <p:ph sz="quarter" idx="10"/>
-          </p:nvPr>
-        </p:nvSpPr>
-        <p:spPr>
-          <a:xfrm>
-            <a:off x="172788" y="556007"/>
-            <a:ext cx="11426771" cy="5924573"/>
-          </a:xfrm>
-        </p:spPr>
-        <p:txBody>
-          <a:bodyPr>
-            <a:normAutofit fontScale="92500" lnSpcReduction="10000"/>
-          </a:bodyPr>
-          <a:lstStyle/>
-          <a:p>
-            <a:pPr marL="457200" lvl="1" indent="0">
-              <a:buNone/>
-            </a:pPr>
-            <a:endParaRPr lang="en-US" sz="1100" dirty="0"/>
-          </a:p>
-          <a:p>
-            <a:pPr marL="800100" lvl="1" indent="-342900"/>
-            <a:endParaRPr lang="en-US" sz="1100" i="1" dirty="0"/>
-          </a:p>
-          <a:p>
-            <a:r>
-              <a:rPr lang="en-US" sz="2000" dirty="0"/>
-              <a:t>1. What traffic do you expect at 21:15?</a:t>
-            </a:r>
-          </a:p>
-          <a:p>
-            <a:endParaRPr lang="en-US" sz="2000" dirty="0"/>
-          </a:p>
-          <a:p>
-            <a:r>
-              <a:rPr lang="en-US" sz="2000" dirty="0"/>
-              <a:t>2. What is the predicted SLA state at 21:15?</a:t>
-            </a:r>
-          </a:p>
-          <a:p>
-            <a:endParaRPr lang="en-US" sz="2000" dirty="0"/>
-          </a:p>
-          <a:p>
-            <a:r>
-              <a:rPr lang="en-US" sz="2000" dirty="0"/>
-              <a:t>3. Show me the complete network state at 16:20.</a:t>
-            </a:r>
-          </a:p>
-          <a:p>
-            <a:endParaRPr lang="en-US" sz="2000" dirty="0"/>
-          </a:p>
-          <a:p>
-            <a:r>
-              <a:rPr lang="en-US" sz="2000" dirty="0"/>
-              <a:t>4. Keep PON on 2 subcarriers at 21:15 and allocate the remaining two.</a:t>
-            </a:r>
-          </a:p>
-          <a:p>
-            <a:endParaRPr lang="en-US" sz="2000" dirty="0"/>
-          </a:p>
-          <a:p>
-            <a:r>
-              <a:rPr lang="en-US" sz="2000" dirty="0"/>
-              <a:t>5. Reserve 1 subcarrier for PON at 21:15 and allocate the remaining three.</a:t>
-            </a:r>
-          </a:p>
-          <a:p>
-            <a:endParaRPr lang="en-US" sz="2000" dirty="0"/>
-          </a:p>
-          <a:p>
-            <a:r>
-              <a:rPr lang="en-US" sz="2000" dirty="0"/>
-              <a:t>6. And one hour later?</a:t>
-            </a:r>
-          </a:p>
-          <a:p>
-            <a:endParaRPr lang="en-US" sz="2000" dirty="0"/>
-          </a:p>
-          <a:p>
-            <a:r>
-              <a:rPr lang="en-US" sz="2000" dirty="0"/>
-              <a:t>   System → Which time should I use as the reference?</a:t>
-            </a:r>
-          </a:p>
-          <a:p>
-            <a:endParaRPr lang="en-US" sz="2000" dirty="0"/>
-          </a:p>
-          <a:p>
-            <a:r>
-              <a:rPr lang="en-US" sz="2000" dirty="0"/>
-              <a:t>7. </a:t>
-            </a:r>
-            <a:r>
-              <a:rPr lang="en-US" sz="2000"/>
-              <a:t>10:00%</a:t>
-            </a:r>
-            <a:r>
-              <a:rPr lang="en-US" sz="2000" dirty="0"/>
-              <a:t>	</a:t>
-            </a:r>
-            <a:endParaRPr lang="en-US" sz="1100" i="1" dirty="0"/>
-          </a:p>
-          <a:p>
-            <a:endParaRPr lang="en-US" sz="1100" dirty="0"/>
-          </a:p>
-          <a:p>
-            <a:endParaRPr lang="en-US" sz="1100" dirty="0"/>
-          </a:p>
-          <a:p>
-            <a:endParaRPr lang="en-IN" sz="1100" dirty="0"/>
-          </a:p>
-        </p:txBody>
-      </p:sp>
-    </p:spTree>
-    <p:extLst>
-      <p:ext uri="{BB962C8B-B14F-4D97-AF65-F5344CB8AC3E}">
-        <p14:creationId xmlns:p14="http://schemas.microsoft.com/office/powerpoint/2010/main" val="315198265"/>
       </p:ext>
     </p:extLst>
   </p:cSld>
@@ -10082,6 +11176,1362 @@
     <p:extLst>
       <p:ext uri="{BB962C8B-B14F-4D97-AF65-F5344CB8AC3E}">
         <p14:creationId xmlns:p14="http://schemas.microsoft.com/office/powerpoint/2010/main" val="2340798936"/>
+      </p:ext>
+    </p:extLst>
+  </p:cSld>
+  <p:clrMapOvr>
+    <a:masterClrMapping/>
+  </p:clrMapOvr>
+</p:sld>
+</file>
+
+<file path=ppt/slides/slide20.xml><?xml version="1.0" encoding="utf-8"?>
+<p:sld xmlns:a="http://schemas.openxmlformats.org/drawingml/2006/main" xmlns:r="http://schemas.openxmlformats.org/officeDocument/2006/relationships" xmlns:p="http://schemas.openxmlformats.org/presentationml/2006/main">
+  <p:cSld>
+    <p:spTree>
+      <p:nvGrpSpPr>
+        <p:cNvPr id="1" name="">
+          <a:extLst>
+            <a:ext uri="{FF2B5EF4-FFF2-40B4-BE49-F238E27FC236}">
+              <a16:creationId xmlns:a16="http://schemas.microsoft.com/office/drawing/2014/main" id="{B900C2F6-9F79-33A7-76FC-2774DB35FB56}"/>
+            </a:ext>
+          </a:extLst>
+        </p:cNvPr>
+        <p:cNvGrpSpPr/>
+        <p:nvPr/>
+      </p:nvGrpSpPr>
+      <p:grpSpPr>
+        <a:xfrm>
+          <a:off x="0" y="0"/>
+          <a:ext cx="0" cy="0"/>
+          <a:chOff x="0" y="0"/>
+          <a:chExt cx="0" cy="0"/>
+        </a:xfrm>
+      </p:grpSpPr>
+      <p:sp>
+        <p:nvSpPr>
+          <p:cNvPr id="2" name="Title 1">
+            <a:extLst>
+              <a:ext uri="{FF2B5EF4-FFF2-40B4-BE49-F238E27FC236}">
+                <a16:creationId xmlns:a16="http://schemas.microsoft.com/office/drawing/2014/main" id="{5BB8F4F5-9009-FCC1-1542-85E4687F341F}"/>
+              </a:ext>
+            </a:extLst>
+          </p:cNvPr>
+          <p:cNvSpPr>
+            <a:spLocks noGrp="1"/>
+          </p:cNvSpPr>
+          <p:nvPr>
+            <p:ph type="title"/>
+          </p:nvPr>
+        </p:nvSpPr>
+        <p:spPr>
+          <a:xfrm>
+            <a:off x="305555" y="0"/>
+            <a:ext cx="11885653" cy="838800"/>
+          </a:xfrm>
+        </p:spPr>
+        <p:txBody>
+          <a:bodyPr anchor="ctr">
+            <a:normAutofit/>
+          </a:bodyPr>
+          <a:lstStyle/>
+          <a:p>
+            <a:r>
+              <a:rPr lang="en-IN" dirty="0"/>
+              <a:t>Todays demo</a:t>
+            </a:r>
+          </a:p>
+        </p:txBody>
+      </p:sp>
+      <p:sp>
+        <p:nvSpPr>
+          <p:cNvPr id="3" name="Content Placeholder 2">
+            <a:extLst>
+              <a:ext uri="{FF2B5EF4-FFF2-40B4-BE49-F238E27FC236}">
+                <a16:creationId xmlns:a16="http://schemas.microsoft.com/office/drawing/2014/main" id="{F2285AB5-7FE8-25C8-B84E-698086E31CC4}"/>
+              </a:ext>
+            </a:extLst>
+          </p:cNvPr>
+          <p:cNvSpPr>
+            <a:spLocks noGrp="1"/>
+          </p:cNvSpPr>
+          <p:nvPr>
+            <p:ph sz="quarter" idx="10"/>
+          </p:nvPr>
+        </p:nvSpPr>
+        <p:spPr>
+          <a:xfrm>
+            <a:off x="172788" y="556007"/>
+            <a:ext cx="11426771" cy="5924573"/>
+          </a:xfrm>
+        </p:spPr>
+        <p:txBody>
+          <a:bodyPr>
+            <a:normAutofit lnSpcReduction="10000"/>
+          </a:bodyPr>
+          <a:lstStyle/>
+          <a:p>
+            <a:pPr marL="457200" lvl="1" indent="0">
+              <a:buNone/>
+            </a:pPr>
+            <a:endParaRPr lang="en-US" sz="1100" dirty="0"/>
+          </a:p>
+          <a:p>
+            <a:pPr marL="800100" lvl="1" indent="-342900"/>
+            <a:endParaRPr lang="en-US" sz="1100" i="1" dirty="0"/>
+          </a:p>
+          <a:p>
+            <a:r>
+              <a:rPr lang="en-US" sz="1800" b="1" dirty="0"/>
+              <a:t>1. What traffic do you expect at 21:15?</a:t>
+            </a:r>
+          </a:p>
+          <a:p>
+            <a:endParaRPr lang="en-US" sz="1800" b="1" dirty="0"/>
+          </a:p>
+          <a:p>
+            <a:r>
+              <a:rPr lang="en-US" sz="1800" b="1" dirty="0"/>
+              <a:t>2. What is the predicted SLA state at 21:15?</a:t>
+            </a:r>
+          </a:p>
+          <a:p>
+            <a:endParaRPr lang="en-US" sz="1800" b="1" dirty="0"/>
+          </a:p>
+          <a:p>
+            <a:r>
+              <a:rPr lang="en-US" sz="1800" b="1" dirty="0"/>
+              <a:t>3. Show me the complete network state at 16:20.</a:t>
+            </a:r>
+          </a:p>
+          <a:p>
+            <a:endParaRPr lang="en-US" sz="1800" b="1" dirty="0"/>
+          </a:p>
+          <a:p>
+            <a:r>
+              <a:rPr lang="en-US" sz="1800" b="1" dirty="0"/>
+              <a:t>4. Keep PON on 2 subcarriers at 21:15 and allocate the remaining two.</a:t>
+            </a:r>
+          </a:p>
+          <a:p>
+            <a:endParaRPr lang="en-US" sz="1800" b="1" dirty="0"/>
+          </a:p>
+          <a:p>
+            <a:r>
+              <a:rPr lang="en-US" sz="1800" b="1" dirty="0"/>
+              <a:t>5. Reserve 1 subcarrier for PON at 21:15 and allocate the remaining three.</a:t>
+            </a:r>
+          </a:p>
+          <a:p>
+            <a:endParaRPr lang="en-US" sz="1800" b="1" dirty="0"/>
+          </a:p>
+          <a:p>
+            <a:r>
+              <a:rPr lang="en-US" sz="1800" b="1" dirty="0"/>
+              <a:t>6. And one hour later?</a:t>
+            </a:r>
+          </a:p>
+          <a:p>
+            <a:endParaRPr lang="en-US" sz="1800" b="1" dirty="0"/>
+          </a:p>
+          <a:p>
+            <a:r>
+              <a:rPr lang="en-US" sz="1800" b="1" dirty="0"/>
+              <a:t>   System → Which time should I use as the reference?</a:t>
+            </a:r>
+          </a:p>
+          <a:p>
+            <a:endParaRPr lang="en-US" sz="1800" b="1" dirty="0"/>
+          </a:p>
+          <a:p>
+            <a:r>
+              <a:rPr lang="en-US" sz="1800" b="1" dirty="0"/>
+              <a:t>7. 10:00</a:t>
+            </a:r>
+          </a:p>
+          <a:p>
+            <a:endParaRPr lang="en-US" sz="1100" dirty="0"/>
+          </a:p>
+          <a:p>
+            <a:endParaRPr lang="en-IN" sz="1100" dirty="0"/>
+          </a:p>
+        </p:txBody>
+      </p:sp>
+    </p:spTree>
+    <p:extLst>
+      <p:ext uri="{BB962C8B-B14F-4D97-AF65-F5344CB8AC3E}">
+        <p14:creationId xmlns:p14="http://schemas.microsoft.com/office/powerpoint/2010/main" val="315198265"/>
+      </p:ext>
+    </p:extLst>
+  </p:cSld>
+  <p:clrMapOvr>
+    <a:masterClrMapping/>
+  </p:clrMapOvr>
+</p:sld>
+</file>
+
+<file path=ppt/slides/slide21.xml><?xml version="1.0" encoding="utf-8"?>
+<p:sld xmlns:a="http://schemas.openxmlformats.org/drawingml/2006/main" xmlns:r="http://schemas.openxmlformats.org/officeDocument/2006/relationships" xmlns:p="http://schemas.openxmlformats.org/presentationml/2006/main">
+  <p:cSld>
+    <p:spTree>
+      <p:nvGrpSpPr>
+        <p:cNvPr id="1" name="">
+          <a:extLst>
+            <a:ext uri="{FF2B5EF4-FFF2-40B4-BE49-F238E27FC236}">
+              <a16:creationId xmlns:a16="http://schemas.microsoft.com/office/drawing/2014/main" id="{FD0EA979-33B5-10D2-686C-600AB33E8579}"/>
+            </a:ext>
+          </a:extLst>
+        </p:cNvPr>
+        <p:cNvGrpSpPr/>
+        <p:nvPr/>
+      </p:nvGrpSpPr>
+      <p:grpSpPr>
+        <a:xfrm>
+          <a:off x="0" y="0"/>
+          <a:ext cx="0" cy="0"/>
+          <a:chOff x="0" y="0"/>
+          <a:chExt cx="0" cy="0"/>
+        </a:xfrm>
+      </p:grpSpPr>
+      <p:sp>
+        <p:nvSpPr>
+          <p:cNvPr id="2" name="Title 1">
+            <a:extLst>
+              <a:ext uri="{FF2B5EF4-FFF2-40B4-BE49-F238E27FC236}">
+                <a16:creationId xmlns:a16="http://schemas.microsoft.com/office/drawing/2014/main" id="{928F54E8-E5AB-2835-7534-58A9CC6FCC27}"/>
+              </a:ext>
+            </a:extLst>
+          </p:cNvPr>
+          <p:cNvSpPr>
+            <a:spLocks noGrp="1"/>
+          </p:cNvSpPr>
+          <p:nvPr>
+            <p:ph type="title"/>
+          </p:nvPr>
+        </p:nvSpPr>
+        <p:spPr>
+          <a:xfrm>
+            <a:off x="305555" y="0"/>
+            <a:ext cx="11885653" cy="838800"/>
+          </a:xfrm>
+        </p:spPr>
+        <p:txBody>
+          <a:bodyPr anchor="ctr">
+            <a:normAutofit/>
+          </a:bodyPr>
+          <a:lstStyle/>
+          <a:p>
+            <a:r>
+              <a:rPr lang="en-IN" dirty="0"/>
+              <a:t>Moving forward</a:t>
+            </a:r>
+          </a:p>
+        </p:txBody>
+      </p:sp>
+      <p:sp>
+        <p:nvSpPr>
+          <p:cNvPr id="3" name="Content Placeholder 2">
+            <a:extLst>
+              <a:ext uri="{FF2B5EF4-FFF2-40B4-BE49-F238E27FC236}">
+                <a16:creationId xmlns:a16="http://schemas.microsoft.com/office/drawing/2014/main" id="{710AD660-20CA-F2D1-0EEC-180BEFD123C5}"/>
+              </a:ext>
+            </a:extLst>
+          </p:cNvPr>
+          <p:cNvSpPr>
+            <a:spLocks noGrp="1"/>
+          </p:cNvSpPr>
+          <p:nvPr>
+            <p:ph sz="quarter" idx="10"/>
+          </p:nvPr>
+        </p:nvSpPr>
+        <p:spPr>
+          <a:xfrm>
+            <a:off x="387580" y="752388"/>
+            <a:ext cx="11426771" cy="4813793"/>
+          </a:xfrm>
+        </p:spPr>
+        <p:txBody>
+          <a:bodyPr>
+            <a:normAutofit/>
+          </a:bodyPr>
+          <a:lstStyle/>
+          <a:p>
+            <a:pPr marL="457200" lvl="1" indent="0">
+              <a:buNone/>
+            </a:pPr>
+            <a:endParaRPr lang="en-US" sz="1100" dirty="0"/>
+          </a:p>
+          <a:p>
+            <a:pPr marL="800100" lvl="1" indent="-342900"/>
+            <a:endParaRPr lang="en-US" sz="1100" i="1" dirty="0"/>
+          </a:p>
+          <a:p>
+            <a:pPr>
+              <a:buFont typeface="Arial" panose="020B0604020202020204" pitchFamily="34" charset="0"/>
+              <a:buChar char="•"/>
+            </a:pPr>
+            <a:r>
+              <a:rPr lang="en-GB" sz="2400" b="1" dirty="0"/>
+              <a:t>Access to Physical parameters</a:t>
+            </a:r>
+          </a:p>
+          <a:p>
+            <a:pPr>
+              <a:buFont typeface="Arial" panose="020B0604020202020204" pitchFamily="34" charset="0"/>
+              <a:buChar char="•"/>
+            </a:pPr>
+            <a:r>
+              <a:rPr lang="en-GB" sz="2400" b="1" dirty="0"/>
+              <a:t>Larger Mesh network topology</a:t>
+            </a:r>
+          </a:p>
+          <a:p>
+            <a:pPr>
+              <a:buFont typeface="Arial" panose="020B0604020202020204" pitchFamily="34" charset="0"/>
+              <a:buChar char="•"/>
+            </a:pPr>
+            <a:r>
+              <a:rPr lang="en-GB" sz="2400" b="1" dirty="0"/>
+              <a:t>Integration of live telemetry</a:t>
+            </a:r>
+          </a:p>
+          <a:p>
+            <a:pPr>
+              <a:buFont typeface="Arial" panose="020B0604020202020204" pitchFamily="34" charset="0"/>
+              <a:buChar char="•"/>
+            </a:pPr>
+            <a:r>
+              <a:rPr lang="en-GB" sz="2400" b="1" dirty="0"/>
+              <a:t>Devising comprehensive set of training queries probably in different language variants as well</a:t>
+            </a:r>
+          </a:p>
+          <a:p>
+            <a:pPr>
+              <a:buFont typeface="Arial" panose="020B0604020202020204" pitchFamily="34" charset="0"/>
+              <a:buChar char="•"/>
+            </a:pPr>
+            <a:r>
+              <a:rPr lang="en-GB" sz="2400" b="1" dirty="0"/>
+              <a:t>Fine tuning the model for latency reduction</a:t>
+            </a:r>
+          </a:p>
+          <a:p>
+            <a:pPr>
+              <a:buFont typeface="Arial" panose="020B0604020202020204" pitchFamily="34" charset="0"/>
+              <a:buChar char="•"/>
+            </a:pPr>
+            <a:r>
+              <a:rPr lang="en-GB" sz="2400" b="1" dirty="0"/>
+              <a:t>Compare the current results with the fine-tune dataset</a:t>
+            </a:r>
+            <a:endParaRPr lang="en-GB" sz="2000" dirty="0"/>
+          </a:p>
+          <a:p>
+            <a:pPr marL="457200" lvl="1" indent="0">
+              <a:buNone/>
+            </a:pPr>
+            <a:endParaRPr lang="en-GB" sz="2000" dirty="0"/>
+          </a:p>
+          <a:p>
+            <a:pPr>
+              <a:buFont typeface="Arial" panose="020B0604020202020204" pitchFamily="34" charset="0"/>
+              <a:buChar char="•"/>
+            </a:pPr>
+            <a:endParaRPr lang="en-US" sz="1100" i="1" dirty="0"/>
+          </a:p>
+          <a:p>
+            <a:endParaRPr lang="en-US" sz="1100" dirty="0"/>
+          </a:p>
+          <a:p>
+            <a:endParaRPr lang="en-US" sz="1100" dirty="0"/>
+          </a:p>
+          <a:p>
+            <a:endParaRPr lang="en-IN" sz="1100" dirty="0"/>
+          </a:p>
+        </p:txBody>
+      </p:sp>
+      <p:sp>
+        <p:nvSpPr>
+          <p:cNvPr id="7" name="TextBox 6">
+            <a:extLst>
+              <a:ext uri="{FF2B5EF4-FFF2-40B4-BE49-F238E27FC236}">
+                <a16:creationId xmlns:a16="http://schemas.microsoft.com/office/drawing/2014/main" id="{7F720CB5-9551-CB24-871C-3A7780F1B480}"/>
+              </a:ext>
+            </a:extLst>
+          </p:cNvPr>
+          <p:cNvSpPr txBox="1"/>
+          <p:nvPr/>
+        </p:nvSpPr>
+        <p:spPr>
+          <a:xfrm>
+            <a:off x="8976320" y="2852936"/>
+            <a:ext cx="473206" cy="369332"/>
+          </a:xfrm>
+          <a:prstGeom prst="rect">
+            <a:avLst/>
+          </a:prstGeom>
+          <a:noFill/>
+        </p:spPr>
+        <p:txBody>
+          <a:bodyPr wrap="none" rtlCol="0">
+            <a:spAutoFit/>
+          </a:bodyPr>
+          <a:lstStyle/>
+          <a:p>
+            <a:pPr marL="285750" indent="-285750">
+              <a:buFont typeface="Wingdings" panose="05000000000000000000" pitchFamily="2" charset="2"/>
+              <a:buChar char="§"/>
+            </a:pPr>
+            <a:endParaRPr lang="en-US" err="1">
+              <a:solidFill>
+                <a:schemeClr val="accent2"/>
+              </a:solidFill>
+              <a:latin typeface="Montserrat" pitchFamily="2" charset="0"/>
+            </a:endParaRPr>
+          </a:p>
+        </p:txBody>
+      </p:sp>
+    </p:spTree>
+    <p:extLst>
+      <p:ext uri="{BB962C8B-B14F-4D97-AF65-F5344CB8AC3E}">
+        <p14:creationId xmlns:p14="http://schemas.microsoft.com/office/powerpoint/2010/main" val="509745660"/>
+      </p:ext>
+    </p:extLst>
+  </p:cSld>
+  <p:clrMapOvr>
+    <a:masterClrMapping/>
+  </p:clrMapOvr>
+</p:sld>
+</file>
+
+<file path=ppt/slides/slide22.xml><?xml version="1.0" encoding="utf-8"?>
+<p:sld xmlns:a="http://schemas.openxmlformats.org/drawingml/2006/main" xmlns:r="http://schemas.openxmlformats.org/officeDocument/2006/relationships" xmlns:p="http://schemas.openxmlformats.org/presentationml/2006/main">
+  <p:cSld>
+    <p:spTree>
+      <p:nvGrpSpPr>
+        <p:cNvPr id="1" name="">
+          <a:extLst>
+            <a:ext uri="{FF2B5EF4-FFF2-40B4-BE49-F238E27FC236}">
+              <a16:creationId xmlns:a16="http://schemas.microsoft.com/office/drawing/2014/main" id="{1E008E0E-37FC-417C-2570-657D781B5C5D}"/>
+            </a:ext>
+          </a:extLst>
+        </p:cNvPr>
+        <p:cNvGrpSpPr/>
+        <p:nvPr/>
+      </p:nvGrpSpPr>
+      <p:grpSpPr>
+        <a:xfrm>
+          <a:off x="0" y="0"/>
+          <a:ext cx="0" cy="0"/>
+          <a:chOff x="0" y="0"/>
+          <a:chExt cx="0" cy="0"/>
+        </a:xfrm>
+      </p:grpSpPr>
+      <p:sp>
+        <p:nvSpPr>
+          <p:cNvPr id="2" name="Title 1">
+            <a:extLst>
+              <a:ext uri="{FF2B5EF4-FFF2-40B4-BE49-F238E27FC236}">
+                <a16:creationId xmlns:a16="http://schemas.microsoft.com/office/drawing/2014/main" id="{349CE84B-174E-DB7C-FB54-44915FFDEE19}"/>
+              </a:ext>
+            </a:extLst>
+          </p:cNvPr>
+          <p:cNvSpPr>
+            <a:spLocks noGrp="1"/>
+          </p:cNvSpPr>
+          <p:nvPr>
+            <p:ph type="title"/>
+          </p:nvPr>
+        </p:nvSpPr>
+        <p:spPr>
+          <a:xfrm>
+            <a:off x="453881" y="872419"/>
+            <a:ext cx="11885653" cy="838800"/>
+          </a:xfrm>
+        </p:spPr>
+        <p:txBody>
+          <a:bodyPr anchor="ctr">
+            <a:normAutofit fontScale="90000"/>
+          </a:bodyPr>
+          <a:lstStyle/>
+          <a:p>
+            <a:r>
+              <a:rPr lang="en-IN" dirty="0"/>
+              <a:t>OFC 2026: OPTS – A Fine tuned </a:t>
+            </a:r>
+            <a:r>
+              <a:rPr lang="en-IN" dirty="0" err="1"/>
+              <a:t>slm</a:t>
+            </a:r>
+            <a:r>
+              <a:rPr lang="en-IN" dirty="0"/>
+              <a:t> for transceiver data </a:t>
+            </a:r>
+            <a:r>
+              <a:rPr lang="en-IN" dirty="0" err="1"/>
+              <a:t>extration</a:t>
+            </a:r>
+            <a:endParaRPr lang="en-IN" dirty="0"/>
+          </a:p>
+        </p:txBody>
+      </p:sp>
+      <p:sp>
+        <p:nvSpPr>
+          <p:cNvPr id="3" name="Content Placeholder 2">
+            <a:extLst>
+              <a:ext uri="{FF2B5EF4-FFF2-40B4-BE49-F238E27FC236}">
+                <a16:creationId xmlns:a16="http://schemas.microsoft.com/office/drawing/2014/main" id="{C0B60D69-F46F-22D9-3624-E0952348E7D4}"/>
+              </a:ext>
+            </a:extLst>
+          </p:cNvPr>
+          <p:cNvSpPr>
+            <a:spLocks noGrp="1"/>
+          </p:cNvSpPr>
+          <p:nvPr>
+            <p:ph sz="quarter" idx="10"/>
+          </p:nvPr>
+        </p:nvSpPr>
+        <p:spPr>
+          <a:xfrm>
+            <a:off x="382613" y="1711219"/>
+            <a:ext cx="11426771" cy="4813793"/>
+          </a:xfrm>
+        </p:spPr>
+        <p:txBody>
+          <a:bodyPr>
+            <a:normAutofit/>
+          </a:bodyPr>
+          <a:lstStyle/>
+          <a:p>
+            <a:pPr marL="457200" lvl="1" indent="0">
+              <a:buNone/>
+            </a:pPr>
+            <a:r>
+              <a:rPr lang="en-US" sz="1100" dirty="0"/>
+              <a:t> </a:t>
+            </a:r>
+          </a:p>
+          <a:p>
+            <a:pPr marL="800100" lvl="1" indent="-342900"/>
+            <a:endParaRPr lang="en-US" sz="1100" i="1" dirty="0"/>
+          </a:p>
+          <a:p>
+            <a:pPr>
+              <a:buFont typeface="Arial" panose="020B0604020202020204" pitchFamily="34" charset="0"/>
+              <a:buChar char="•"/>
+            </a:pPr>
+            <a:r>
+              <a:rPr lang="en-GB" sz="2000" dirty="0"/>
+              <a:t>Converts optical transceiver PDF datasheets into editable Markdown using PyMuPDF4LLM</a:t>
+            </a:r>
+          </a:p>
+          <a:p>
+            <a:pPr>
+              <a:buFont typeface="Arial" panose="020B0604020202020204" pitchFamily="34" charset="0"/>
+              <a:buChar char="•"/>
+            </a:pPr>
+            <a:r>
+              <a:rPr lang="en-GB" sz="2000" dirty="0"/>
+              <a:t>Extracts parameters such as wavelength, baud rate, modulation, FEC, optical power and reach </a:t>
+            </a:r>
+          </a:p>
+          <a:p>
+            <a:pPr>
+              <a:buFont typeface="Arial" panose="020B0604020202020204" pitchFamily="34" charset="0"/>
+              <a:buChar char="•"/>
+            </a:pPr>
+            <a:r>
+              <a:rPr lang="en-GB" sz="2000" dirty="0"/>
+              <a:t>Uses a local Qwen model through llama-server, keeping datasheet content on the user’s machine</a:t>
+            </a:r>
+          </a:p>
+          <a:p>
+            <a:pPr>
+              <a:buFont typeface="Arial" panose="020B0604020202020204" pitchFamily="34" charset="0"/>
+              <a:buChar char="•"/>
+            </a:pPr>
+            <a:r>
+              <a:rPr lang="en-GB" sz="2000" dirty="0"/>
+              <a:t>Separates atomic parameter extraction from operational mode synthesis to improve accuracy</a:t>
+            </a:r>
+          </a:p>
+          <a:p>
+            <a:pPr>
+              <a:buFont typeface="Arial" panose="020B0604020202020204" pitchFamily="34" charset="0"/>
+              <a:buChar char="•"/>
+            </a:pPr>
+            <a:r>
+              <a:rPr lang="en-GB" sz="2000" dirty="0"/>
+              <a:t>Validates outputs with </a:t>
+            </a:r>
+            <a:r>
+              <a:rPr lang="en-GB" sz="2000" dirty="0" err="1"/>
+              <a:t>Pydantic</a:t>
+            </a:r>
+            <a:r>
+              <a:rPr lang="en-GB" sz="2000" dirty="0"/>
+              <a:t> and stores the source text, raw model response and structured JSON for review</a:t>
+            </a:r>
+          </a:p>
+          <a:p>
+            <a:pPr>
+              <a:buFont typeface="Arial" panose="020B0604020202020204" pitchFamily="34" charset="0"/>
+              <a:buChar char="•"/>
+            </a:pPr>
+            <a:endParaRPr lang="en-GB" sz="2000" dirty="0"/>
+          </a:p>
+          <a:p>
+            <a:pPr>
+              <a:buFont typeface="Arial" panose="020B0604020202020204" pitchFamily="34" charset="0"/>
+              <a:buChar char="•"/>
+            </a:pPr>
+            <a:endParaRPr lang="en-US" sz="1100" i="1" dirty="0"/>
+          </a:p>
+          <a:p>
+            <a:endParaRPr lang="en-US" sz="1100" dirty="0"/>
+          </a:p>
+          <a:p>
+            <a:endParaRPr lang="en-US" sz="1100" dirty="0"/>
+          </a:p>
+          <a:p>
+            <a:endParaRPr lang="en-IN" sz="1100" dirty="0"/>
+          </a:p>
+        </p:txBody>
+      </p:sp>
+      <p:sp>
+        <p:nvSpPr>
+          <p:cNvPr id="7" name="TextBox 6">
+            <a:extLst>
+              <a:ext uri="{FF2B5EF4-FFF2-40B4-BE49-F238E27FC236}">
+                <a16:creationId xmlns:a16="http://schemas.microsoft.com/office/drawing/2014/main" id="{B382B353-681E-CD2A-1531-04BF872A9EA0}"/>
+              </a:ext>
+            </a:extLst>
+          </p:cNvPr>
+          <p:cNvSpPr txBox="1"/>
+          <p:nvPr/>
+        </p:nvSpPr>
+        <p:spPr>
+          <a:xfrm>
+            <a:off x="8976320" y="2852936"/>
+            <a:ext cx="473206" cy="369332"/>
+          </a:xfrm>
+          <a:prstGeom prst="rect">
+            <a:avLst/>
+          </a:prstGeom>
+          <a:noFill/>
+        </p:spPr>
+        <p:txBody>
+          <a:bodyPr wrap="none" rtlCol="0">
+            <a:spAutoFit/>
+          </a:bodyPr>
+          <a:lstStyle/>
+          <a:p>
+            <a:pPr marL="285750" indent="-285750">
+              <a:buFont typeface="Wingdings" panose="05000000000000000000" pitchFamily="2" charset="2"/>
+              <a:buChar char="§"/>
+            </a:pPr>
+            <a:endParaRPr lang="en-US" err="1">
+              <a:solidFill>
+                <a:schemeClr val="accent2"/>
+              </a:solidFill>
+              <a:latin typeface="Montserrat" pitchFamily="2" charset="0"/>
+            </a:endParaRPr>
+          </a:p>
+        </p:txBody>
+      </p:sp>
+    </p:spTree>
+    <p:extLst>
+      <p:ext uri="{BB962C8B-B14F-4D97-AF65-F5344CB8AC3E}">
+        <p14:creationId xmlns:p14="http://schemas.microsoft.com/office/powerpoint/2010/main" val="2164013933"/>
+      </p:ext>
+    </p:extLst>
+  </p:cSld>
+  <p:clrMapOvr>
+    <a:masterClrMapping/>
+  </p:clrMapOvr>
+</p:sld>
+</file>
+
+<file path=ppt/slides/slide23.xml><?xml version="1.0" encoding="utf-8"?>
+<p:sld xmlns:a="http://schemas.openxmlformats.org/drawingml/2006/main" xmlns:r="http://schemas.openxmlformats.org/officeDocument/2006/relationships" xmlns:p="http://schemas.openxmlformats.org/presentationml/2006/main">
+  <p:cSld>
+    <p:spTree>
+      <p:nvGrpSpPr>
+        <p:cNvPr id="1" name="">
+          <a:extLst>
+            <a:ext uri="{FF2B5EF4-FFF2-40B4-BE49-F238E27FC236}">
+              <a16:creationId xmlns:a16="http://schemas.microsoft.com/office/drawing/2014/main" id="{058D2291-E15A-8D05-7D16-7FB6C770805B}"/>
+            </a:ext>
+          </a:extLst>
+        </p:cNvPr>
+        <p:cNvGrpSpPr/>
+        <p:nvPr/>
+      </p:nvGrpSpPr>
+      <p:grpSpPr>
+        <a:xfrm>
+          <a:off x="0" y="0"/>
+          <a:ext cx="0" cy="0"/>
+          <a:chOff x="0" y="0"/>
+          <a:chExt cx="0" cy="0"/>
+        </a:xfrm>
+      </p:grpSpPr>
+      <p:sp>
+        <p:nvSpPr>
+          <p:cNvPr id="2" name="Title 1">
+            <a:extLst>
+              <a:ext uri="{FF2B5EF4-FFF2-40B4-BE49-F238E27FC236}">
+                <a16:creationId xmlns:a16="http://schemas.microsoft.com/office/drawing/2014/main" id="{71A9C53C-2DC4-BFCB-28E1-ACCFD33712D6}"/>
+              </a:ext>
+            </a:extLst>
+          </p:cNvPr>
+          <p:cNvSpPr>
+            <a:spLocks noGrp="1"/>
+          </p:cNvSpPr>
+          <p:nvPr>
+            <p:ph type="title"/>
+          </p:nvPr>
+        </p:nvSpPr>
+        <p:spPr>
+          <a:xfrm>
+            <a:off x="453881" y="872419"/>
+            <a:ext cx="11885653" cy="838800"/>
+          </a:xfrm>
+        </p:spPr>
+        <p:txBody>
+          <a:bodyPr anchor="ctr">
+            <a:normAutofit/>
+          </a:bodyPr>
+          <a:lstStyle/>
+          <a:p>
+            <a:r>
+              <a:rPr lang="en-IN" dirty="0"/>
+              <a:t>Use case</a:t>
+            </a:r>
+          </a:p>
+        </p:txBody>
+      </p:sp>
+      <p:sp>
+        <p:nvSpPr>
+          <p:cNvPr id="3" name="Content Placeholder 2">
+            <a:extLst>
+              <a:ext uri="{FF2B5EF4-FFF2-40B4-BE49-F238E27FC236}">
+                <a16:creationId xmlns:a16="http://schemas.microsoft.com/office/drawing/2014/main" id="{F4B9A672-AE9D-8150-1140-A40CC7B03021}"/>
+              </a:ext>
+            </a:extLst>
+          </p:cNvPr>
+          <p:cNvSpPr>
+            <a:spLocks noGrp="1"/>
+          </p:cNvSpPr>
+          <p:nvPr>
+            <p:ph sz="quarter" idx="10"/>
+          </p:nvPr>
+        </p:nvSpPr>
+        <p:spPr>
+          <a:xfrm>
+            <a:off x="382613" y="1711219"/>
+            <a:ext cx="11426771" cy="4813793"/>
+          </a:xfrm>
+        </p:spPr>
+        <p:txBody>
+          <a:bodyPr>
+            <a:normAutofit/>
+          </a:bodyPr>
+          <a:lstStyle/>
+          <a:p>
+            <a:pPr marL="457200" lvl="1" indent="0">
+              <a:buNone/>
+            </a:pPr>
+            <a:r>
+              <a:rPr lang="en-US" sz="1100" dirty="0"/>
+              <a:t> </a:t>
+            </a:r>
+          </a:p>
+          <a:p>
+            <a:pPr marL="800100" lvl="1" indent="-342900"/>
+            <a:endParaRPr lang="en-US" sz="1100" i="1" dirty="0"/>
+          </a:p>
+          <a:p>
+            <a:pPr>
+              <a:buFont typeface="Arial" panose="020B0604020202020204" pitchFamily="34" charset="0"/>
+              <a:buChar char="•"/>
+            </a:pPr>
+            <a:r>
+              <a:rPr lang="en-US" sz="2000" dirty="0"/>
+              <a:t>Automate the conversion of vendor optical transceiver datasheets into validated, machine-readable specifications for:</a:t>
+            </a:r>
+          </a:p>
+          <a:p>
+            <a:pPr>
+              <a:buFont typeface="Arial" panose="020B0604020202020204" pitchFamily="34" charset="0"/>
+              <a:buChar char="•"/>
+            </a:pPr>
+            <a:r>
+              <a:rPr lang="en-US" sz="2000" dirty="0"/>
+              <a:t>Faster transceiver comparison and selection </a:t>
+            </a:r>
+          </a:p>
+          <a:p>
+            <a:pPr>
+              <a:buFont typeface="Arial" panose="020B0604020202020204" pitchFamily="34" charset="0"/>
+              <a:buChar char="•"/>
+            </a:pPr>
+            <a:r>
+              <a:rPr lang="en-US" sz="2000" dirty="0"/>
+              <a:t>Network planning and link feasibility assessment </a:t>
+            </a:r>
+          </a:p>
+          <a:p>
+            <a:pPr>
+              <a:buFont typeface="Arial" panose="020B0604020202020204" pitchFamily="34" charset="0"/>
+              <a:buChar char="•"/>
+            </a:pPr>
+            <a:r>
+              <a:rPr lang="en-US" sz="2000" dirty="0"/>
+              <a:t>Automated standards and interoperability checks </a:t>
+            </a:r>
+          </a:p>
+          <a:p>
+            <a:pPr>
+              <a:buFont typeface="Arial" panose="020B0604020202020204" pitchFamily="34" charset="0"/>
+              <a:buChar char="•"/>
+            </a:pPr>
+            <a:r>
+              <a:rPr lang="en-US" sz="2000" dirty="0"/>
+              <a:t>Capability-based equipment inventory </a:t>
+            </a:r>
+          </a:p>
+          <a:p>
+            <a:pPr>
+              <a:buFont typeface="Arial" panose="020B0604020202020204" pitchFamily="34" charset="0"/>
+              <a:buChar char="•"/>
+            </a:pPr>
+            <a:r>
+              <a:rPr lang="en-US" sz="2000" dirty="0"/>
+              <a:t>Reduced manual effort and parameter-entry errors</a:t>
+            </a:r>
+          </a:p>
+          <a:p>
+            <a:pPr>
+              <a:buFont typeface="Arial" panose="020B0604020202020204" pitchFamily="34" charset="0"/>
+              <a:buChar char="•"/>
+            </a:pPr>
+            <a:endParaRPr lang="en-GB" sz="2000" dirty="0"/>
+          </a:p>
+          <a:p>
+            <a:pPr>
+              <a:buFont typeface="Arial" panose="020B0604020202020204" pitchFamily="34" charset="0"/>
+              <a:buChar char="•"/>
+            </a:pPr>
+            <a:endParaRPr lang="en-US" sz="1100" i="1" dirty="0"/>
+          </a:p>
+          <a:p>
+            <a:endParaRPr lang="en-US" sz="1100" dirty="0"/>
+          </a:p>
+          <a:p>
+            <a:endParaRPr lang="en-US" sz="1100" dirty="0"/>
+          </a:p>
+          <a:p>
+            <a:endParaRPr lang="en-IN" sz="1100" dirty="0"/>
+          </a:p>
+        </p:txBody>
+      </p:sp>
+      <p:sp>
+        <p:nvSpPr>
+          <p:cNvPr id="7" name="TextBox 6">
+            <a:extLst>
+              <a:ext uri="{FF2B5EF4-FFF2-40B4-BE49-F238E27FC236}">
+                <a16:creationId xmlns:a16="http://schemas.microsoft.com/office/drawing/2014/main" id="{EE5688AD-0BD2-A2E9-AF09-320716AD2F6B}"/>
+              </a:ext>
+            </a:extLst>
+          </p:cNvPr>
+          <p:cNvSpPr txBox="1"/>
+          <p:nvPr/>
+        </p:nvSpPr>
+        <p:spPr>
+          <a:xfrm>
+            <a:off x="8976320" y="2852936"/>
+            <a:ext cx="473206" cy="369332"/>
+          </a:xfrm>
+          <a:prstGeom prst="rect">
+            <a:avLst/>
+          </a:prstGeom>
+          <a:noFill/>
+        </p:spPr>
+        <p:txBody>
+          <a:bodyPr wrap="none" rtlCol="0">
+            <a:spAutoFit/>
+          </a:bodyPr>
+          <a:lstStyle/>
+          <a:p>
+            <a:pPr marL="285750" indent="-285750">
+              <a:buFont typeface="Wingdings" panose="05000000000000000000" pitchFamily="2" charset="2"/>
+              <a:buChar char="§"/>
+            </a:pPr>
+            <a:endParaRPr lang="en-US" err="1">
+              <a:solidFill>
+                <a:schemeClr val="accent2"/>
+              </a:solidFill>
+              <a:latin typeface="Montserrat" pitchFamily="2" charset="0"/>
+            </a:endParaRPr>
+          </a:p>
+        </p:txBody>
+      </p:sp>
+    </p:spTree>
+    <p:extLst>
+      <p:ext uri="{BB962C8B-B14F-4D97-AF65-F5344CB8AC3E}">
+        <p14:creationId xmlns:p14="http://schemas.microsoft.com/office/powerpoint/2010/main" val="161753541"/>
+      </p:ext>
+    </p:extLst>
+  </p:cSld>
+  <p:clrMapOvr>
+    <a:masterClrMapping/>
+  </p:clrMapOvr>
+</p:sld>
+</file>
+
+<file path=ppt/slides/slide24.xml><?xml version="1.0" encoding="utf-8"?>
+<p:sld xmlns:a="http://schemas.openxmlformats.org/drawingml/2006/main" xmlns:r="http://schemas.openxmlformats.org/officeDocument/2006/relationships" xmlns:p="http://schemas.openxmlformats.org/presentationml/2006/main">
+  <p:cSld>
+    <p:spTree>
+      <p:nvGrpSpPr>
+        <p:cNvPr id="1" name="">
+          <a:extLst>
+            <a:ext uri="{FF2B5EF4-FFF2-40B4-BE49-F238E27FC236}">
+              <a16:creationId xmlns:a16="http://schemas.microsoft.com/office/drawing/2014/main" id="{9F6C328C-D34D-40E6-7DD2-0DD1B87259F2}"/>
+            </a:ext>
+          </a:extLst>
+        </p:cNvPr>
+        <p:cNvGrpSpPr/>
+        <p:nvPr/>
+      </p:nvGrpSpPr>
+      <p:grpSpPr>
+        <a:xfrm>
+          <a:off x="0" y="0"/>
+          <a:ext cx="0" cy="0"/>
+          <a:chOff x="0" y="0"/>
+          <a:chExt cx="0" cy="0"/>
+        </a:xfrm>
+      </p:grpSpPr>
+      <p:sp>
+        <p:nvSpPr>
+          <p:cNvPr id="2" name="Title 1">
+            <a:extLst>
+              <a:ext uri="{FF2B5EF4-FFF2-40B4-BE49-F238E27FC236}">
+                <a16:creationId xmlns:a16="http://schemas.microsoft.com/office/drawing/2014/main" id="{A02DA05B-B309-A341-4923-55C5BE999330}"/>
+              </a:ext>
+            </a:extLst>
+          </p:cNvPr>
+          <p:cNvSpPr>
+            <a:spLocks noGrp="1"/>
+          </p:cNvSpPr>
+          <p:nvPr>
+            <p:ph type="title"/>
+          </p:nvPr>
+        </p:nvSpPr>
+        <p:spPr>
+          <a:xfrm>
+            <a:off x="453881" y="872419"/>
+            <a:ext cx="11885653" cy="838800"/>
+          </a:xfrm>
+        </p:spPr>
+        <p:txBody>
+          <a:bodyPr anchor="ctr">
+            <a:normAutofit/>
+          </a:bodyPr>
+          <a:lstStyle/>
+          <a:p>
+            <a:r>
+              <a:rPr lang="en-IN" dirty="0"/>
+              <a:t>proposed idea</a:t>
+            </a:r>
+          </a:p>
+        </p:txBody>
+      </p:sp>
+      <p:sp>
+        <p:nvSpPr>
+          <p:cNvPr id="3" name="Content Placeholder 2">
+            <a:extLst>
+              <a:ext uri="{FF2B5EF4-FFF2-40B4-BE49-F238E27FC236}">
+                <a16:creationId xmlns:a16="http://schemas.microsoft.com/office/drawing/2014/main" id="{26672A75-34EE-65D0-6F59-A74DF78A4958}"/>
+              </a:ext>
+            </a:extLst>
+          </p:cNvPr>
+          <p:cNvSpPr>
+            <a:spLocks noGrp="1"/>
+          </p:cNvSpPr>
+          <p:nvPr>
+            <p:ph sz="quarter" idx="10"/>
+          </p:nvPr>
+        </p:nvSpPr>
+        <p:spPr>
+          <a:xfrm>
+            <a:off x="382613" y="1711219"/>
+            <a:ext cx="11426771" cy="4813793"/>
+          </a:xfrm>
+        </p:spPr>
+        <p:txBody>
+          <a:bodyPr>
+            <a:normAutofit/>
+          </a:bodyPr>
+          <a:lstStyle/>
+          <a:p>
+            <a:pPr marL="457200" lvl="1" indent="0">
+              <a:buNone/>
+            </a:pPr>
+            <a:r>
+              <a:rPr lang="en-US" sz="1100" dirty="0"/>
+              <a:t> </a:t>
+            </a:r>
+          </a:p>
+          <a:p>
+            <a:pPr marL="800100" lvl="1" indent="-342900"/>
+            <a:endParaRPr lang="en-US" sz="1100" i="1" dirty="0"/>
+          </a:p>
+          <a:p>
+            <a:pPr>
+              <a:buFont typeface="Arial" panose="020B0604020202020204" pitchFamily="34" charset="0"/>
+              <a:buChar char="•"/>
+            </a:pPr>
+            <a:r>
+              <a:rPr lang="en-US" sz="2000" dirty="0"/>
+              <a:t>Develop a fine-tuned small language model (SLLM) that learns to extract optical transceiver parameters from datasheets accurately and return schema-valid JSON</a:t>
+            </a:r>
+          </a:p>
+          <a:p>
+            <a:pPr>
+              <a:buFont typeface="Arial" panose="020B0604020202020204" pitchFamily="34" charset="0"/>
+              <a:buChar char="•"/>
+            </a:pPr>
+            <a:r>
+              <a:rPr lang="en-US" sz="2000" dirty="0"/>
+              <a:t>Fine-tune a compact Qwen 4B model using human verified datasheet and JSON pairs</a:t>
+            </a:r>
+          </a:p>
+          <a:p>
+            <a:pPr>
+              <a:buFont typeface="Arial" panose="020B0604020202020204" pitchFamily="34" charset="0"/>
+              <a:buChar char="•"/>
+            </a:pPr>
+            <a:r>
+              <a:rPr lang="en-US" sz="2000" dirty="0"/>
+              <a:t>Train it on separate tasks for parameter extraction, mode discovery and scope resolution </a:t>
+            </a:r>
+          </a:p>
+          <a:p>
+            <a:pPr>
+              <a:buFont typeface="Arial" panose="020B0604020202020204" pitchFamily="34" charset="0"/>
+              <a:buChar char="•"/>
+            </a:pPr>
+            <a:r>
+              <a:rPr lang="en-US" sz="2000" dirty="0"/>
+              <a:t>Use constrained JSON generation and </a:t>
+            </a:r>
+            <a:r>
+              <a:rPr lang="en-US" sz="2000" dirty="0" err="1"/>
+              <a:t>Pydantic</a:t>
+            </a:r>
+            <a:r>
+              <a:rPr lang="en-US" sz="2000" dirty="0"/>
+              <a:t> validation to ensure valid outputs </a:t>
+            </a:r>
+          </a:p>
+          <a:p>
+            <a:pPr>
+              <a:buFont typeface="Arial" panose="020B0604020202020204" pitchFamily="34" charset="0"/>
+              <a:buChar char="•"/>
+            </a:pPr>
+            <a:r>
+              <a:rPr lang="en-US" sz="2000" dirty="0"/>
+              <a:t>Compare the original 4B model with the fine-tuned version for accuracy, hallucination rate and latency </a:t>
+            </a:r>
+          </a:p>
+          <a:p>
+            <a:pPr marL="0" indent="0"/>
+            <a:endParaRPr lang="en-GB" sz="2000" dirty="0"/>
+          </a:p>
+          <a:p>
+            <a:pPr>
+              <a:buFont typeface="Arial" panose="020B0604020202020204" pitchFamily="34" charset="0"/>
+              <a:buChar char="•"/>
+            </a:pPr>
+            <a:endParaRPr lang="en-US" sz="1100" i="1" dirty="0"/>
+          </a:p>
+          <a:p>
+            <a:endParaRPr lang="en-US" sz="1100" dirty="0"/>
+          </a:p>
+          <a:p>
+            <a:endParaRPr lang="en-US" sz="1100" dirty="0"/>
+          </a:p>
+          <a:p>
+            <a:endParaRPr lang="en-IN" sz="1100" dirty="0"/>
+          </a:p>
+        </p:txBody>
+      </p:sp>
+      <p:sp>
+        <p:nvSpPr>
+          <p:cNvPr id="7" name="TextBox 6">
+            <a:extLst>
+              <a:ext uri="{FF2B5EF4-FFF2-40B4-BE49-F238E27FC236}">
+                <a16:creationId xmlns:a16="http://schemas.microsoft.com/office/drawing/2014/main" id="{70B5182B-2FCD-55DA-7B55-E183751B1572}"/>
+              </a:ext>
+            </a:extLst>
+          </p:cNvPr>
+          <p:cNvSpPr txBox="1"/>
+          <p:nvPr/>
+        </p:nvSpPr>
+        <p:spPr>
+          <a:xfrm>
+            <a:off x="8976320" y="2852936"/>
+            <a:ext cx="473206" cy="369332"/>
+          </a:xfrm>
+          <a:prstGeom prst="rect">
+            <a:avLst/>
+          </a:prstGeom>
+          <a:noFill/>
+        </p:spPr>
+        <p:txBody>
+          <a:bodyPr wrap="none" rtlCol="0">
+            <a:spAutoFit/>
+          </a:bodyPr>
+          <a:lstStyle/>
+          <a:p>
+            <a:pPr marL="285750" indent="-285750">
+              <a:buFont typeface="Wingdings" panose="05000000000000000000" pitchFamily="2" charset="2"/>
+              <a:buChar char="§"/>
+            </a:pPr>
+            <a:endParaRPr lang="en-US" err="1">
+              <a:solidFill>
+                <a:schemeClr val="accent2"/>
+              </a:solidFill>
+              <a:latin typeface="Montserrat" pitchFamily="2" charset="0"/>
+            </a:endParaRPr>
+          </a:p>
+        </p:txBody>
+      </p:sp>
+    </p:spTree>
+    <p:extLst>
+      <p:ext uri="{BB962C8B-B14F-4D97-AF65-F5344CB8AC3E}">
+        <p14:creationId xmlns:p14="http://schemas.microsoft.com/office/powerpoint/2010/main" val="3265252280"/>
+      </p:ext>
+    </p:extLst>
+  </p:cSld>
+  <p:clrMapOvr>
+    <a:masterClrMapping/>
+  </p:clrMapOvr>
+</p:sld>
+</file>
+
+<file path=ppt/slides/slide25.xml><?xml version="1.0" encoding="utf-8"?>
+<p:sld xmlns:a="http://schemas.openxmlformats.org/drawingml/2006/main" xmlns:r="http://schemas.openxmlformats.org/officeDocument/2006/relationships" xmlns:p="http://schemas.openxmlformats.org/presentationml/2006/main">
+  <p:cSld>
+    <p:spTree>
+      <p:nvGrpSpPr>
+        <p:cNvPr id="1" name="">
+          <a:extLst>
+            <a:ext uri="{FF2B5EF4-FFF2-40B4-BE49-F238E27FC236}">
+              <a16:creationId xmlns:a16="http://schemas.microsoft.com/office/drawing/2014/main" id="{6E766C84-AB3D-4D55-AB43-4FA53237CF98}"/>
+            </a:ext>
+          </a:extLst>
+        </p:cNvPr>
+        <p:cNvGrpSpPr/>
+        <p:nvPr/>
+      </p:nvGrpSpPr>
+      <p:grpSpPr>
+        <a:xfrm>
+          <a:off x="0" y="0"/>
+          <a:ext cx="0" cy="0"/>
+          <a:chOff x="0" y="0"/>
+          <a:chExt cx="0" cy="0"/>
+        </a:xfrm>
+      </p:grpSpPr>
+      <p:sp>
+        <p:nvSpPr>
+          <p:cNvPr id="2" name="Title 1">
+            <a:extLst>
+              <a:ext uri="{FF2B5EF4-FFF2-40B4-BE49-F238E27FC236}">
+                <a16:creationId xmlns:a16="http://schemas.microsoft.com/office/drawing/2014/main" id="{E7499681-4C18-F8F9-E1B2-BE43056D1B9F}"/>
+              </a:ext>
+            </a:extLst>
+          </p:cNvPr>
+          <p:cNvSpPr>
+            <a:spLocks noGrp="1"/>
+          </p:cNvSpPr>
+          <p:nvPr>
+            <p:ph type="title"/>
+          </p:nvPr>
+        </p:nvSpPr>
+        <p:spPr>
+          <a:xfrm>
+            <a:off x="453881" y="872419"/>
+            <a:ext cx="11885653" cy="838800"/>
+          </a:xfrm>
+        </p:spPr>
+        <p:txBody>
+          <a:bodyPr anchor="ctr">
+            <a:normAutofit/>
+          </a:bodyPr>
+          <a:lstStyle/>
+          <a:p>
+            <a:r>
+              <a:rPr lang="en-IN" dirty="0"/>
+              <a:t>Potential use case</a:t>
+            </a:r>
+          </a:p>
+        </p:txBody>
+      </p:sp>
+      <p:sp>
+        <p:nvSpPr>
+          <p:cNvPr id="3" name="Content Placeholder 2">
+            <a:extLst>
+              <a:ext uri="{FF2B5EF4-FFF2-40B4-BE49-F238E27FC236}">
+                <a16:creationId xmlns:a16="http://schemas.microsoft.com/office/drawing/2014/main" id="{42FC0D13-CE0F-88F7-BFA0-F4A44D81DD5E}"/>
+              </a:ext>
+            </a:extLst>
+          </p:cNvPr>
+          <p:cNvSpPr>
+            <a:spLocks noGrp="1"/>
+          </p:cNvSpPr>
+          <p:nvPr>
+            <p:ph sz="quarter" idx="10"/>
+          </p:nvPr>
+        </p:nvSpPr>
+        <p:spPr>
+          <a:xfrm>
+            <a:off x="-409049" y="1570070"/>
+            <a:ext cx="12204195" cy="4813793"/>
+          </a:xfrm>
+        </p:spPr>
+        <p:txBody>
+          <a:bodyPr>
+            <a:normAutofit/>
+          </a:bodyPr>
+          <a:lstStyle/>
+          <a:p>
+            <a:pPr marL="457200" lvl="1" indent="0">
+              <a:buNone/>
+            </a:pPr>
+            <a:r>
+              <a:rPr lang="en-US" sz="1100" dirty="0"/>
+              <a:t> </a:t>
+            </a:r>
+          </a:p>
+          <a:p>
+            <a:pPr marL="800100" lvl="1" indent="-342900"/>
+            <a:r>
+              <a:rPr lang="en-US" sz="1400" b="1" dirty="0"/>
+              <a:t>Capability ingestion: </a:t>
+            </a:r>
+            <a:r>
+              <a:rPr lang="en-US" sz="1400" dirty="0"/>
+              <a:t>Populate the digital twin with supported rates, modulation formats, FEC, power limits and reach</a:t>
+            </a:r>
+          </a:p>
+          <a:p>
+            <a:pPr marL="800100" lvl="1" indent="-342900"/>
+            <a:r>
+              <a:rPr lang="en-US" sz="1400" b="1" dirty="0"/>
+              <a:t>Device compatibility: </a:t>
+            </a:r>
+            <a:r>
+              <a:rPr lang="en-US" sz="1400" dirty="0"/>
+              <a:t>Check whether a transceiver supports a requested link or operational configuration </a:t>
+            </a:r>
+          </a:p>
+          <a:p>
+            <a:pPr marL="800100" lvl="1" indent="-342900"/>
+            <a:r>
+              <a:rPr lang="en-US" sz="1400" b="1" dirty="0"/>
+              <a:t>Configuration support: </a:t>
+            </a:r>
+            <a:r>
+              <a:rPr lang="en-US" sz="1400" dirty="0"/>
+              <a:t>Identify valid operating modes and prevent unsupported parameter combinations</a:t>
+            </a:r>
+          </a:p>
+          <a:p>
+            <a:pPr marL="800100" lvl="1" indent="-342900"/>
+            <a:r>
+              <a:rPr lang="en-US" sz="1400" b="1" dirty="0"/>
+              <a:t>Planning input: </a:t>
+            </a:r>
+            <a:r>
+              <a:rPr lang="en-US" sz="1400" dirty="0"/>
+              <a:t>Supply structured equipment constraints to link-budget, spectrum-allocation and path-planning tools</a:t>
+            </a:r>
+          </a:p>
+          <a:p>
+            <a:pPr marL="457200" lvl="1" indent="0">
+              <a:buNone/>
+            </a:pPr>
+            <a:endParaRPr lang="en-US" sz="1400" i="1" dirty="0"/>
+          </a:p>
+          <a:p>
+            <a:pPr marL="0" indent="0"/>
+            <a:endParaRPr lang="en-GB" sz="2000" dirty="0"/>
+          </a:p>
+          <a:p>
+            <a:pPr>
+              <a:buFont typeface="Arial" panose="020B0604020202020204" pitchFamily="34" charset="0"/>
+              <a:buChar char="•"/>
+            </a:pPr>
+            <a:endParaRPr lang="en-US" sz="1100" i="1" dirty="0"/>
+          </a:p>
+          <a:p>
+            <a:endParaRPr lang="en-US" sz="1100" dirty="0"/>
+          </a:p>
+          <a:p>
+            <a:endParaRPr lang="en-US" sz="1100" dirty="0"/>
+          </a:p>
+          <a:p>
+            <a:endParaRPr lang="en-IN" sz="1100" dirty="0"/>
+          </a:p>
+        </p:txBody>
+      </p:sp>
+      <p:sp>
+        <p:nvSpPr>
+          <p:cNvPr id="7" name="TextBox 6">
+            <a:extLst>
+              <a:ext uri="{FF2B5EF4-FFF2-40B4-BE49-F238E27FC236}">
+                <a16:creationId xmlns:a16="http://schemas.microsoft.com/office/drawing/2014/main" id="{4C336E68-F0AC-25B3-3BE2-A313643C222E}"/>
+              </a:ext>
+            </a:extLst>
+          </p:cNvPr>
+          <p:cNvSpPr txBox="1"/>
+          <p:nvPr/>
+        </p:nvSpPr>
+        <p:spPr>
+          <a:xfrm>
+            <a:off x="8773802" y="2779293"/>
+            <a:ext cx="473206" cy="369332"/>
+          </a:xfrm>
+          <a:prstGeom prst="rect">
+            <a:avLst/>
+          </a:prstGeom>
+          <a:noFill/>
+        </p:spPr>
+        <p:txBody>
+          <a:bodyPr wrap="none" rtlCol="0">
+            <a:spAutoFit/>
+          </a:bodyPr>
+          <a:lstStyle/>
+          <a:p>
+            <a:pPr marL="285750" indent="-285750">
+              <a:buFont typeface="Wingdings" panose="05000000000000000000" pitchFamily="2" charset="2"/>
+              <a:buChar char="§"/>
+            </a:pPr>
+            <a:endParaRPr lang="en-US" err="1">
+              <a:solidFill>
+                <a:schemeClr val="accent2"/>
+              </a:solidFill>
+              <a:latin typeface="Montserrat" pitchFamily="2" charset="0"/>
+            </a:endParaRPr>
+          </a:p>
+        </p:txBody>
+      </p:sp>
+    </p:spTree>
+    <p:extLst>
+      <p:ext uri="{BB962C8B-B14F-4D97-AF65-F5344CB8AC3E}">
+        <p14:creationId xmlns:p14="http://schemas.microsoft.com/office/powerpoint/2010/main" val="1141079304"/>
       </p:ext>
     </p:extLst>
   </p:cSld>

</xml_diff>